<commit_message>
fix(research-slides): place slide text with explicit boxes, not placeholders
pptxgenjs writes placeholder-based text without <p:ph>, so LibreOffice and
Google Slides drop the title, topic, footnote and cover text at the top-left
corner with default styling. deck.js now gives every text box its own
geometry and font (BOX table) and keeps the masters to static objects.
Template rebuilt and verified with check-deck.py --render.

Co-Authored-By: Claude Fable 5.1 <noreply@anthropic.com>
</commit_message>
<xml_diff>
--- a/agents/.agents/skills/research-slides/assets/research-slides-template.pptx
+++ b/agents/.agents/skills/research-slides/assets/research-slides-template.pptx
@@ -121,10 +121,10 @@
   <p:extLst>
     <p:ext uri="{521415D9-36F7-43E2-AB2F-B90AF26B5E84}">
       <p14:sectionLst xmlns:p14="http://schemas.microsoft.com/office/powerpoint/2010/main">
-        <p14:section name="Templates" id="{f69eb5fe-3a82-a670-4bb5-c62c857addf5}">
+        <p14:section name="Templates" id="{e547fee6-67e7-8e17-fddc-e417c2337ab3}">
           <p14:sldIdLst/>
         </p14:section>
-        <p14:section name="Default-1" id="{1f7dc431-2f6d-9986-9542-b5809e0144ad}">
+        <p14:section name="Default-1" id="{0e0066a8-0bd3-490c-7603-a8bb4e3f8250}">
           <p14:sldIdLst>
             <p14:sldId id="256"/>
             <p14:sldId id="257"/>
@@ -1904,90 +1904,6 @@
           <a:ln/>
         </p:spPr>
       </p:sp>
-      <p:sp>
-        <p:nvSpPr>
-          <p:cNvPr id="3" name="Text 1"/>
-          <p:cNvSpPr/>
-          <p:nvPr>
-            <p:ph idx="101" hasCustomPrompt="1"/>
-          </p:nvPr>
-        </p:nvSpPr>
-        <p:spPr>
-          <a:xfrm>
-            <a:off x="310896" y="1682496"/>
-            <a:ext cx="8522208" cy="1773936"/>
-          </a:xfrm>
-          <a:prstGeom prst="rect">
-            <a:avLst/>
-          </a:prstGeom>
-          <a:noFill/>
-          <a:ln/>
-        </p:spPr>
-        <p:txBody>
-          <a:bodyPr wrap="square" rtlCol="0"/>
-          <a:lstStyle>
-            <a:lvl1pPr algn="l" indent="0" marL="0">
-              <a:buNone/>
-              <a:defRPr lang="en-US" sz="2600" b="1" dirty="0">
-                <a:solidFill>
-                  <a:schemeClr val="tx1"/>
-                </a:solidFill>
-                <a:latin typeface="Arial" pitchFamily="34" charset="0"/>
-                <a:ea typeface="Arial" pitchFamily="34" charset="-122"/>
-                <a:cs typeface="Arial" pitchFamily="34" charset="-120"/>
-              </a:defRPr>
-            </a:lvl1pPr>
-          </a:lstStyle>
-          <a:p>
-            <a:pPr algn="l" indent="0" marL="0">
-              <a:buNone/>
-            </a:pPr>
-            <a:endParaRPr lang="en-US" sz="2600" dirty="0"/>
-          </a:p>
-        </p:txBody>
-      </p:sp>
-      <p:sp>
-        <p:nvSpPr>
-          <p:cNvPr id="4" name="Text 1"/>
-          <p:cNvSpPr/>
-          <p:nvPr>
-            <p:ph idx="102" type="body" hasCustomPrompt="1"/>
-          </p:nvPr>
-        </p:nvSpPr>
-        <p:spPr>
-          <a:xfrm>
-            <a:off x="329184" y="3968496"/>
-            <a:ext cx="8522208" cy="914400"/>
-          </a:xfrm>
-          <a:prstGeom prst="rect">
-            <a:avLst/>
-          </a:prstGeom>
-          <a:noFill/>
-          <a:ln/>
-        </p:spPr>
-        <p:txBody>
-          <a:bodyPr wrap="square" rtlCol="0"/>
-          <a:lstStyle>
-            <a:lvl1pPr algn="l" indent="0" marL="0">
-              <a:buNone/>
-              <a:defRPr lang="en-US" sz="1400" b="1" dirty="0">
-                <a:solidFill>
-                  <a:schemeClr val="tx2"/>
-                </a:solidFill>
-                <a:latin typeface="Times New Roman" pitchFamily="34" charset="0"/>
-                <a:ea typeface="Times New Roman" pitchFamily="34" charset="-122"/>
-                <a:cs typeface="Times New Roman" pitchFamily="34" charset="-120"/>
-              </a:defRPr>
-            </a:lvl1pPr>
-          </a:lstStyle>
-          <a:p>
-            <a:pPr algn="l" indent="0" marL="0">
-              <a:buNone/>
-            </a:pPr>
-            <a:endParaRPr lang="en-US" sz="1400" dirty="0"/>
-          </a:p>
-        </p:txBody>
-      </p:sp>
     </p:spTree>
   </p:cSld>
   <p:clrMapOvr>
@@ -2051,90 +1967,6 @@
       </p:sp>
       <p:sp>
         <p:nvSpPr>
-          <p:cNvPr id="3" name="Text 1"/>
-          <p:cNvSpPr/>
-          <p:nvPr>
-            <p:ph idx="101" hasCustomPrompt="1"/>
-          </p:nvPr>
-        </p:nvSpPr>
-        <p:spPr>
-          <a:xfrm>
-            <a:off x="310896" y="1682496"/>
-            <a:ext cx="8522208" cy="1773936"/>
-          </a:xfrm>
-          <a:prstGeom prst="rect">
-            <a:avLst/>
-          </a:prstGeom>
-          <a:noFill/>
-          <a:ln/>
-        </p:spPr>
-        <p:txBody>
-          <a:bodyPr wrap="square" rtlCol="0"/>
-          <a:lstStyle>
-            <a:lvl1pPr algn="l" indent="0" marL="0">
-              <a:buNone/>
-              <a:defRPr lang="en-US" sz="2600" b="1" dirty="0">
-                <a:solidFill>
-                  <a:schemeClr val="tx1"/>
-                </a:solidFill>
-                <a:latin typeface="Arial" pitchFamily="34" charset="0"/>
-                <a:ea typeface="Arial" pitchFamily="34" charset="-122"/>
-                <a:cs typeface="Arial" pitchFamily="34" charset="-120"/>
-              </a:defRPr>
-            </a:lvl1pPr>
-          </a:lstStyle>
-          <a:p>
-            <a:pPr algn="l" indent="0" marL="0">
-              <a:buNone/>
-            </a:pPr>
-            <a:endParaRPr lang="en-US" sz="2600" dirty="0"/>
-          </a:p>
-        </p:txBody>
-      </p:sp>
-      <p:sp>
-        <p:nvSpPr>
-          <p:cNvPr id="4" name="Text 1"/>
-          <p:cNvSpPr/>
-          <p:nvPr>
-            <p:ph idx="104" hasCustomPrompt="1"/>
-          </p:nvPr>
-        </p:nvSpPr>
-        <p:spPr>
-          <a:xfrm>
-            <a:off x="0" y="4791456"/>
-            <a:ext cx="7863840" cy="356616"/>
-          </a:xfrm>
-          <a:prstGeom prst="rect">
-            <a:avLst/>
-          </a:prstGeom>
-          <a:noFill/>
-          <a:ln/>
-        </p:spPr>
-        <p:txBody>
-          <a:bodyPr wrap="square" rtlCol="0"/>
-          <a:lstStyle>
-            <a:lvl1pPr indent="0" marL="0">
-              <a:buNone/>
-              <a:defRPr lang="en-US" sz="800" dirty="0">
-                <a:solidFill>
-                  <a:schemeClr val="tx1"/>
-                </a:solidFill>
-                <a:latin typeface="Arial" pitchFamily="34" charset="0"/>
-                <a:ea typeface="Arial" pitchFamily="34" charset="-122"/>
-                <a:cs typeface="Arial" pitchFamily="34" charset="-120"/>
-              </a:defRPr>
-            </a:lvl1pPr>
-          </a:lstStyle>
-          <a:p>
-            <a:pPr indent="0" marL="0">
-              <a:buNone/>
-            </a:pPr>
-            <a:endParaRPr lang="en-US" sz="800" dirty="0"/>
-          </a:p>
-        </p:txBody>
-      </p:sp>
-      <p:sp>
-        <p:nvSpPr>
           <p:cNvPr id="25" name="Slide Number Placeholder 0"/>
           <p:cNvSpPr>
             <a:spLocks noGrp="1"/>
@@ -2163,7 +1995,7 @@
             <a:lvl1pPr>
               <a:defRPr sz="1200">
                 <a:solidFill>
-                  <a:schemeClr val="tx1"/>
+                  <a:srgbClr val="000000"/>
                 </a:solidFill>
                 <a:latin typeface="Arial"/>
                 <a:ea typeface="Arial"/>
@@ -2215,48 +2047,6 @@
       </p:grpSpPr>
       <p:sp>
         <p:nvSpPr>
-          <p:cNvPr id="2" name="Text 0"/>
-          <p:cNvSpPr/>
-          <p:nvPr>
-            <p:ph idx="100" type="title" hasCustomPrompt="1"/>
-          </p:nvPr>
-        </p:nvSpPr>
-        <p:spPr>
-          <a:xfrm>
-            <a:off x="301752" y="2350008"/>
-            <a:ext cx="8531352" cy="438912"/>
-          </a:xfrm>
-          <a:prstGeom prst="rect">
-            <a:avLst/>
-          </a:prstGeom>
-          <a:noFill/>
-          <a:ln/>
-        </p:spPr>
-        <p:txBody>
-          <a:bodyPr wrap="square" rtlCol="0"/>
-          <a:lstStyle>
-            <a:lvl1pPr algn="ctr" indent="0" marL="0">
-              <a:buNone/>
-              <a:defRPr lang="en-US" sz="2200" dirty="0">
-                <a:solidFill>
-                  <a:schemeClr val="tx1"/>
-                </a:solidFill>
-                <a:latin typeface="Arial" pitchFamily="34" charset="0"/>
-                <a:ea typeface="Arial" pitchFamily="34" charset="-122"/>
-                <a:cs typeface="Arial" pitchFamily="34" charset="-120"/>
-              </a:defRPr>
-            </a:lvl1pPr>
-          </a:lstStyle>
-          <a:p>
-            <a:pPr algn="ctr" indent="0" marL="0">
-              <a:buNone/>
-            </a:pPr>
-            <a:endParaRPr lang="en-US" sz="2200" dirty="0"/>
-          </a:p>
-        </p:txBody>
-      </p:sp>
-      <p:sp>
-        <p:nvSpPr>
           <p:cNvPr id="25" name="Slide Number Placeholder 0"/>
           <p:cNvSpPr>
             <a:spLocks noGrp="1"/>
@@ -2285,7 +2075,7 @@
             <a:lvl1pPr>
               <a:defRPr sz="1200">
                 <a:solidFill>
-                  <a:schemeClr val="tx1"/>
+                  <a:srgbClr val="000000"/>
                 </a:solidFill>
                 <a:latin typeface="Arial"/>
                 <a:ea typeface="Arial"/>
@@ -2337,91 +2127,7 @@
       </p:grpSpPr>
       <p:sp>
         <p:nvSpPr>
-          <p:cNvPr id="2" name="Text 0"/>
-          <p:cNvSpPr/>
-          <p:nvPr>
-            <p:ph idx="100" hasCustomPrompt="1"/>
-          </p:nvPr>
-        </p:nvSpPr>
-        <p:spPr>
-          <a:xfrm>
-            <a:off x="365760" y="182880"/>
-            <a:ext cx="8412480" cy="411480"/>
-          </a:xfrm>
-          <a:prstGeom prst="rect">
-            <a:avLst/>
-          </a:prstGeom>
-          <a:noFill/>
-          <a:ln/>
-        </p:spPr>
-        <p:txBody>
-          <a:bodyPr wrap="square" rtlCol="0"/>
-          <a:lstStyle>
-            <a:lvl1pPr algn="l" indent="0" marL="0">
-              <a:buNone/>
-              <a:defRPr lang="en-US" sz="2200" dirty="0">
-                <a:solidFill>
-                  <a:schemeClr val="tx1"/>
-                </a:solidFill>
-                <a:latin typeface="Arial" pitchFamily="34" charset="0"/>
-                <a:ea typeface="Arial" pitchFamily="34" charset="-122"/>
-                <a:cs typeface="Arial" pitchFamily="34" charset="-120"/>
-              </a:defRPr>
-            </a:lvl1pPr>
-          </a:lstStyle>
-          <a:p>
-            <a:pPr algn="l" indent="0" marL="0">
-              <a:buNone/>
-            </a:pPr>
-            <a:endParaRPr lang="en-US" sz="2200" dirty="0"/>
-          </a:p>
-        </p:txBody>
-      </p:sp>
-      <p:sp>
-        <p:nvSpPr>
-          <p:cNvPr id="3" name="Text 0"/>
-          <p:cNvSpPr/>
-          <p:nvPr>
-            <p:ph idx="101" hasCustomPrompt="1"/>
-          </p:nvPr>
-        </p:nvSpPr>
-        <p:spPr>
-          <a:xfrm>
-            <a:off x="365760" y="576072"/>
-            <a:ext cx="8412480" cy="274320"/>
-          </a:xfrm>
-          <a:prstGeom prst="rect">
-            <a:avLst/>
-          </a:prstGeom>
-          <a:noFill/>
-          <a:ln/>
-        </p:spPr>
-        <p:txBody>
-          <a:bodyPr wrap="square" rtlCol="0"/>
-          <a:lstStyle>
-            <a:lvl1pPr algn="l" indent="0" marL="0">
-              <a:buNone/>
-              <a:defRPr lang="en-US" sz="1250" dirty="0">
-                <a:solidFill>
-                  <a:schemeClr val="accent1"/>
-                </a:solidFill>
-                <a:latin typeface="Arial" pitchFamily="34" charset="0"/>
-                <a:ea typeface="Arial" pitchFamily="34" charset="-122"/>
-                <a:cs typeface="Arial" pitchFamily="34" charset="-120"/>
-              </a:defRPr>
-            </a:lvl1pPr>
-          </a:lstStyle>
-          <a:p>
-            <a:pPr algn="l" indent="0" marL="0">
-              <a:buNone/>
-            </a:pPr>
-            <a:endParaRPr lang="en-US" sz="1250" dirty="0"/>
-          </a:p>
-        </p:txBody>
-      </p:sp>
-      <p:sp>
-        <p:nvSpPr>
-          <p:cNvPr id="4" name="Shape 0"/>
+          <p:cNvPr id="2" name="Shape 0"/>
           <p:cNvSpPr/>
           <p:nvPr/>
         </p:nvSpPr>
@@ -2436,53 +2142,11 @@
           <a:noFill/>
           <a:ln w="12700">
             <a:solidFill>
-              <a:schemeClr val="tx1"/>
+              <a:srgbClr val="000000"/>
             </a:solidFill>
             <a:prstDash val="solid"/>
           </a:ln>
         </p:spPr>
-      </p:sp>
-      <p:sp>
-        <p:nvSpPr>
-          <p:cNvPr id="5" name="Text 1"/>
-          <p:cNvSpPr/>
-          <p:nvPr>
-            <p:ph idx="104" hasCustomPrompt="1"/>
-          </p:nvPr>
-        </p:nvSpPr>
-        <p:spPr>
-          <a:xfrm>
-            <a:off x="0" y="4791456"/>
-            <a:ext cx="7863840" cy="356616"/>
-          </a:xfrm>
-          <a:prstGeom prst="rect">
-            <a:avLst/>
-          </a:prstGeom>
-          <a:noFill/>
-          <a:ln/>
-        </p:spPr>
-        <p:txBody>
-          <a:bodyPr wrap="square" rtlCol="0"/>
-          <a:lstStyle>
-            <a:lvl1pPr indent="0" marL="0">
-              <a:buNone/>
-              <a:defRPr lang="en-US" sz="800" dirty="0">
-                <a:solidFill>
-                  <a:schemeClr val="tx1"/>
-                </a:solidFill>
-                <a:latin typeface="Arial" pitchFamily="34" charset="0"/>
-                <a:ea typeface="Arial" pitchFamily="34" charset="-122"/>
-                <a:cs typeface="Arial" pitchFamily="34" charset="-120"/>
-              </a:defRPr>
-            </a:lvl1pPr>
-          </a:lstStyle>
-          <a:p>
-            <a:pPr indent="0" marL="0">
-              <a:buNone/>
-            </a:pPr>
-            <a:endParaRPr lang="en-US" sz="800" dirty="0"/>
-          </a:p>
-        </p:txBody>
       </p:sp>
       <p:sp>
         <p:nvSpPr>
@@ -2514,7 +2178,7 @@
             <a:lvl1pPr>
               <a:defRPr sz="1200">
                 <a:solidFill>
-                  <a:schemeClr val="tx1"/>
+                  <a:srgbClr val="000000"/>
                 </a:solidFill>
                 <a:latin typeface="Arial"/>
                 <a:ea typeface="Arial"/>
@@ -2566,91 +2230,7 @@
       </p:grpSpPr>
       <p:sp>
         <p:nvSpPr>
-          <p:cNvPr id="2" name="Text 0"/>
-          <p:cNvSpPr/>
-          <p:nvPr>
-            <p:ph idx="100" hasCustomPrompt="1"/>
-          </p:nvPr>
-        </p:nvSpPr>
-        <p:spPr>
-          <a:xfrm>
-            <a:off x="365760" y="182880"/>
-            <a:ext cx="8412480" cy="411480"/>
-          </a:xfrm>
-          <a:prstGeom prst="rect">
-            <a:avLst/>
-          </a:prstGeom>
-          <a:noFill/>
-          <a:ln/>
-        </p:spPr>
-        <p:txBody>
-          <a:bodyPr wrap="square" rtlCol="0"/>
-          <a:lstStyle>
-            <a:lvl1pPr algn="l" indent="0" marL="0">
-              <a:buNone/>
-              <a:defRPr lang="en-US" sz="2200" dirty="0">
-                <a:solidFill>
-                  <a:schemeClr val="tx1"/>
-                </a:solidFill>
-                <a:latin typeface="Arial" pitchFamily="34" charset="0"/>
-                <a:ea typeface="Arial" pitchFamily="34" charset="-122"/>
-                <a:cs typeface="Arial" pitchFamily="34" charset="-120"/>
-              </a:defRPr>
-            </a:lvl1pPr>
-          </a:lstStyle>
-          <a:p>
-            <a:pPr algn="l" indent="0" marL="0">
-              <a:buNone/>
-            </a:pPr>
-            <a:endParaRPr lang="en-US" sz="2200" dirty="0"/>
-          </a:p>
-        </p:txBody>
-      </p:sp>
-      <p:sp>
-        <p:nvSpPr>
-          <p:cNvPr id="3" name="Text 0"/>
-          <p:cNvSpPr/>
-          <p:nvPr>
-            <p:ph idx="101" hasCustomPrompt="1"/>
-          </p:nvPr>
-        </p:nvSpPr>
-        <p:spPr>
-          <a:xfrm>
-            <a:off x="365760" y="576072"/>
-            <a:ext cx="8412480" cy="274320"/>
-          </a:xfrm>
-          <a:prstGeom prst="rect">
-            <a:avLst/>
-          </a:prstGeom>
-          <a:noFill/>
-          <a:ln/>
-        </p:spPr>
-        <p:txBody>
-          <a:bodyPr wrap="square" rtlCol="0"/>
-          <a:lstStyle>
-            <a:lvl1pPr algn="l" indent="0" marL="0">
-              <a:buNone/>
-              <a:defRPr lang="en-US" sz="1250" dirty="0">
-                <a:solidFill>
-                  <a:schemeClr val="accent1"/>
-                </a:solidFill>
-                <a:latin typeface="Arial" pitchFamily="34" charset="0"/>
-                <a:ea typeface="Arial" pitchFamily="34" charset="-122"/>
-                <a:cs typeface="Arial" pitchFamily="34" charset="-120"/>
-              </a:defRPr>
-            </a:lvl1pPr>
-          </a:lstStyle>
-          <a:p>
-            <a:pPr algn="l" indent="0" marL="0">
-              <a:buNone/>
-            </a:pPr>
-            <a:endParaRPr lang="en-US" sz="1250" dirty="0"/>
-          </a:p>
-        </p:txBody>
-      </p:sp>
-      <p:sp>
-        <p:nvSpPr>
-          <p:cNvPr id="4" name="Shape 0"/>
+          <p:cNvPr id="2" name="Shape 0"/>
           <p:cNvSpPr/>
           <p:nvPr/>
         </p:nvSpPr>
@@ -2665,95 +2245,11 @@
           <a:noFill/>
           <a:ln w="12700">
             <a:solidFill>
-              <a:schemeClr val="tx1"/>
+              <a:srgbClr val="000000"/>
             </a:solidFill>
             <a:prstDash val="solid"/>
           </a:ln>
         </p:spPr>
-      </p:sp>
-      <p:sp>
-        <p:nvSpPr>
-          <p:cNvPr id="5" name="Text 1"/>
-          <p:cNvSpPr/>
-          <p:nvPr>
-            <p:ph idx="103" type="body" hasCustomPrompt="1"/>
-          </p:nvPr>
-        </p:nvSpPr>
-        <p:spPr>
-          <a:xfrm>
-            <a:off x="301752" y="932688"/>
-            <a:ext cx="8531352" cy="557784"/>
-          </a:xfrm>
-          <a:prstGeom prst="rect">
-            <a:avLst/>
-          </a:prstGeom>
-          <a:noFill/>
-          <a:ln/>
-        </p:spPr>
-        <p:txBody>
-          <a:bodyPr wrap="square" rtlCol="0"/>
-          <a:lstStyle>
-            <a:lvl1pPr algn="l" indent="0" marL="0">
-              <a:buNone/>
-              <a:defRPr lang="en-US" sz="1200" dirty="0">
-                <a:solidFill>
-                  <a:schemeClr val="tx1"/>
-                </a:solidFill>
-                <a:latin typeface="Times New Roman" pitchFamily="34" charset="0"/>
-                <a:ea typeface="Times New Roman" pitchFamily="34" charset="-122"/>
-                <a:cs typeface="Times New Roman" pitchFamily="34" charset="-120"/>
-              </a:defRPr>
-            </a:lvl1pPr>
-          </a:lstStyle>
-          <a:p>
-            <a:pPr algn="l" indent="0" marL="0">
-              <a:buNone/>
-            </a:pPr>
-            <a:endParaRPr lang="en-US" sz="1200" dirty="0"/>
-          </a:p>
-        </p:txBody>
-      </p:sp>
-      <p:sp>
-        <p:nvSpPr>
-          <p:cNvPr id="6" name="Text 1"/>
-          <p:cNvSpPr/>
-          <p:nvPr>
-            <p:ph idx="104" hasCustomPrompt="1"/>
-          </p:nvPr>
-        </p:nvSpPr>
-        <p:spPr>
-          <a:xfrm>
-            <a:off x="0" y="4791456"/>
-            <a:ext cx="7863840" cy="356616"/>
-          </a:xfrm>
-          <a:prstGeom prst="rect">
-            <a:avLst/>
-          </a:prstGeom>
-          <a:noFill/>
-          <a:ln/>
-        </p:spPr>
-        <p:txBody>
-          <a:bodyPr wrap="square" rtlCol="0"/>
-          <a:lstStyle>
-            <a:lvl1pPr indent="0" marL="0">
-              <a:buNone/>
-              <a:defRPr lang="en-US" sz="800" dirty="0">
-                <a:solidFill>
-                  <a:schemeClr val="tx1"/>
-                </a:solidFill>
-                <a:latin typeface="Arial" pitchFamily="34" charset="0"/>
-                <a:ea typeface="Arial" pitchFamily="34" charset="-122"/>
-                <a:cs typeface="Arial" pitchFamily="34" charset="-120"/>
-              </a:defRPr>
-            </a:lvl1pPr>
-          </a:lstStyle>
-          <a:p>
-            <a:pPr indent="0" marL="0">
-              <a:buNone/>
-            </a:pPr>
-            <a:endParaRPr lang="en-US" sz="800" dirty="0"/>
-          </a:p>
-        </p:txBody>
       </p:sp>
       <p:sp>
         <p:nvSpPr>
@@ -2785,7 +2281,7 @@
             <a:lvl1pPr>
               <a:defRPr sz="1200">
                 <a:solidFill>
-                  <a:schemeClr val="tx1"/>
+                  <a:srgbClr val="000000"/>
                 </a:solidFill>
                 <a:latin typeface="Arial"/>
                 <a:ea typeface="Arial"/>
@@ -2858,7 +2354,7 @@
             <a:lvl1pPr>
               <a:defRPr sz="1200">
                 <a:solidFill>
-                  <a:schemeClr val="tx1"/>
+                  <a:srgbClr val="000000"/>
                 </a:solidFill>
                 <a:latin typeface="Arial"/>
                 <a:ea typeface="Arial"/>
@@ -3160,14 +2656,14 @@
       </p:grpSpPr>
       <p:sp>
         <p:nvSpPr>
-          <p:cNvPr id="2" name="Text 0"/>
-          <p:cNvSpPr/>
+          <p:cNvPr id="2" name="Cover title"/>
+          <p:cNvSpPr txBox="1"/>
           <p:nvPr/>
         </p:nvSpPr>
         <p:spPr>
           <a:xfrm>
-            <a:off x="0" y="0"/>
-            <a:ext cx="6858000" cy="0"/>
+            <a:off x="310896" y="1682496"/>
+            <a:ext cx="8522208" cy="1773936"/>
           </a:xfrm>
           <a:prstGeom prst="rect">
             <a:avLst/>
@@ -3176,27 +2672,32 @@
           <a:ln/>
         </p:spPr>
         <p:txBody>
-          <a:bodyPr wrap="square" rtlCol="0"/>
+          <a:bodyPr wrap="square" lIns="0" tIns="0" rIns="0" bIns="0" rtlCol="0" anchor="ctr"/>
           <a:lstStyle/>
           <a:p>
-            <a:pPr indent="0" marL="0">
+            <a:pPr algn="l" indent="0" marL="0">
               <a:buNone/>
             </a:pPr>
             <a:r>
-              <a:rPr lang="en-US" dirty="0"/>
+              <a:rPr lang="en-US" sz="2600" b="1" dirty="0">
+                <a:solidFill>
+                  <a:srgbClr val="000000"/>
+                </a:solidFill>
+                <a:latin typeface="Arial" pitchFamily="34" charset="0"/>
+                <a:ea typeface="Arial" pitchFamily="34" charset="-122"/>
+                <a:cs typeface="Arial" pitchFamily="34" charset="-120"/>
+              </a:rPr>
               <a:t>Progress Report</a:t>
             </a:r>
-            <a:endParaRPr lang="en-US" dirty="0"/>
+            <a:endParaRPr lang="en-US" sz="2600" dirty="0"/>
           </a:p>
         </p:txBody>
       </p:sp>
       <p:sp>
         <p:nvSpPr>
-          <p:cNvPr id="3" name="Text 1"/>
-          <p:cNvSpPr/>
-          <p:nvPr>
-            <p:ph idx="102" type="body" hasCustomPrompt="1"/>
-          </p:nvPr>
+          <p:cNvPr id="3" name="Cover subtitle"/>
+          <p:cNvSpPr txBox="1"/>
+          <p:nvPr/>
         </p:nvSpPr>
         <p:spPr>
           <a:xfrm>
@@ -3219,7 +2720,7 @@
             <a:r>
               <a:rPr lang="en-US" sz="1400" b="1" dirty="0">
                 <a:solidFill>
-                  <a:schemeClr val="tx2"/>
+                  <a:srgbClr val="595959"/>
                 </a:solidFill>
                 <a:latin typeface="Times New Roman" pitchFamily="34" charset="0"/>
                 <a:ea typeface="Times New Roman" pitchFamily="34" charset="-122"/>
@@ -3236,7 +2737,7 @@
             <a:r>
               <a:rPr lang="en-US" sz="1400" b="1" dirty="0">
                 <a:solidFill>
-                  <a:schemeClr val="tx2"/>
+                  <a:srgbClr val="595959"/>
                 </a:solidFill>
                 <a:latin typeface="Times New Roman" pitchFamily="34" charset="0"/>
                 <a:ea typeface="Times New Roman" pitchFamily="34" charset="-122"/>
@@ -3245,34 +2746,6 @@
               <a:t>Oct. 28, 2026</a:t>
             </a:r>
             <a:endParaRPr lang="en-US" sz="1400" dirty="0"/>
-          </a:p>
-        </p:txBody>
-      </p:sp>
-      <p:sp>
-        <p:nvSpPr>
-          <p:cNvPr id="5" name="Text 1"/>
-          <p:cNvSpPr/>
-          <p:nvPr/>
-        </p:nvSpPr>
-        <p:spPr>
-          <a:xfrm>
-            <a:off x="310896" y="1682496"/>
-            <a:ext cx="8522208" cy="1773936"/>
-          </a:xfrm>
-          <a:prstGeom prst="rect">
-            <a:avLst/>
-          </a:prstGeom>
-          <a:noFill/>
-          <a:ln/>
-        </p:spPr>
-        <p:txBody>
-          <a:bodyPr wrap="square" lIns="0" tIns="0" rIns="0" bIns="0" rtlCol="0" anchor="ctr"/>
-          <a:lstStyle/>
-          <a:p>
-            <a:pPr algn="l" indent="0" marL="0">
-              <a:buNone/>
-            </a:pPr>
-            <a:endParaRPr lang="en-US" sz="2600" dirty="0"/>
           </a:p>
         </p:txBody>
       </p:sp>
@@ -3303,14 +2776,14 @@
       </p:grpSpPr>
       <p:sp>
         <p:nvSpPr>
-          <p:cNvPr id="2" name="Text 0"/>
-          <p:cNvSpPr/>
+          <p:cNvPr id="2" name="Title"/>
+          <p:cNvSpPr txBox="1"/>
           <p:nvPr/>
         </p:nvSpPr>
         <p:spPr>
           <a:xfrm>
-            <a:off x="0" y="0"/>
-            <a:ext cx="6858000" cy="0"/>
+            <a:off x="365760" y="182880"/>
+            <a:ext cx="8412480" cy="411480"/>
           </a:xfrm>
           <a:prstGeom prst="rect">
             <a:avLst/>
@@ -3319,30 +2792,37 @@
           <a:ln/>
         </p:spPr>
         <p:txBody>
-          <a:bodyPr wrap="square" rtlCol="0"/>
+          <a:bodyPr wrap="square" lIns="0" tIns="0" rIns="0" bIns="0" rtlCol="0" anchor="t"/>
           <a:lstStyle/>
           <a:p>
-            <a:pPr indent="0" marL="0">
+            <a:pPr algn="l" indent="0" marL="0">
               <a:buNone/>
             </a:pPr>
             <a:r>
-              <a:rPr lang="en-US" dirty="0"/>
+              <a:rPr lang="en-US" sz="2200" dirty="0">
+                <a:solidFill>
+                  <a:srgbClr val="000000"/>
+                </a:solidFill>
+                <a:latin typeface="Arial" pitchFamily="34" charset="0"/>
+                <a:ea typeface="Arial" pitchFamily="34" charset="-122"/>
+                <a:cs typeface="Arial" pitchFamily="34" charset="-120"/>
+              </a:rPr>
               <a:t>Coding evaluation pipeline</a:t>
             </a:r>
-            <a:endParaRPr lang="en-US" dirty="0"/>
+            <a:endParaRPr lang="en-US" sz="2200" dirty="0"/>
           </a:p>
         </p:txBody>
       </p:sp>
       <p:sp>
         <p:nvSpPr>
-          <p:cNvPr id="3" name="Text 1"/>
-          <p:cNvSpPr/>
+          <p:cNvPr id="3" name="Topic"/>
+          <p:cNvSpPr txBox="1"/>
           <p:nvPr/>
         </p:nvSpPr>
         <p:spPr>
           <a:xfrm>
-            <a:off x="0" y="0"/>
-            <a:ext cx="6858000" cy="0"/>
+            <a:off x="365760" y="576072"/>
+            <a:ext cx="8412480" cy="274320"/>
           </a:xfrm>
           <a:prstGeom prst="rect">
             <a:avLst/>
@@ -3351,30 +2831,37 @@
           <a:ln/>
         </p:spPr>
         <p:txBody>
-          <a:bodyPr wrap="square" rtlCol="0"/>
+          <a:bodyPr wrap="square" lIns="0" tIns="0" rIns="0" bIns="0" rtlCol="0" anchor="t"/>
           <a:lstStyle/>
           <a:p>
-            <a:pPr indent="0" marL="0">
+            <a:pPr algn="l" indent="0" marL="0">
               <a:buNone/>
             </a:pPr>
             <a:r>
-              <a:rPr lang="en-US" dirty="0"/>
+              <a:rPr lang="en-US" sz="1250" dirty="0">
+                <a:solidFill>
+                  <a:srgbClr val="9C6B1E"/>
+                </a:solidFill>
+                <a:latin typeface="Arial" pitchFamily="34" charset="0"/>
+                <a:ea typeface="Arial" pitchFamily="34" charset="-122"/>
+                <a:cs typeface="Arial" pitchFamily="34" charset="-120"/>
+              </a:rPr>
               <a:t>HumanEval</a:t>
             </a:r>
-            <a:endParaRPr lang="en-US" dirty="0"/>
+            <a:endParaRPr lang="en-US" sz="1250" dirty="0"/>
           </a:p>
         </p:txBody>
       </p:sp>
       <p:sp>
         <p:nvSpPr>
-          <p:cNvPr id="4" name="Text 2"/>
-          <p:cNvSpPr/>
+          <p:cNvPr id="4" name="Footnote"/>
+          <p:cNvSpPr txBox="1"/>
           <p:nvPr/>
         </p:nvSpPr>
         <p:spPr>
           <a:xfrm>
-            <a:off x="0" y="0"/>
-            <a:ext cx="6858000" cy="0"/>
+            <a:off x="0" y="4791456"/>
+            <a:ext cx="7863840" cy="356616"/>
           </a:xfrm>
           <a:prstGeom prst="rect">
             <a:avLst/>
@@ -3383,39 +2870,48 @@
           <a:ln/>
         </p:spPr>
         <p:txBody>
-          <a:bodyPr wrap="square" rtlCol="0"/>
+          <a:bodyPr wrap="square" lIns="91440" tIns="91440" rIns="91440" bIns="91440" rtlCol="0" anchor="ctr"/>
           <a:lstStyle/>
           <a:p>
-            <a:pPr indent="0" marL="0">
+            <a:pPr algn="l" indent="0" marL="0">
               <a:buNone/>
             </a:pPr>
             <a:r>
-              <a:rPr lang="en-US" b="1" u="sng" dirty="0">
+              <a:rPr lang="en-US" sz="800" b="1" u="sng" dirty="0">
                 <a:solidFill>
                   <a:srgbClr val="000000"/>
                 </a:solidFill>
+                <a:latin typeface="Arial" pitchFamily="34" charset="0"/>
+                <a:ea typeface="Arial" pitchFamily="34" charset="-122"/>
+                <a:cs typeface="Arial" pitchFamily="34" charset="-120"/>
               </a:rPr>
               <a:t>*1</a:t>
             </a:r>
-            <a:pPr indent="0" marL="0">
+            <a:pPr algn="l" indent="0" marL="0">
               <a:buNone/>
             </a:pPr>
             <a:r>
-              <a:rPr lang="en-US" dirty="0">
+              <a:rPr lang="en-US" sz="800" dirty="0">
                 <a:solidFill>
                   <a:srgbClr val="000000"/>
                 </a:solidFill>
+                <a:latin typeface="Arial" pitchFamily="34" charset="0"/>
+                <a:ea typeface="Arial" pitchFamily="34" charset="-122"/>
+                <a:cs typeface="Arial" pitchFamily="34" charset="-120"/>
               </a:rPr>
               <a:t> </a:t>
             </a:r>
-            <a:pPr indent="0" marL="0">
+            <a:pPr algn="l" indent="0" marL="0">
               <a:buNone/>
             </a:pPr>
             <a:r>
-              <a:rPr lang="en-US" u="sng" dirty="0">
+              <a:rPr lang="en-US" sz="800" u="sng" dirty="0">
                 <a:solidFill>
                   <a:srgbClr val="0000EE"/>
                 </a:solidFill>
+                <a:latin typeface="Arial" pitchFamily="34" charset="0"/>
+                <a:ea typeface="Arial" pitchFamily="34" charset="-122"/>
+                <a:cs typeface="Arial" pitchFamily="34" charset="-120"/>
                 <a:hlinkClick r:id="rId1" invalidUrl="" action="" tgtFrame="" tooltip="" history="1" highlightClick="0" endSnd="0">
                   <a:extLst>
                     <a:ext uri="{A12FA001-AC4F-418D-AE19-62706E023703}">
@@ -3426,7 +2922,7 @@
               </a:rPr>
               <a:t>https://github.com/torridfish/lrm/issues/6</a:t>
             </a:r>
-            <a:endParaRPr lang="en-US" dirty="0"/>
+            <a:endParaRPr lang="en-US" sz="800" dirty="0"/>
           </a:p>
         </p:txBody>
       </p:sp>
@@ -3649,7 +3145,7 @@
             <a:lvl1pPr>
               <a:defRPr sz="1200">
                 <a:solidFill>
-                  <a:schemeClr val="tx1"/>
+                  <a:srgbClr val="000000"/>
                 </a:solidFill>
                 <a:latin typeface="Arial"/>
                 <a:ea typeface="Arial"/>
@@ -3694,14 +3190,14 @@
       </p:grpSpPr>
       <p:sp>
         <p:nvSpPr>
-          <p:cNvPr id="2" name="Text 0"/>
-          <p:cNvSpPr/>
+          <p:cNvPr id="2" name="Title"/>
+          <p:cNvSpPr txBox="1"/>
           <p:nvPr/>
         </p:nvSpPr>
         <p:spPr>
           <a:xfrm>
-            <a:off x="0" y="0"/>
-            <a:ext cx="6858000" cy="0"/>
+            <a:off x="365760" y="182880"/>
+            <a:ext cx="8412480" cy="411480"/>
           </a:xfrm>
           <a:prstGeom prst="rect">
             <a:avLst/>
@@ -3710,30 +3206,37 @@
           <a:ln/>
         </p:spPr>
         <p:txBody>
-          <a:bodyPr wrap="square" rtlCol="0"/>
+          <a:bodyPr wrap="square" lIns="0" tIns="0" rIns="0" bIns="0" rtlCol="0" anchor="t"/>
           <a:lstStyle/>
           <a:p>
-            <a:pPr indent="0" marL="0">
+            <a:pPr algn="l" indent="0" marL="0">
               <a:buNone/>
             </a:pPr>
             <a:r>
-              <a:rPr lang="en-US" dirty="0"/>
+              <a:rPr lang="en-US" sz="2200" dirty="0">
+                <a:solidFill>
+                  <a:srgbClr val="000000"/>
+                </a:solidFill>
+                <a:latin typeface="Arial" pitchFamily="34" charset="0"/>
+                <a:ea typeface="Arial" pitchFamily="34" charset="-122"/>
+                <a:cs typeface="Arial" pitchFamily="34" charset="-120"/>
+              </a:rPr>
               <a:t>Setup</a:t>
             </a:r>
-            <a:endParaRPr lang="en-US" dirty="0"/>
+            <a:endParaRPr lang="en-US" sz="2200" dirty="0"/>
           </a:p>
         </p:txBody>
       </p:sp>
       <p:sp>
         <p:nvSpPr>
-          <p:cNvPr id="3" name="Text 1"/>
-          <p:cNvSpPr/>
+          <p:cNvPr id="3" name="Topic"/>
+          <p:cNvSpPr txBox="1"/>
           <p:nvPr/>
         </p:nvSpPr>
         <p:spPr>
           <a:xfrm>
-            <a:off x="0" y="0"/>
-            <a:ext cx="6858000" cy="0"/>
+            <a:off x="365760" y="576072"/>
+            <a:ext cx="8412480" cy="274320"/>
           </a:xfrm>
           <a:prstGeom prst="rect">
             <a:avLst/>
@@ -3742,27 +3245,32 @@
           <a:ln/>
         </p:spPr>
         <p:txBody>
-          <a:bodyPr wrap="square" rtlCol="0"/>
+          <a:bodyPr wrap="square" lIns="0" tIns="0" rIns="0" bIns="0" rtlCol="0" anchor="t"/>
           <a:lstStyle/>
           <a:p>
-            <a:pPr indent="0" marL="0">
+            <a:pPr algn="l" indent="0" marL="0">
               <a:buNone/>
             </a:pPr>
             <a:r>
-              <a:rPr lang="en-US" dirty="0"/>
+              <a:rPr lang="en-US" sz="1250" dirty="0">
+                <a:solidFill>
+                  <a:srgbClr val="9C6B1E"/>
+                </a:solidFill>
+                <a:latin typeface="Arial" pitchFamily="34" charset="0"/>
+                <a:ea typeface="Arial" pitchFamily="34" charset="-122"/>
+                <a:cs typeface="Arial" pitchFamily="34" charset="-120"/>
+              </a:rPr>
               <a:t>Training loss and the two-stage procedure</a:t>
             </a:r>
-            <a:endParaRPr lang="en-US" dirty="0"/>
+            <a:endParaRPr lang="en-US" sz="1250" dirty="0"/>
           </a:p>
         </p:txBody>
       </p:sp>
       <p:sp>
         <p:nvSpPr>
-          <p:cNvPr id="4" name="Text 1"/>
-          <p:cNvSpPr/>
-          <p:nvPr>
-            <p:ph idx="103" type="body" hasCustomPrompt="1"/>
-          </p:nvPr>
+          <p:cNvPr id="4" name="Lead"/>
+          <p:cNvSpPr txBox="1"/>
+          <p:nvPr/>
         </p:nvSpPr>
         <p:spPr>
           <a:xfrm>
@@ -3785,7 +3293,7 @@
             <a:r>
               <a:rPr lang="en-US" sz="1200" dirty="0">
                 <a:solidFill>
-                  <a:schemeClr val="tx1"/>
+                  <a:srgbClr val="000000"/>
                 </a:solidFill>
                 <a:latin typeface="Times New Roman" pitchFamily="34" charset="0"/>
                 <a:ea typeface="Times New Roman" pitchFamily="34" charset="-122"/>
@@ -3799,14 +3307,14 @@
       </p:sp>
       <p:sp>
         <p:nvSpPr>
-          <p:cNvPr id="5" name="Text 3"/>
-          <p:cNvSpPr/>
+          <p:cNvPr id="5" name="Footnote"/>
+          <p:cNvSpPr txBox="1"/>
           <p:nvPr/>
         </p:nvSpPr>
         <p:spPr>
           <a:xfrm>
-            <a:off x="0" y="0"/>
-            <a:ext cx="6858000" cy="0"/>
+            <a:off x="0" y="4791456"/>
+            <a:ext cx="7863840" cy="356616"/>
           </a:xfrm>
           <a:prstGeom prst="rect">
             <a:avLst/>
@@ -3815,32 +3323,38 @@
           <a:ln/>
         </p:spPr>
         <p:txBody>
-          <a:bodyPr wrap="square" rtlCol="0"/>
+          <a:bodyPr wrap="square" lIns="91440" tIns="91440" rIns="91440" bIns="91440" rtlCol="0" anchor="ctr"/>
           <a:lstStyle/>
           <a:p>
-            <a:pPr indent="0" marL="0">
+            <a:pPr algn="l" indent="0" marL="0">
               <a:buNone/>
             </a:pPr>
             <a:r>
-              <a:rPr lang="en-US" b="1" u="sng" dirty="0">
+              <a:rPr lang="en-US" sz="800" b="1" u="sng" dirty="0">
                 <a:solidFill>
                   <a:srgbClr val="000000"/>
                 </a:solidFill>
+                <a:latin typeface="Arial" pitchFamily="34" charset="0"/>
+                <a:ea typeface="Arial" pitchFamily="34" charset="-122"/>
+                <a:cs typeface="Arial" pitchFamily="34" charset="-120"/>
               </a:rPr>
               <a:t>*1</a:t>
             </a:r>
-            <a:pPr indent="0" marL="0">
+            <a:pPr algn="l" indent="0" marL="0">
               <a:buNone/>
             </a:pPr>
             <a:r>
-              <a:rPr lang="en-US" dirty="0">
+              <a:rPr lang="en-US" sz="800" dirty="0">
                 <a:solidFill>
                   <a:srgbClr val="000000"/>
                 </a:solidFill>
+                <a:latin typeface="Arial" pitchFamily="34" charset="0"/>
+                <a:ea typeface="Arial" pitchFamily="34" charset="-122"/>
+                <a:cs typeface="Arial" pitchFamily="34" charset="-120"/>
               </a:rPr>
               <a:t> Rendered with the local TeX Live by the research-slides skill (tex2img.sh); sources under assets/Math/.</a:t>
             </a:r>
-            <a:endParaRPr lang="en-US" dirty="0"/>
+            <a:endParaRPr lang="en-US" sz="800" dirty="0"/>
           </a:p>
         </p:txBody>
       </p:sp>
@@ -3922,7 +3436,7 @@
             <a:lvl1pPr>
               <a:defRPr sz="1200">
                 <a:solidFill>
-                  <a:schemeClr val="tx1"/>
+                  <a:srgbClr val="000000"/>
                 </a:solidFill>
                 <a:latin typeface="Arial"/>
                 <a:ea typeface="Arial"/>
@@ -3967,14 +3481,14 @@
       </p:grpSpPr>
       <p:sp>
         <p:nvSpPr>
-          <p:cNvPr id="2" name="Text 0"/>
-          <p:cNvSpPr/>
+          <p:cNvPr id="2" name="Title"/>
+          <p:cNvSpPr txBox="1"/>
           <p:nvPr/>
         </p:nvSpPr>
         <p:spPr>
           <a:xfrm>
-            <a:off x="0" y="0"/>
-            <a:ext cx="6858000" cy="0"/>
+            <a:off x="365760" y="182880"/>
+            <a:ext cx="8412480" cy="411480"/>
           </a:xfrm>
           <a:prstGeom prst="rect">
             <a:avLst/>
@@ -3983,30 +3497,37 @@
           <a:ln/>
         </p:spPr>
         <p:txBody>
-          <a:bodyPr wrap="square" rtlCol="0"/>
+          <a:bodyPr wrap="square" lIns="0" tIns="0" rIns="0" bIns="0" rtlCol="0" anchor="t"/>
           <a:lstStyle/>
           <a:p>
-            <a:pPr indent="0" marL="0">
+            <a:pPr algn="l" indent="0" marL="0">
               <a:buNone/>
             </a:pPr>
             <a:r>
-              <a:rPr lang="en-US" dirty="0"/>
+              <a:rPr lang="en-US" sz="2200" dirty="0">
+                <a:solidFill>
+                  <a:srgbClr val="000000"/>
+                </a:solidFill>
+                <a:latin typeface="Arial" pitchFamily="34" charset="0"/>
+                <a:ea typeface="Arial" pitchFamily="34" charset="-122"/>
+                <a:cs typeface="Arial" pitchFamily="34" charset="-120"/>
+              </a:rPr>
               <a:t>Experiment</a:t>
             </a:r>
-            <a:endParaRPr lang="en-US" dirty="0"/>
+            <a:endParaRPr lang="en-US" sz="2200" dirty="0"/>
           </a:p>
         </p:txBody>
       </p:sp>
       <p:sp>
         <p:nvSpPr>
-          <p:cNvPr id="3" name="Text 1"/>
-          <p:cNvSpPr/>
+          <p:cNvPr id="3" name="Topic"/>
+          <p:cNvSpPr txBox="1"/>
           <p:nvPr/>
         </p:nvSpPr>
         <p:spPr>
           <a:xfrm>
-            <a:off x="0" y="0"/>
-            <a:ext cx="6858000" cy="0"/>
+            <a:off x="365760" y="576072"/>
+            <a:ext cx="8412480" cy="274320"/>
           </a:xfrm>
           <a:prstGeom prst="rect">
             <a:avLst/>
@@ -4015,27 +3536,32 @@
           <a:ln/>
         </p:spPr>
         <p:txBody>
-          <a:bodyPr wrap="square" rtlCol="0"/>
+          <a:bodyPr wrap="square" lIns="0" tIns="0" rIns="0" bIns="0" rtlCol="0" anchor="t"/>
           <a:lstStyle/>
           <a:p>
-            <a:pPr indent="0" marL="0">
+            <a:pPr algn="l" indent="0" marL="0">
               <a:buNone/>
             </a:pPr>
             <a:r>
-              <a:rPr lang="en-US" dirty="0"/>
+              <a:rPr lang="en-US" sz="1250" dirty="0">
+                <a:solidFill>
+                  <a:srgbClr val="9C6B1E"/>
+                </a:solidFill>
+                <a:latin typeface="Arial" pitchFamily="34" charset="0"/>
+                <a:ea typeface="Arial" pitchFamily="34" charset="-122"/>
+                <a:cs typeface="Arial" pitchFamily="34" charset="-120"/>
+              </a:rPr>
               <a:t>Category C: Observation</a:t>
             </a:r>
-            <a:endParaRPr lang="en-US" dirty="0"/>
+            <a:endParaRPr lang="en-US" sz="1250" dirty="0"/>
           </a:p>
         </p:txBody>
       </p:sp>
       <p:sp>
         <p:nvSpPr>
-          <p:cNvPr id="4" name="Text 1"/>
-          <p:cNvSpPr/>
-          <p:nvPr>
-            <p:ph idx="103" type="body" hasCustomPrompt="1"/>
-          </p:nvPr>
+          <p:cNvPr id="4" name="Lead"/>
+          <p:cNvSpPr txBox="1"/>
+          <p:nvPr/>
         </p:nvSpPr>
         <p:spPr>
           <a:xfrm>
@@ -4058,7 +3584,7 @@
             <a:r>
               <a:rPr lang="en-US" sz="1200" dirty="0">
                 <a:solidFill>
-                  <a:schemeClr val="tx1"/>
+                  <a:srgbClr val="000000"/>
                 </a:solidFill>
                 <a:latin typeface="Times New Roman" pitchFamily="34" charset="0"/>
                 <a:ea typeface="Times New Roman" pitchFamily="34" charset="-122"/>
@@ -4075,7 +3601,7 @@
             <a:r>
               <a:rPr lang="en-US" sz="1200" dirty="0">
                 <a:solidFill>
-                  <a:schemeClr val="tx1"/>
+                  <a:srgbClr val="000000"/>
                 </a:solidFill>
                 <a:latin typeface="Times New Roman" pitchFamily="34" charset="0"/>
                 <a:ea typeface="Times New Roman" pitchFamily="34" charset="-122"/>
@@ -4373,7 +3899,7 @@
             <a:lvl1pPr>
               <a:defRPr sz="1200">
                 <a:solidFill>
-                  <a:schemeClr val="tx1"/>
+                  <a:srgbClr val="000000"/>
                 </a:solidFill>
                 <a:latin typeface="Arial"/>
                 <a:ea typeface="Arial"/>
@@ -4418,14 +3944,14 @@
       </p:grpSpPr>
       <p:sp>
         <p:nvSpPr>
-          <p:cNvPr id="2" name="Text 0"/>
-          <p:cNvSpPr/>
+          <p:cNvPr id="2" name="Title"/>
+          <p:cNvSpPr txBox="1"/>
           <p:nvPr/>
         </p:nvSpPr>
         <p:spPr>
           <a:xfrm>
-            <a:off x="0" y="0"/>
-            <a:ext cx="6858000" cy="0"/>
+            <a:off x="365760" y="182880"/>
+            <a:ext cx="8412480" cy="411480"/>
           </a:xfrm>
           <a:prstGeom prst="rect">
             <a:avLst/>
@@ -4434,30 +3960,37 @@
           <a:ln/>
         </p:spPr>
         <p:txBody>
-          <a:bodyPr wrap="square" rtlCol="0"/>
+          <a:bodyPr wrap="square" lIns="0" tIns="0" rIns="0" bIns="0" rtlCol="0" anchor="t"/>
           <a:lstStyle/>
           <a:p>
-            <a:pPr indent="0" marL="0">
+            <a:pPr algn="l" indent="0" marL="0">
               <a:buNone/>
             </a:pPr>
             <a:r>
-              <a:rPr lang="en-US" dirty="0"/>
+              <a:rPr lang="en-US" sz="2200" dirty="0">
+                <a:solidFill>
+                  <a:srgbClr val="000000"/>
+                </a:solidFill>
+                <a:latin typeface="Arial" pitchFamily="34" charset="0"/>
+                <a:ea typeface="Arial" pitchFamily="34" charset="-122"/>
+                <a:cs typeface="Arial" pitchFamily="34" charset="-120"/>
+              </a:rPr>
               <a:t>Setup</a:t>
             </a:r>
-            <a:endParaRPr lang="en-US" dirty="0"/>
+            <a:endParaRPr lang="en-US" sz="2200" dirty="0"/>
           </a:p>
         </p:txBody>
       </p:sp>
       <p:sp>
         <p:nvSpPr>
-          <p:cNvPr id="3" name="Text 1"/>
-          <p:cNvSpPr/>
+          <p:cNvPr id="3" name="Topic"/>
+          <p:cNvSpPr txBox="1"/>
           <p:nvPr/>
         </p:nvSpPr>
         <p:spPr>
           <a:xfrm>
-            <a:off x="0" y="0"/>
-            <a:ext cx="6858000" cy="0"/>
+            <a:off x="365760" y="576072"/>
+            <a:ext cx="8412480" cy="274320"/>
           </a:xfrm>
           <a:prstGeom prst="rect">
             <a:avLst/>
@@ -4466,27 +3999,32 @@
           <a:ln/>
         </p:spPr>
         <p:txBody>
-          <a:bodyPr wrap="square" rtlCol="0"/>
+          <a:bodyPr wrap="square" lIns="0" tIns="0" rIns="0" bIns="0" rtlCol="0" anchor="t"/>
           <a:lstStyle/>
           <a:p>
-            <a:pPr indent="0" marL="0">
+            <a:pPr algn="l" indent="0" marL="0">
               <a:buNone/>
             </a:pPr>
             <a:r>
-              <a:rPr lang="en-US" dirty="0"/>
+              <a:rPr lang="en-US" sz="1250" dirty="0">
+                <a:solidFill>
+                  <a:srgbClr val="9C6B1E"/>
+                </a:solidFill>
+                <a:latin typeface="Arial" pitchFamily="34" charset="0"/>
+                <a:ea typeface="Arial" pitchFamily="34" charset="-122"/>
+                <a:cs typeface="Arial" pitchFamily="34" charset="-120"/>
+              </a:rPr>
               <a:t>Prompt template</a:t>
             </a:r>
-            <a:endParaRPr lang="en-US" dirty="0"/>
+            <a:endParaRPr lang="en-US" sz="1250" dirty="0"/>
           </a:p>
         </p:txBody>
       </p:sp>
       <p:sp>
         <p:nvSpPr>
-          <p:cNvPr id="4" name="Text 1"/>
-          <p:cNvSpPr/>
-          <p:nvPr>
-            <p:ph idx="103" type="body" hasCustomPrompt="1"/>
-          </p:nvPr>
+          <p:cNvPr id="4" name="Lead"/>
+          <p:cNvSpPr txBox="1"/>
+          <p:nvPr/>
         </p:nvSpPr>
         <p:spPr>
           <a:xfrm>
@@ -4509,7 +4047,7 @@
             <a:r>
               <a:rPr lang="en-US" sz="1200" dirty="0">
                 <a:solidFill>
-                  <a:schemeClr val="tx1"/>
+                  <a:srgbClr val="000000"/>
                 </a:solidFill>
                 <a:latin typeface="Times New Roman" pitchFamily="34" charset="0"/>
                 <a:ea typeface="Times New Roman" pitchFamily="34" charset="-122"/>
@@ -4884,7 +4422,7 @@
             <a:lvl1pPr>
               <a:defRPr sz="1200">
                 <a:solidFill>
-                  <a:schemeClr val="tx1"/>
+                  <a:srgbClr val="000000"/>
                 </a:solidFill>
                 <a:latin typeface="Arial"/>
                 <a:ea typeface="Arial"/>
@@ -4929,14 +4467,14 @@
       </p:grpSpPr>
       <p:sp>
         <p:nvSpPr>
-          <p:cNvPr id="2" name="Text 0"/>
-          <p:cNvSpPr/>
+          <p:cNvPr id="2" name="Title"/>
+          <p:cNvSpPr txBox="1"/>
           <p:nvPr/>
         </p:nvSpPr>
         <p:spPr>
           <a:xfrm>
-            <a:off x="0" y="0"/>
-            <a:ext cx="6858000" cy="0"/>
+            <a:off x="365760" y="182880"/>
+            <a:ext cx="8412480" cy="411480"/>
           </a:xfrm>
           <a:prstGeom prst="rect">
             <a:avLst/>
@@ -4945,30 +4483,37 @@
           <a:ln/>
         </p:spPr>
         <p:txBody>
-          <a:bodyPr wrap="square" rtlCol="0"/>
+          <a:bodyPr wrap="square" lIns="0" tIns="0" rIns="0" bIns="0" rtlCol="0" anchor="t"/>
           <a:lstStyle/>
           <a:p>
-            <a:pPr indent="0" marL="0">
+            <a:pPr algn="l" indent="0" marL="0">
               <a:buNone/>
             </a:pPr>
             <a:r>
-              <a:rPr lang="en-US" dirty="0"/>
+              <a:rPr lang="en-US" sz="2200" dirty="0">
+                <a:solidFill>
+                  <a:srgbClr val="000000"/>
+                </a:solidFill>
+                <a:latin typeface="Arial" pitchFamily="34" charset="0"/>
+                <a:ea typeface="Arial" pitchFamily="34" charset="-122"/>
+                <a:cs typeface="Arial" pitchFamily="34" charset="-120"/>
+              </a:rPr>
               <a:t>Experiment</a:t>
             </a:r>
-            <a:endParaRPr lang="en-US" dirty="0"/>
+            <a:endParaRPr lang="en-US" sz="2200" dirty="0"/>
           </a:p>
         </p:txBody>
       </p:sp>
       <p:sp>
         <p:nvSpPr>
-          <p:cNvPr id="3" name="Text 1"/>
-          <p:cNvSpPr/>
+          <p:cNvPr id="3" name="Topic"/>
+          <p:cNvSpPr txBox="1"/>
           <p:nvPr/>
         </p:nvSpPr>
         <p:spPr>
           <a:xfrm>
-            <a:off x="0" y="0"/>
-            <a:ext cx="6858000" cy="0"/>
+            <a:off x="365760" y="576072"/>
+            <a:ext cx="8412480" cy="274320"/>
           </a:xfrm>
           <a:prstGeom prst="rect">
             <a:avLst/>
@@ -4977,30 +4522,37 @@
           <a:ln/>
         </p:spPr>
         <p:txBody>
-          <a:bodyPr wrap="square" rtlCol="0"/>
+          <a:bodyPr wrap="square" lIns="0" tIns="0" rIns="0" bIns="0" rtlCol="0" anchor="t"/>
           <a:lstStyle/>
           <a:p>
-            <a:pPr indent="0" marL="0">
+            <a:pPr algn="l" indent="0" marL="0">
               <a:buNone/>
             </a:pPr>
             <a:r>
-              <a:rPr lang="en-US" dirty="0"/>
+              <a:rPr lang="en-US" sz="1250" dirty="0">
+                <a:solidFill>
+                  <a:srgbClr val="9C6B1E"/>
+                </a:solidFill>
+                <a:latin typeface="Arial" pitchFamily="34" charset="0"/>
+                <a:ea typeface="Arial" pitchFamily="34" charset="-122"/>
+                <a:cs typeface="Arial" pitchFamily="34" charset="-120"/>
+              </a:rPr>
               <a:t>Category B setups</a:t>
             </a:r>
-            <a:endParaRPr lang="en-US" dirty="0"/>
+            <a:endParaRPr lang="en-US" sz="1250" dirty="0"/>
           </a:p>
         </p:txBody>
       </p:sp>
       <p:sp>
         <p:nvSpPr>
-          <p:cNvPr id="4" name="Text 2"/>
-          <p:cNvSpPr/>
+          <p:cNvPr id="4" name="Footnote"/>
+          <p:cNvSpPr txBox="1"/>
           <p:nvPr/>
         </p:nvSpPr>
         <p:spPr>
           <a:xfrm>
-            <a:off x="0" y="0"/>
-            <a:ext cx="6858000" cy="0"/>
+            <a:off x="0" y="4791456"/>
+            <a:ext cx="7863840" cy="356616"/>
           </a:xfrm>
           <a:prstGeom prst="rect">
             <a:avLst/>
@@ -5009,32 +4561,38 @@
           <a:ln/>
         </p:spPr>
         <p:txBody>
-          <a:bodyPr wrap="square" rtlCol="0"/>
+          <a:bodyPr wrap="square" lIns="91440" tIns="91440" rIns="91440" bIns="91440" rtlCol="0" anchor="ctr"/>
           <a:lstStyle/>
           <a:p>
-            <a:pPr indent="0" marL="0">
+            <a:pPr algn="l" indent="0" marL="0">
               <a:buNone/>
             </a:pPr>
             <a:r>
-              <a:rPr lang="en-US" b="1" u="sng" dirty="0">
+              <a:rPr lang="en-US" sz="800" b="1" u="sng" dirty="0">
                 <a:solidFill>
                   <a:srgbClr val="000000"/>
                 </a:solidFill>
+                <a:latin typeface="Arial" pitchFamily="34" charset="0"/>
+                <a:ea typeface="Arial" pitchFamily="34" charset="-122"/>
+                <a:cs typeface="Arial" pitchFamily="34" charset="-120"/>
               </a:rPr>
               <a:t>*1</a:t>
             </a:r>
-            <a:pPr indent="0" marL="0">
+            <a:pPr algn="l" indent="0" marL="0">
               <a:buNone/>
             </a:pPr>
             <a:r>
-              <a:rPr lang="en-US" dirty="0">
+              <a:rPr lang="en-US" sz="800" dirty="0">
                 <a:solidFill>
                   <a:srgbClr val="000000"/>
                 </a:solidFill>
+                <a:latin typeface="Arial" pitchFamily="34" charset="0"/>
+                <a:ea typeface="Arial" pitchFamily="34" charset="-122"/>
+                <a:cs typeface="Arial" pitchFamily="34" charset="-120"/>
               </a:rPr>
               <a:t> → means the difference from the base run.</a:t>
             </a:r>
-            <a:endParaRPr lang="en-US" dirty="0"/>
+            <a:endParaRPr lang="en-US" sz="800" dirty="0"/>
           </a:p>
         </p:txBody>
       </p:sp>
@@ -5197,7 +4755,7 @@
             <a:lvl1pPr>
               <a:defRPr sz="1200">
                 <a:solidFill>
-                  <a:schemeClr val="tx1"/>
+                  <a:srgbClr val="000000"/>
                 </a:solidFill>
                 <a:latin typeface="Arial"/>
                 <a:ea typeface="Arial"/>
@@ -5242,14 +4800,14 @@
       </p:grpSpPr>
       <p:sp>
         <p:nvSpPr>
-          <p:cNvPr id="2" name="Text 0"/>
-          <p:cNvSpPr/>
+          <p:cNvPr id="2" name="Title"/>
+          <p:cNvSpPr txBox="1"/>
           <p:nvPr/>
         </p:nvSpPr>
         <p:spPr>
           <a:xfrm>
-            <a:off x="0" y="0"/>
-            <a:ext cx="6858000" cy="0"/>
+            <a:off x="365760" y="182880"/>
+            <a:ext cx="8412480" cy="411480"/>
           </a:xfrm>
           <a:prstGeom prst="rect">
             <a:avLst/>
@@ -5258,30 +4816,37 @@
           <a:ln/>
         </p:spPr>
         <p:txBody>
-          <a:bodyPr wrap="square" rtlCol="0"/>
+          <a:bodyPr wrap="square" lIns="0" tIns="0" rIns="0" bIns="0" rtlCol="0" anchor="t"/>
           <a:lstStyle/>
           <a:p>
-            <a:pPr indent="0" marL="0">
+            <a:pPr algn="l" indent="0" marL="0">
               <a:buNone/>
             </a:pPr>
             <a:r>
-              <a:rPr lang="en-US" dirty="0"/>
+              <a:rPr lang="en-US" sz="2200" dirty="0">
+                <a:solidFill>
+                  <a:srgbClr val="000000"/>
+                </a:solidFill>
+                <a:latin typeface="Arial" pitchFamily="34" charset="0"/>
+                <a:ea typeface="Arial" pitchFamily="34" charset="-122"/>
+                <a:cs typeface="Arial" pitchFamily="34" charset="-120"/>
+              </a:rPr>
               <a:t>TODO</a:t>
             </a:r>
-            <a:endParaRPr lang="en-US" dirty="0"/>
+            <a:endParaRPr lang="en-US" sz="2200" dirty="0"/>
           </a:p>
         </p:txBody>
       </p:sp>
       <p:sp>
         <p:nvSpPr>
-          <p:cNvPr id="3" name="Text 1"/>
-          <p:cNvSpPr/>
+          <p:cNvPr id="3" name="Topic"/>
+          <p:cNvSpPr txBox="1"/>
           <p:nvPr/>
         </p:nvSpPr>
         <p:spPr>
           <a:xfrm>
-            <a:off x="0" y="0"/>
-            <a:ext cx="6858000" cy="0"/>
+            <a:off x="365760" y="576072"/>
+            <a:ext cx="8412480" cy="274320"/>
           </a:xfrm>
           <a:prstGeom prst="rect">
             <a:avLst/>
@@ -5290,17 +4855,24 @@
           <a:ln/>
         </p:spPr>
         <p:txBody>
-          <a:bodyPr wrap="square" rtlCol="0"/>
+          <a:bodyPr wrap="square" lIns="0" tIns="0" rIns="0" bIns="0" rtlCol="0" anchor="t"/>
           <a:lstStyle/>
           <a:p>
-            <a:pPr indent="0" marL="0">
+            <a:pPr algn="l" indent="0" marL="0">
               <a:buNone/>
             </a:pPr>
             <a:r>
-              <a:rPr lang="en-US" dirty="0"/>
+              <a:rPr lang="en-US" sz="1250" dirty="0">
+                <a:solidFill>
+                  <a:srgbClr val="9C6B1E"/>
+                </a:solidFill>
+                <a:latin typeface="Arial" pitchFamily="34" charset="0"/>
+                <a:ea typeface="Arial" pitchFamily="34" charset="-122"/>
+                <a:cs typeface="Arial" pitchFamily="34" charset="-120"/>
+              </a:rPr>
               <a:t>Week of Oct. 13</a:t>
             </a:r>
-            <a:endParaRPr lang="en-US" dirty="0"/>
+            <a:endParaRPr lang="en-US" sz="1250" dirty="0"/>
           </a:p>
         </p:txBody>
       </p:sp>
@@ -5489,7 +5061,7 @@
             <a:lvl1pPr>
               <a:defRPr sz="1200">
                 <a:solidFill>
-                  <a:schemeClr val="tx1"/>
+                  <a:srgbClr val="000000"/>
                 </a:solidFill>
                 <a:latin typeface="Arial"/>
                 <a:ea typeface="Arial"/>
@@ -5534,105 +5106,8 @@
       </p:grpSpPr>
       <p:sp>
         <p:nvSpPr>
-          <p:cNvPr id="2" name="Text 0"/>
-          <p:cNvSpPr/>
-          <p:nvPr/>
-        </p:nvSpPr>
-        <p:spPr>
-          <a:xfrm>
-            <a:off x="0" y="0"/>
-            <a:ext cx="6858000" cy="0"/>
-          </a:xfrm>
-          <a:prstGeom prst="rect">
-            <a:avLst/>
-          </a:prstGeom>
-          <a:noFill/>
-          <a:ln/>
-        </p:spPr>
-        <p:txBody>
-          <a:bodyPr wrap="square" rtlCol="0"/>
-          <a:lstStyle/>
-          <a:p>
-            <a:pPr indent="0" marL="0">
-              <a:buNone/>
-            </a:pPr>
-            <a:r>
-              <a:rPr lang="en-US" dirty="0"/>
-              <a:t>Experiment: Does KV cache help?</a:t>
-            </a:r>
-            <a:endParaRPr lang="en-US" dirty="0"/>
-          </a:p>
-        </p:txBody>
-      </p:sp>
-      <p:sp>
-        <p:nvSpPr>
-          <p:cNvPr id="3" name="Text 1"/>
-          <p:cNvSpPr/>
-          <p:nvPr/>
-        </p:nvSpPr>
-        <p:spPr>
-          <a:xfrm>
-            <a:off x="0" y="0"/>
-            <a:ext cx="6858000" cy="0"/>
-          </a:xfrm>
-          <a:prstGeom prst="rect">
-            <a:avLst/>
-          </a:prstGeom>
-          <a:noFill/>
-          <a:ln/>
-        </p:spPr>
-        <p:txBody>
-          <a:bodyPr wrap="square" rtlCol="0"/>
-          <a:lstStyle/>
-          <a:p>
-            <a:pPr indent="0" marL="0">
-              <a:buNone/>
-            </a:pPr>
-            <a:r>
-              <a:rPr lang="en-US" b="1" u="sng" dirty="0">
-                <a:solidFill>
-                  <a:srgbClr val="000000"/>
-                </a:solidFill>
-              </a:rPr>
-              <a:t>*1</a:t>
-            </a:r>
-            <a:pPr indent="0" marL="0">
-              <a:buNone/>
-            </a:pPr>
-            <a:r>
-              <a:rPr lang="en-US" dirty="0">
-                <a:solidFill>
-                  <a:srgbClr val="000000"/>
-                </a:solidFill>
-              </a:rPr>
-              <a:t> Link: </a:t>
-            </a:r>
-            <a:pPr indent="0" marL="0">
-              <a:buNone/>
-            </a:pPr>
-            <a:r>
-              <a:rPr lang="en-US" u="sng" dirty="0">
-                <a:solidFill>
-                  <a:srgbClr val="0000EE"/>
-                </a:solidFill>
-                <a:hlinkClick r:id="rId1" invalidUrl="" action="" tgtFrame="" tooltip="" history="1" highlightClick="0" endSnd="0">
-                  <a:extLst>
-                    <a:ext uri="{A12FA001-AC4F-418D-AE19-62706E023703}">
-                      <ahyp:hlinkClr xmlns:ahyp="http://schemas.microsoft.com/office/drawing/2018/hyperlinkcolor" val="tx"/>
-                    </a:ext>
-                  </a:extLst>
-                </a:hlinkClick>
-              </a:rPr>
-              <a:t>https://github.com/torridfish/just3d/issues/17</a:t>
-            </a:r>
-            <a:endParaRPr lang="en-US" dirty="0"/>
-          </a:p>
-        </p:txBody>
-      </p:sp>
-      <p:sp>
-        <p:nvSpPr>
-          <p:cNvPr id="5" name="Text 1"/>
-          <p:cNvSpPr/>
+          <p:cNvPr id="2" name="Cover title"/>
+          <p:cNvSpPr txBox="1"/>
           <p:nvPr/>
         </p:nvSpPr>
         <p:spPr>
@@ -5653,7 +5128,92 @@
             <a:pPr algn="l" indent="0" marL="0">
               <a:buNone/>
             </a:pPr>
+            <a:r>
+              <a:rPr lang="en-US" sz="2600" b="1" dirty="0">
+                <a:solidFill>
+                  <a:srgbClr val="000000"/>
+                </a:solidFill>
+                <a:latin typeface="Arial" pitchFamily="34" charset="0"/>
+                <a:ea typeface="Arial" pitchFamily="34" charset="-122"/>
+                <a:cs typeface="Arial" pitchFamily="34" charset="-120"/>
+              </a:rPr>
+              <a:t>Experiment: Does KV cache help?</a:t>
+            </a:r>
             <a:endParaRPr lang="en-US" sz="2600" dirty="0"/>
+          </a:p>
+        </p:txBody>
+      </p:sp>
+      <p:sp>
+        <p:nvSpPr>
+          <p:cNvPr id="3" name="Footnote"/>
+          <p:cNvSpPr txBox="1"/>
+          <p:nvPr/>
+        </p:nvSpPr>
+        <p:spPr>
+          <a:xfrm>
+            <a:off x="0" y="4791456"/>
+            <a:ext cx="7863840" cy="356616"/>
+          </a:xfrm>
+          <a:prstGeom prst="rect">
+            <a:avLst/>
+          </a:prstGeom>
+          <a:noFill/>
+          <a:ln/>
+        </p:spPr>
+        <p:txBody>
+          <a:bodyPr wrap="square" lIns="91440" tIns="91440" rIns="91440" bIns="91440" rtlCol="0" anchor="ctr"/>
+          <a:lstStyle/>
+          <a:p>
+            <a:pPr algn="l" indent="0" marL="0">
+              <a:buNone/>
+            </a:pPr>
+            <a:r>
+              <a:rPr lang="en-US" sz="800" b="1" u="sng" dirty="0">
+                <a:solidFill>
+                  <a:srgbClr val="000000"/>
+                </a:solidFill>
+                <a:latin typeface="Arial" pitchFamily="34" charset="0"/>
+                <a:ea typeface="Arial" pitchFamily="34" charset="-122"/>
+                <a:cs typeface="Arial" pitchFamily="34" charset="-120"/>
+              </a:rPr>
+              <a:t>*1</a:t>
+            </a:r>
+            <a:pPr algn="l" indent="0" marL="0">
+              <a:buNone/>
+            </a:pPr>
+            <a:r>
+              <a:rPr lang="en-US" sz="800" dirty="0">
+                <a:solidFill>
+                  <a:srgbClr val="000000"/>
+                </a:solidFill>
+                <a:latin typeface="Arial" pitchFamily="34" charset="0"/>
+                <a:ea typeface="Arial" pitchFamily="34" charset="-122"/>
+                <a:cs typeface="Arial" pitchFamily="34" charset="-120"/>
+              </a:rPr>
+              <a:t> Link: </a:t>
+            </a:r>
+            <a:pPr algn="l" indent="0" marL="0">
+              <a:buNone/>
+            </a:pPr>
+            <a:r>
+              <a:rPr lang="en-US" sz="800" u="sng" dirty="0">
+                <a:solidFill>
+                  <a:srgbClr val="0000EE"/>
+                </a:solidFill>
+                <a:latin typeface="Arial" pitchFamily="34" charset="0"/>
+                <a:ea typeface="Arial" pitchFamily="34" charset="-122"/>
+                <a:cs typeface="Arial" pitchFamily="34" charset="-120"/>
+                <a:hlinkClick r:id="rId1" invalidUrl="" action="" tgtFrame="" tooltip="" history="1" highlightClick="0" endSnd="0">
+                  <a:extLst>
+                    <a:ext uri="{A12FA001-AC4F-418D-AE19-62706E023703}">
+                      <ahyp:hlinkClr xmlns:ahyp="http://schemas.microsoft.com/office/drawing/2018/hyperlinkcolor" val="tx"/>
+                    </a:ext>
+                  </a:extLst>
+                </a:hlinkClick>
+              </a:rPr>
+              <a:t>https://github.com/torridfish/just3d/issues/17</a:t>
+            </a:r>
+            <a:endParaRPr lang="en-US" sz="800" dirty="0"/>
           </a:p>
         </p:txBody>
       </p:sp>
@@ -5687,7 +5247,7 @@
             <a:lvl1pPr>
               <a:defRPr sz="1200">
                 <a:solidFill>
-                  <a:schemeClr val="tx1"/>
+                  <a:srgbClr val="000000"/>
                 </a:solidFill>
                 <a:latin typeface="Arial"/>
                 <a:ea typeface="Arial"/>
@@ -5732,11 +5292,9 @@
       </p:grpSpPr>
       <p:sp>
         <p:nvSpPr>
-          <p:cNvPr id="2" name="Text 0"/>
-          <p:cNvSpPr/>
-          <p:nvPr>
-            <p:ph idx="100" type="title" hasCustomPrompt="1"/>
-          </p:nvPr>
+          <p:cNvPr id="2" name="Divider"/>
+          <p:cNvSpPr txBox="1"/>
+          <p:nvPr/>
         </p:nvSpPr>
         <p:spPr>
           <a:xfrm>
@@ -5759,7 +5317,7 @@
             <a:r>
               <a:rPr lang="en-US" sz="2200" dirty="0">
                 <a:solidFill>
-                  <a:schemeClr val="tx1"/>
+                  <a:srgbClr val="000000"/>
                 </a:solidFill>
                 <a:latin typeface="Arial" pitchFamily="34" charset="0"/>
                 <a:ea typeface="Arial" pitchFamily="34" charset="-122"/>
@@ -5801,7 +5359,7 @@
             <a:lvl1pPr>
               <a:defRPr sz="1200">
                 <a:solidFill>
-                  <a:schemeClr val="tx1"/>
+                  <a:srgbClr val="000000"/>
                 </a:solidFill>
                 <a:latin typeface="Arial"/>
                 <a:ea typeface="Arial"/>
@@ -5846,14 +5404,14 @@
       </p:grpSpPr>
       <p:sp>
         <p:nvSpPr>
-          <p:cNvPr id="2" name="Text 0"/>
-          <p:cNvSpPr/>
+          <p:cNvPr id="2" name="Title"/>
+          <p:cNvSpPr txBox="1"/>
           <p:nvPr/>
         </p:nvSpPr>
         <p:spPr>
           <a:xfrm>
-            <a:off x="0" y="0"/>
-            <a:ext cx="6858000" cy="0"/>
+            <a:off x="365760" y="182880"/>
+            <a:ext cx="8412480" cy="411480"/>
           </a:xfrm>
           <a:prstGeom prst="rect">
             <a:avLst/>
@@ -5862,30 +5420,37 @@
           <a:ln/>
         </p:spPr>
         <p:txBody>
-          <a:bodyPr wrap="square" rtlCol="0"/>
+          <a:bodyPr wrap="square" lIns="0" tIns="0" rIns="0" bIns="0" rtlCol="0" anchor="t"/>
           <a:lstStyle/>
           <a:p>
-            <a:pPr indent="0" marL="0">
+            <a:pPr algn="l" indent="0" marL="0">
               <a:buNone/>
             </a:pPr>
             <a:r>
-              <a:rPr lang="en-US" dirty="0"/>
+              <a:rPr lang="en-US" sz="2200" dirty="0">
+                <a:solidFill>
+                  <a:srgbClr val="000000"/>
+                </a:solidFill>
+                <a:latin typeface="Arial" pitchFamily="34" charset="0"/>
+                <a:ea typeface="Arial" pitchFamily="34" charset="-122"/>
+                <a:cs typeface="Arial" pitchFamily="34" charset="-120"/>
+              </a:rPr>
               <a:t>Experiment</a:t>
             </a:r>
-            <a:endParaRPr lang="en-US" dirty="0"/>
+            <a:endParaRPr lang="en-US" sz="2200" dirty="0"/>
           </a:p>
         </p:txBody>
       </p:sp>
       <p:sp>
         <p:nvSpPr>
-          <p:cNvPr id="3" name="Text 1"/>
-          <p:cNvSpPr/>
+          <p:cNvPr id="3" name="Topic"/>
+          <p:cNvSpPr txBox="1"/>
           <p:nvPr/>
         </p:nvSpPr>
         <p:spPr>
           <a:xfrm>
-            <a:off x="0" y="0"/>
-            <a:ext cx="6858000" cy="0"/>
+            <a:off x="365760" y="576072"/>
+            <a:ext cx="8412480" cy="274320"/>
           </a:xfrm>
           <a:prstGeom prst="rect">
             <a:avLst/>
@@ -5894,27 +5459,32 @@
           <a:ln/>
         </p:spPr>
         <p:txBody>
-          <a:bodyPr wrap="square" rtlCol="0"/>
+          <a:bodyPr wrap="square" lIns="0" tIns="0" rIns="0" bIns="0" rtlCol="0" anchor="t"/>
           <a:lstStyle/>
           <a:p>
-            <a:pPr indent="0" marL="0">
+            <a:pPr algn="l" indent="0" marL="0">
               <a:buNone/>
             </a:pPr>
             <a:r>
-              <a:rPr lang="en-US" dirty="0"/>
+              <a:rPr lang="en-US" sz="1250" dirty="0">
+                <a:solidFill>
+                  <a:srgbClr val="9C6B1E"/>
+                </a:solidFill>
+                <a:latin typeface="Arial" pitchFamily="34" charset="0"/>
+                <a:ea typeface="Arial" pitchFamily="34" charset="-122"/>
+                <a:cs typeface="Arial" pitchFamily="34" charset="-120"/>
+              </a:rPr>
               <a:t>LLM backbone as its own proposer</a:t>
             </a:r>
-            <a:endParaRPr lang="en-US" dirty="0"/>
+            <a:endParaRPr lang="en-US" sz="1250" dirty="0"/>
           </a:p>
         </p:txBody>
       </p:sp>
       <p:sp>
         <p:nvSpPr>
-          <p:cNvPr id="4" name="Text 1"/>
-          <p:cNvSpPr/>
-          <p:nvPr>
-            <p:ph idx="103" type="body" hasCustomPrompt="1"/>
-          </p:nvPr>
+          <p:cNvPr id="4" name="Lead"/>
+          <p:cNvSpPr txBox="1"/>
+          <p:nvPr/>
         </p:nvSpPr>
         <p:spPr>
           <a:xfrm>
@@ -5937,7 +5507,7 @@
             <a:r>
               <a:rPr lang="en-US" sz="1200" dirty="0">
                 <a:solidFill>
-                  <a:schemeClr val="tx1"/>
+                  <a:srgbClr val="000000"/>
                 </a:solidFill>
                 <a:latin typeface="Times New Roman" pitchFamily="34" charset="0"/>
                 <a:ea typeface="Times New Roman" pitchFamily="34" charset="-122"/>
@@ -5954,7 +5524,7 @@
             <a:r>
               <a:rPr lang="en-US" sz="1200" dirty="0">
                 <a:solidFill>
-                  <a:schemeClr val="tx1"/>
+                  <a:srgbClr val="000000"/>
                 </a:solidFill>
                 <a:latin typeface="Times New Roman" pitchFamily="34" charset="0"/>
                 <a:ea typeface="Times New Roman" pitchFamily="34" charset="-122"/>
@@ -5968,14 +5538,14 @@
       </p:sp>
       <p:sp>
         <p:nvSpPr>
-          <p:cNvPr id="5" name="Text 3"/>
-          <p:cNvSpPr/>
+          <p:cNvPr id="5" name="Footnote"/>
+          <p:cNvSpPr txBox="1"/>
           <p:nvPr/>
         </p:nvSpPr>
         <p:spPr>
           <a:xfrm>
-            <a:off x="0" y="0"/>
-            <a:ext cx="6858000" cy="0"/>
+            <a:off x="0" y="4791456"/>
+            <a:ext cx="7863840" cy="356616"/>
           </a:xfrm>
           <a:prstGeom prst="rect">
             <a:avLst/>
@@ -5984,54 +5554,66 @@
           <a:ln/>
         </p:spPr>
         <p:txBody>
-          <a:bodyPr wrap="square" rtlCol="0"/>
+          <a:bodyPr wrap="square" lIns="91440" tIns="91440" rIns="91440" bIns="91440" rtlCol="0" anchor="ctr"/>
           <a:lstStyle/>
           <a:p>
-            <a:pPr indent="0" marL="0">
+            <a:pPr algn="l" indent="0" marL="0">
               <a:buNone/>
             </a:pPr>
             <a:r>
-              <a:rPr lang="en-US" b="1" u="sng" dirty="0">
+              <a:rPr lang="en-US" sz="800" b="1" u="sng" dirty="0">
                 <a:solidFill>
                   <a:srgbClr val="000000"/>
                 </a:solidFill>
+                <a:latin typeface="Arial" pitchFamily="34" charset="0"/>
+                <a:ea typeface="Arial" pitchFamily="34" charset="-122"/>
+                <a:cs typeface="Arial" pitchFamily="34" charset="-120"/>
               </a:rPr>
               <a:t>*1</a:t>
             </a:r>
-            <a:pPr indent="0" marL="0">
+            <a:pPr algn="l" indent="0" marL="0">
               <a:buNone/>
             </a:pPr>
             <a:r>
-              <a:rPr lang="en-US" dirty="0">
+              <a:rPr lang="en-US" sz="800" dirty="0">
                 <a:solidFill>
                   <a:srgbClr val="000000"/>
                 </a:solidFill>
+                <a:latin typeface="Arial" pitchFamily="34" charset="0"/>
+                <a:ea typeface="Arial" pitchFamily="34" charset="-122"/>
+                <a:cs typeface="Arial" pitchFamily="34" charset="-120"/>
               </a:rPr>
               <a:t> Proposal should be scene-shared, so KV cache </a:t>
             </a:r>
-            <a:pPr indent="0" marL="0">
+            <a:pPr algn="l" indent="0" marL="0">
               <a:buNone/>
             </a:pPr>
             <a:r>
-              <a:rPr lang="en-US" b="1" dirty="0">
+              <a:rPr lang="en-US" sz="800" b="1" dirty="0">
                 <a:solidFill>
                   <a:srgbClr val="000000"/>
                 </a:solidFill>
+                <a:latin typeface="Arial" pitchFamily="34" charset="0"/>
+                <a:ea typeface="Arial" pitchFamily="34" charset="-122"/>
+                <a:cs typeface="Arial" pitchFamily="34" charset="-120"/>
               </a:rPr>
               <a:t>reuse</a:t>
             </a:r>
-            <a:pPr indent="0" marL="0">
+            <a:pPr algn="l" indent="0" marL="0">
               <a:buNone/>
             </a:pPr>
             <a:r>
-              <a:rPr lang="en-US" dirty="0">
+              <a:rPr lang="en-US" sz="800" dirty="0">
                 <a:solidFill>
                   <a:srgbClr val="000000"/>
                 </a:solidFill>
+                <a:latin typeface="Arial" pitchFamily="34" charset="0"/>
+                <a:ea typeface="Arial" pitchFamily="34" charset="-122"/>
+                <a:cs typeface="Arial" pitchFamily="34" charset="-120"/>
               </a:rPr>
               <a:t> here might not be the main proposal.</a:t>
             </a:r>
-            <a:endParaRPr lang="en-US" dirty="0"/>
+            <a:endParaRPr lang="en-US" sz="800" dirty="0"/>
           </a:p>
         </p:txBody>
       </p:sp>
@@ -6089,7 +5671,7 @@
             <a:lvl1pPr>
               <a:defRPr sz="1200">
                 <a:solidFill>
-                  <a:schemeClr val="tx1"/>
+                  <a:srgbClr val="000000"/>
                 </a:solidFill>
                 <a:latin typeface="Arial"/>
                 <a:ea typeface="Arial"/>
@@ -6134,14 +5716,14 @@
       </p:grpSpPr>
       <p:sp>
         <p:nvSpPr>
-          <p:cNvPr id="2" name="Text 0"/>
-          <p:cNvSpPr/>
+          <p:cNvPr id="2" name="Title"/>
+          <p:cNvSpPr txBox="1"/>
           <p:nvPr/>
         </p:nvSpPr>
         <p:spPr>
           <a:xfrm>
-            <a:off x="0" y="0"/>
-            <a:ext cx="6858000" cy="0"/>
+            <a:off x="365760" y="182880"/>
+            <a:ext cx="8412480" cy="411480"/>
           </a:xfrm>
           <a:prstGeom prst="rect">
             <a:avLst/>
@@ -6150,30 +5732,37 @@
           <a:ln/>
         </p:spPr>
         <p:txBody>
-          <a:bodyPr wrap="square" rtlCol="0"/>
+          <a:bodyPr wrap="square" lIns="0" tIns="0" rIns="0" bIns="0" rtlCol="0" anchor="t"/>
           <a:lstStyle/>
           <a:p>
-            <a:pPr indent="0" marL="0">
+            <a:pPr algn="l" indent="0" marL="0">
               <a:buNone/>
             </a:pPr>
             <a:r>
-              <a:rPr lang="en-US" dirty="0"/>
+              <a:rPr lang="en-US" sz="2200" dirty="0">
+                <a:solidFill>
+                  <a:srgbClr val="000000"/>
+                </a:solidFill>
+                <a:latin typeface="Arial" pitchFamily="34" charset="0"/>
+                <a:ea typeface="Arial" pitchFamily="34" charset="-122"/>
+                <a:cs typeface="Arial" pitchFamily="34" charset="-120"/>
+              </a:rPr>
               <a:t>Setup</a:t>
             </a:r>
-            <a:endParaRPr lang="en-US" dirty="0"/>
+            <a:endParaRPr lang="en-US" sz="2200" dirty="0"/>
           </a:p>
         </p:txBody>
       </p:sp>
       <p:sp>
         <p:nvSpPr>
-          <p:cNvPr id="3" name="Text 1"/>
-          <p:cNvSpPr/>
+          <p:cNvPr id="3" name="Topic"/>
+          <p:cNvSpPr txBox="1"/>
           <p:nvPr/>
         </p:nvSpPr>
         <p:spPr>
           <a:xfrm>
-            <a:off x="0" y="0"/>
-            <a:ext cx="6858000" cy="0"/>
+            <a:off x="365760" y="576072"/>
+            <a:ext cx="8412480" cy="274320"/>
           </a:xfrm>
           <a:prstGeom prst="rect">
             <a:avLst/>
@@ -6182,27 +5771,32 @@
           <a:ln/>
         </p:spPr>
         <p:txBody>
-          <a:bodyPr wrap="square" rtlCol="0"/>
+          <a:bodyPr wrap="square" lIns="0" tIns="0" rIns="0" bIns="0" rtlCol="0" anchor="t"/>
           <a:lstStyle/>
           <a:p>
-            <a:pPr indent="0" marL="0">
+            <a:pPr algn="l" indent="0" marL="0">
               <a:buNone/>
             </a:pPr>
             <a:r>
-              <a:rPr lang="en-US" dirty="0"/>
+              <a:rPr lang="en-US" sz="1250" dirty="0">
+                <a:solidFill>
+                  <a:srgbClr val="9C6B1E"/>
+                </a:solidFill>
+                <a:latin typeface="Arial" pitchFamily="34" charset="0"/>
+                <a:ea typeface="Arial" pitchFamily="34" charset="-122"/>
+                <a:cs typeface="Arial" pitchFamily="34" charset="-120"/>
+              </a:rPr>
               <a:t>draw.io diagram kit</a:t>
             </a:r>
-            <a:endParaRPr lang="en-US" dirty="0"/>
+            <a:endParaRPr lang="en-US" sz="1250" dirty="0"/>
           </a:p>
         </p:txBody>
       </p:sp>
       <p:sp>
         <p:nvSpPr>
-          <p:cNvPr id="4" name="Text 1"/>
-          <p:cNvSpPr/>
-          <p:nvPr>
-            <p:ph idx="103" type="body" hasCustomPrompt="1"/>
-          </p:nvPr>
+          <p:cNvPr id="4" name="Lead"/>
+          <p:cNvSpPr txBox="1"/>
+          <p:nvPr/>
         </p:nvSpPr>
         <p:spPr>
           <a:xfrm>
@@ -6225,7 +5819,7 @@
             <a:r>
               <a:rPr lang="en-US" sz="1200" dirty="0">
                 <a:solidFill>
-                  <a:schemeClr val="tx1"/>
+                  <a:srgbClr val="000000"/>
                 </a:solidFill>
                 <a:latin typeface="Times New Roman" pitchFamily="34" charset="0"/>
                 <a:ea typeface="Times New Roman" pitchFamily="34" charset="-122"/>
@@ -6239,14 +5833,14 @@
       </p:sp>
       <p:sp>
         <p:nvSpPr>
-          <p:cNvPr id="5" name="Text 3"/>
-          <p:cNvSpPr/>
+          <p:cNvPr id="5" name="Footnote"/>
+          <p:cNvSpPr txBox="1"/>
           <p:nvPr/>
         </p:nvSpPr>
         <p:spPr>
           <a:xfrm>
-            <a:off x="0" y="0"/>
-            <a:ext cx="6858000" cy="0"/>
+            <a:off x="0" y="4791456"/>
+            <a:ext cx="7863840" cy="356616"/>
           </a:xfrm>
           <a:prstGeom prst="rect">
             <a:avLst/>
@@ -6255,32 +5849,38 @@
           <a:ln/>
         </p:spPr>
         <p:txBody>
-          <a:bodyPr wrap="square" rtlCol="0"/>
+          <a:bodyPr wrap="square" lIns="91440" tIns="91440" rIns="91440" bIns="91440" rtlCol="0" anchor="ctr"/>
           <a:lstStyle/>
           <a:p>
-            <a:pPr indent="0" marL="0">
+            <a:pPr algn="l" indent="0" marL="0">
               <a:buNone/>
             </a:pPr>
             <a:r>
-              <a:rPr lang="en-US" b="1" u="sng" dirty="0">
+              <a:rPr lang="en-US" sz="800" b="1" u="sng" dirty="0">
                 <a:solidFill>
                   <a:srgbClr val="000000"/>
                 </a:solidFill>
+                <a:latin typeface="Arial" pitchFamily="34" charset="0"/>
+                <a:ea typeface="Arial" pitchFamily="34" charset="-122"/>
+                <a:cs typeface="Arial" pitchFamily="34" charset="-120"/>
               </a:rPr>
               <a:t>*1</a:t>
             </a:r>
-            <a:pPr indent="0" marL="0">
+            <a:pPr algn="l" indent="0" marL="0">
               <a:buNone/>
             </a:pPr>
             <a:r>
-              <a:rPr lang="en-US" dirty="0">
+              <a:rPr lang="en-US" sz="800" dirty="0">
                 <a:solidFill>
                   <a:srgbClr val="000000"/>
                 </a:solidFill>
+                <a:latin typeface="Arial" pitchFamily="34" charset="0"/>
+                <a:ea typeface="Arial" pitchFamily="34" charset="-122"/>
+                <a:cs typeface="Arial" pitchFamily="34" charset="-120"/>
               </a:rPr>
               <a:t> Source: assets/Diagrams/research-slides-diagram-kit.drawio — export with the research-slides skill: scripts/drawio-export.sh</a:t>
             </a:r>
-            <a:endParaRPr lang="en-US" dirty="0"/>
+            <a:endParaRPr lang="en-US" sz="800" dirty="0"/>
           </a:p>
         </p:txBody>
       </p:sp>
@@ -6338,7 +5938,7 @@
             <a:lvl1pPr>
               <a:defRPr sz="1200">
                 <a:solidFill>
-                  <a:schemeClr val="tx1"/>
+                  <a:srgbClr val="000000"/>
                 </a:solidFill>
                 <a:latin typeface="Arial"/>
                 <a:ea typeface="Arial"/>
@@ -6383,14 +5983,14 @@
       </p:grpSpPr>
       <p:sp>
         <p:nvSpPr>
-          <p:cNvPr id="2" name="Text 0"/>
-          <p:cNvSpPr/>
+          <p:cNvPr id="2" name="Title"/>
+          <p:cNvSpPr txBox="1"/>
           <p:nvPr/>
         </p:nvSpPr>
         <p:spPr>
           <a:xfrm>
-            <a:off x="0" y="0"/>
-            <a:ext cx="6858000" cy="0"/>
+            <a:off x="365760" y="182880"/>
+            <a:ext cx="8412480" cy="411480"/>
           </a:xfrm>
           <a:prstGeom prst="rect">
             <a:avLst/>
@@ -6399,30 +5999,37 @@
           <a:ln/>
         </p:spPr>
         <p:txBody>
-          <a:bodyPr wrap="square" rtlCol="0"/>
+          <a:bodyPr wrap="square" lIns="0" tIns="0" rIns="0" bIns="0" rtlCol="0" anchor="t"/>
           <a:lstStyle/>
           <a:p>
-            <a:pPr indent="0" marL="0">
+            <a:pPr algn="l" indent="0" marL="0">
               <a:buNone/>
             </a:pPr>
             <a:r>
-              <a:rPr lang="en-US" dirty="0"/>
+              <a:rPr lang="en-US" sz="2200" dirty="0">
+                <a:solidFill>
+                  <a:srgbClr val="000000"/>
+                </a:solidFill>
+                <a:latin typeface="Arial" pitchFamily="34" charset="0"/>
+                <a:ea typeface="Arial" pitchFamily="34" charset="-122"/>
+                <a:cs typeface="Arial" pitchFamily="34" charset="-120"/>
+              </a:rPr>
               <a:t>Benchmark</a:t>
             </a:r>
-            <a:endParaRPr lang="en-US" dirty="0"/>
+            <a:endParaRPr lang="en-US" sz="2200" dirty="0"/>
           </a:p>
         </p:txBody>
       </p:sp>
       <p:sp>
         <p:nvSpPr>
-          <p:cNvPr id="3" name="Text 1"/>
-          <p:cNvSpPr/>
+          <p:cNvPr id="3" name="Topic"/>
+          <p:cNvSpPr txBox="1"/>
           <p:nvPr/>
         </p:nvSpPr>
         <p:spPr>
           <a:xfrm>
-            <a:off x="0" y="0"/>
-            <a:ext cx="6858000" cy="0"/>
+            <a:off x="365760" y="576072"/>
+            <a:ext cx="8412480" cy="274320"/>
           </a:xfrm>
           <a:prstGeom prst="rect">
             <a:avLst/>
@@ -6431,30 +6038,37 @@
           <a:ln/>
         </p:spPr>
         <p:txBody>
-          <a:bodyPr wrap="square" rtlCol="0"/>
+          <a:bodyPr wrap="square" lIns="0" tIns="0" rIns="0" bIns="0" rtlCol="0" anchor="t"/>
           <a:lstStyle/>
           <a:p>
-            <a:pPr indent="0" marL="0">
+            <a:pPr algn="l" indent="0" marL="0">
               <a:buNone/>
             </a:pPr>
             <a:r>
-              <a:rPr lang="en-US" dirty="0"/>
+              <a:rPr lang="en-US" sz="1250" dirty="0">
+                <a:solidFill>
+                  <a:srgbClr val="9C6B1E"/>
+                </a:solidFill>
+                <a:latin typeface="Arial" pitchFamily="34" charset="0"/>
+                <a:ea typeface="Arial" pitchFamily="34" charset="-122"/>
+                <a:cs typeface="Arial" pitchFamily="34" charset="-120"/>
+              </a:rPr>
               <a:t>ScanRefer</a:t>
             </a:r>
-            <a:endParaRPr lang="en-US" dirty="0"/>
+            <a:endParaRPr lang="en-US" sz="1250" dirty="0"/>
           </a:p>
         </p:txBody>
       </p:sp>
       <p:sp>
         <p:nvSpPr>
-          <p:cNvPr id="4" name="Text 2"/>
-          <p:cNvSpPr/>
+          <p:cNvPr id="4" name="Footnote"/>
+          <p:cNvSpPr txBox="1"/>
           <p:nvPr/>
         </p:nvSpPr>
         <p:spPr>
           <a:xfrm>
-            <a:off x="0" y="0"/>
-            <a:ext cx="6858000" cy="0"/>
+            <a:off x="0" y="4791456"/>
+            <a:ext cx="7863840" cy="356616"/>
           </a:xfrm>
           <a:prstGeom prst="rect">
             <a:avLst/>
@@ -6463,32 +6077,38 @@
           <a:ln/>
         </p:spPr>
         <p:txBody>
-          <a:bodyPr wrap="square" rtlCol="0"/>
+          <a:bodyPr wrap="square" lIns="91440" tIns="91440" rIns="91440" bIns="91440" rtlCol="0" anchor="ctr"/>
           <a:lstStyle/>
           <a:p>
-            <a:pPr indent="0" marL="0">
+            <a:pPr algn="l" indent="0" marL="0">
               <a:buNone/>
             </a:pPr>
             <a:r>
-              <a:rPr lang="en-US" b="1" u="sng" dirty="0">
+              <a:rPr lang="en-US" sz="800" b="1" u="sng" dirty="0">
                 <a:solidFill>
                   <a:srgbClr val="000000"/>
                 </a:solidFill>
+                <a:latin typeface="Arial" pitchFamily="34" charset="0"/>
+                <a:ea typeface="Arial" pitchFamily="34" charset="-122"/>
+                <a:cs typeface="Arial" pitchFamily="34" charset="-120"/>
               </a:rPr>
               <a:t>*1</a:t>
             </a:r>
-            <a:pPr indent="0" marL="0">
+            <a:pPr algn="l" indent="0" marL="0">
               <a:buNone/>
             </a:pPr>
             <a:r>
-              <a:rPr lang="en-US" dirty="0">
+              <a:rPr lang="en-US" sz="800" dirty="0">
                 <a:solidFill>
                   <a:srgbClr val="000000"/>
                 </a:solidFill>
+                <a:latin typeface="Arial" pitchFamily="34" charset="0"/>
+                <a:ea typeface="Arial" pitchFamily="34" charset="-122"/>
+                <a:cs typeface="Arial" pitchFamily="34" charset="-120"/>
               </a:rPr>
               <a:t> 2-92 is last week's reference; 4-00 is this week's run, 4-03 the best of the category C setups.</a:t>
             </a:r>
-            <a:endParaRPr lang="en-US" dirty="0"/>
+            <a:endParaRPr lang="en-US" sz="800" dirty="0"/>
           </a:p>
         </p:txBody>
       </p:sp>
@@ -13039,7 +12659,7 @@
             <a:lvl1pPr>
               <a:defRPr sz="1200">
                 <a:solidFill>
-                  <a:schemeClr val="tx1"/>
+                  <a:srgbClr val="000000"/>
                 </a:solidFill>
                 <a:latin typeface="Arial"/>
                 <a:ea typeface="Arial"/>
@@ -13084,14 +12704,14 @@
       </p:grpSpPr>
       <p:sp>
         <p:nvSpPr>
-          <p:cNvPr id="2" name="Text 0"/>
-          <p:cNvSpPr/>
+          <p:cNvPr id="2" name="Title"/>
+          <p:cNvSpPr txBox="1"/>
           <p:nvPr/>
         </p:nvSpPr>
         <p:spPr>
           <a:xfrm>
-            <a:off x="0" y="0"/>
-            <a:ext cx="6858000" cy="0"/>
+            <a:off x="365760" y="182880"/>
+            <a:ext cx="8412480" cy="411480"/>
           </a:xfrm>
           <a:prstGeom prst="rect">
             <a:avLst/>
@@ -13100,30 +12720,37 @@
           <a:ln/>
         </p:spPr>
         <p:txBody>
-          <a:bodyPr wrap="square" rtlCol="0"/>
+          <a:bodyPr wrap="square" lIns="0" tIns="0" rIns="0" bIns="0" rtlCol="0" anchor="t"/>
           <a:lstStyle/>
           <a:p>
-            <a:pPr indent="0" marL="0">
+            <a:pPr algn="l" indent="0" marL="0">
               <a:buNone/>
             </a:pPr>
             <a:r>
-              <a:rPr lang="en-US" dirty="0"/>
+              <a:rPr lang="en-US" sz="2200" dirty="0">
+                <a:solidFill>
+                  <a:srgbClr val="000000"/>
+                </a:solidFill>
+                <a:latin typeface="Arial" pitchFamily="34" charset="0"/>
+                <a:ea typeface="Arial" pitchFamily="34" charset="-122"/>
+                <a:cs typeface="Arial" pitchFamily="34" charset="-120"/>
+              </a:rPr>
               <a:t>Appendix: Reasoning representation</a:t>
             </a:r>
-            <a:endParaRPr lang="en-US" dirty="0"/>
+            <a:endParaRPr lang="en-US" sz="2200" dirty="0"/>
           </a:p>
         </p:txBody>
       </p:sp>
       <p:sp>
         <p:nvSpPr>
-          <p:cNvPr id="3" name="Text 1"/>
-          <p:cNvSpPr/>
+          <p:cNvPr id="3" name="Topic"/>
+          <p:cNvSpPr txBox="1"/>
           <p:nvPr/>
         </p:nvSpPr>
         <p:spPr>
           <a:xfrm>
-            <a:off x="0" y="0"/>
-            <a:ext cx="6858000" cy="0"/>
+            <a:off x="365760" y="576072"/>
+            <a:ext cx="8412480" cy="274320"/>
           </a:xfrm>
           <a:prstGeom prst="rect">
             <a:avLst/>
@@ -13132,30 +12759,37 @@
           <a:ln/>
         </p:spPr>
         <p:txBody>
-          <a:bodyPr wrap="square" rtlCol="0"/>
+          <a:bodyPr wrap="square" lIns="0" tIns="0" rIns="0" bIns="0" rtlCol="0" anchor="t"/>
           <a:lstStyle/>
           <a:p>
-            <a:pPr indent="0" marL="0">
+            <a:pPr algn="l" indent="0" marL="0">
               <a:buNone/>
             </a:pPr>
             <a:r>
-              <a:rPr lang="en-US" dirty="0"/>
+              <a:rPr lang="en-US" sz="1250" dirty="0">
+                <a:solidFill>
+                  <a:srgbClr val="9C6B1E"/>
+                </a:solidFill>
+                <a:latin typeface="Arial" pitchFamily="34" charset="0"/>
+                <a:ea typeface="Arial" pitchFamily="34" charset="-122"/>
+                <a:cs typeface="Arial" pitchFamily="34" charset="-120"/>
+              </a:rPr>
               <a:t>Previous work</a:t>
             </a:r>
-            <a:endParaRPr lang="en-US" dirty="0"/>
+            <a:endParaRPr lang="en-US" sz="1250" dirty="0"/>
           </a:p>
         </p:txBody>
       </p:sp>
       <p:sp>
         <p:nvSpPr>
-          <p:cNvPr id="4" name="Text 2"/>
-          <p:cNvSpPr/>
+          <p:cNvPr id="4" name="Footnote"/>
+          <p:cNvSpPr txBox="1"/>
           <p:nvPr/>
         </p:nvSpPr>
         <p:spPr>
           <a:xfrm>
-            <a:off x="0" y="0"/>
-            <a:ext cx="6858000" cy="0"/>
+            <a:off x="0" y="4791456"/>
+            <a:ext cx="7863840" cy="356616"/>
           </a:xfrm>
           <a:prstGeom prst="rect">
             <a:avLst/>
@@ -13164,39 +12798,48 @@
           <a:ln/>
         </p:spPr>
         <p:txBody>
-          <a:bodyPr wrap="square" rtlCol="0"/>
+          <a:bodyPr wrap="square" lIns="91440" tIns="91440" rIns="91440" bIns="91440" rtlCol="0" anchor="ctr"/>
           <a:lstStyle/>
           <a:p>
-            <a:pPr indent="0" marL="0">
+            <a:pPr algn="l" indent="0" marL="0">
               <a:buNone/>
             </a:pPr>
             <a:r>
-              <a:rPr lang="en-US" b="1" u="sng" dirty="0">
+              <a:rPr lang="en-US" sz="800" b="1" u="sng" dirty="0">
                 <a:solidFill>
                   <a:srgbClr val="000000"/>
                 </a:solidFill>
+                <a:latin typeface="Arial" pitchFamily="34" charset="0"/>
+                <a:ea typeface="Arial" pitchFamily="34" charset="-122"/>
+                <a:cs typeface="Arial" pitchFamily="34" charset="-120"/>
               </a:rPr>
               <a:t>*1</a:t>
             </a:r>
-            <a:pPr indent="0" marL="0">
+            <a:pPr algn="l" indent="0" marL="0">
               <a:buNone/>
             </a:pPr>
             <a:r>
-              <a:rPr lang="en-US" dirty="0">
+              <a:rPr lang="en-US" sz="800" dirty="0">
                 <a:solidFill>
                   <a:srgbClr val="000000"/>
                 </a:solidFill>
+                <a:latin typeface="Arial" pitchFamily="34" charset="0"/>
+                <a:ea typeface="Arial" pitchFamily="34" charset="-122"/>
+                <a:cs typeface="Arial" pitchFamily="34" charset="-120"/>
               </a:rPr>
               <a:t> </a:t>
             </a:r>
-            <a:pPr indent="0" marL="0">
+            <a:pPr algn="l" indent="0" marL="0">
               <a:buNone/>
             </a:pPr>
             <a:r>
-              <a:rPr lang="en-US" u="sng" dirty="0">
+              <a:rPr lang="en-US" sz="800" u="sng" dirty="0">
                 <a:solidFill>
                   <a:srgbClr val="0000EE"/>
                 </a:solidFill>
+                <a:latin typeface="Arial" pitchFamily="34" charset="0"/>
+                <a:ea typeface="Arial" pitchFamily="34" charset="-122"/>
+                <a:cs typeface="Arial" pitchFamily="34" charset="-120"/>
                 <a:hlinkClick r:id="rId1" invalidUrl="" action="" tgtFrame="" tooltip="" history="1" highlightClick="0" endSnd="0">
                   <a:extLst>
                     <a:ext uri="{A12FA001-AC4F-418D-AE19-62706E023703}">
@@ -13207,7 +12850,7 @@
               </a:rPr>
               <a:t>https://github.com/torridfish/lrm/issues/6</a:t>
             </a:r>
-            <a:endParaRPr lang="en-US" dirty="0"/>
+            <a:endParaRPr lang="en-US" sz="800" dirty="0"/>
           </a:p>
         </p:txBody>
       </p:sp>
@@ -15014,7 +14657,7 @@
             <a:lvl1pPr>
               <a:defRPr sz="1200">
                 <a:solidFill>
-                  <a:schemeClr val="tx1"/>
+                  <a:srgbClr val="000000"/>
                 </a:solidFill>
                 <a:latin typeface="Arial"/>
                 <a:ea typeface="Arial"/>
@@ -15059,14 +14702,14 @@
       </p:grpSpPr>
       <p:sp>
         <p:nvSpPr>
-          <p:cNvPr id="2" name="Text 0"/>
-          <p:cNvSpPr/>
+          <p:cNvPr id="2" name="Title"/>
+          <p:cNvSpPr txBox="1"/>
           <p:nvPr/>
         </p:nvSpPr>
         <p:spPr>
           <a:xfrm>
-            <a:off x="0" y="0"/>
-            <a:ext cx="6858000" cy="0"/>
+            <a:off x="365760" y="182880"/>
+            <a:ext cx="8412480" cy="411480"/>
           </a:xfrm>
           <a:prstGeom prst="rect">
             <a:avLst/>
@@ -15075,30 +14718,37 @@
           <a:ln/>
         </p:spPr>
         <p:txBody>
-          <a:bodyPr wrap="square" rtlCol="0"/>
+          <a:bodyPr wrap="square" lIns="0" tIns="0" rIns="0" bIns="0" rtlCol="0" anchor="t"/>
           <a:lstStyle/>
           <a:p>
-            <a:pPr indent="0" marL="0">
+            <a:pPr algn="l" indent="0" marL="0">
               <a:buNone/>
             </a:pPr>
             <a:r>
-              <a:rPr lang="en-US" dirty="0"/>
+              <a:rPr lang="en-US" sz="2200" dirty="0">
+                <a:solidFill>
+                  <a:srgbClr val="000000"/>
+                </a:solidFill>
+                <a:latin typeface="Arial" pitchFamily="34" charset="0"/>
+                <a:ea typeface="Arial" pitchFamily="34" charset="-122"/>
+                <a:cs typeface="Arial" pitchFamily="34" charset="-120"/>
+              </a:rPr>
               <a:t>Backbone sharing</a:t>
             </a:r>
-            <a:endParaRPr lang="en-US" dirty="0"/>
+            <a:endParaRPr lang="en-US" sz="2200" dirty="0"/>
           </a:p>
         </p:txBody>
       </p:sp>
       <p:sp>
         <p:nvSpPr>
-          <p:cNvPr id="3" name="Text 1"/>
-          <p:cNvSpPr/>
+          <p:cNvPr id="3" name="Topic"/>
+          <p:cNvSpPr txBox="1"/>
           <p:nvPr/>
         </p:nvSpPr>
         <p:spPr>
           <a:xfrm>
-            <a:off x="0" y="0"/>
-            <a:ext cx="6858000" cy="0"/>
+            <a:off x="365760" y="576072"/>
+            <a:ext cx="8412480" cy="274320"/>
           </a:xfrm>
           <a:prstGeom prst="rect">
             <a:avLst/>
@@ -15107,30 +14757,37 @@
           <a:ln/>
         </p:spPr>
         <p:txBody>
-          <a:bodyPr wrap="square" rtlCol="0"/>
+          <a:bodyPr wrap="square" lIns="0" tIns="0" rIns="0" bIns="0" rtlCol="0" anchor="t"/>
           <a:lstStyle/>
           <a:p>
-            <a:pPr indent="0" marL="0">
+            <a:pPr algn="l" indent="0" marL="0">
               <a:buNone/>
             </a:pPr>
             <a:r>
-              <a:rPr lang="en-US" dirty="0"/>
+              <a:rPr lang="en-US" sz="1250" dirty="0">
+                <a:solidFill>
+                  <a:srgbClr val="9C6B1E"/>
+                </a:solidFill>
+                <a:latin typeface="Arial" pitchFamily="34" charset="0"/>
+                <a:ea typeface="Arial" pitchFamily="34" charset="-122"/>
+                <a:cs typeface="Arial" pitchFamily="34" charset="-120"/>
+              </a:rPr>
               <a:t>Transfusion</a:t>
             </a:r>
-            <a:endParaRPr lang="en-US" dirty="0"/>
+            <a:endParaRPr lang="en-US" sz="1250" dirty="0"/>
           </a:p>
         </p:txBody>
       </p:sp>
       <p:sp>
         <p:nvSpPr>
-          <p:cNvPr id="4" name="Text 2"/>
-          <p:cNvSpPr/>
+          <p:cNvPr id="4" name="Footnote"/>
+          <p:cNvSpPr txBox="1"/>
           <p:nvPr/>
         </p:nvSpPr>
         <p:spPr>
           <a:xfrm>
-            <a:off x="0" y="0"/>
-            <a:ext cx="6858000" cy="0"/>
+            <a:off x="0" y="4791456"/>
+            <a:ext cx="7863840" cy="356616"/>
           </a:xfrm>
           <a:prstGeom prst="rect">
             <a:avLst/>
@@ -15139,39 +14796,48 @@
           <a:ln/>
         </p:spPr>
         <p:txBody>
-          <a:bodyPr wrap="square" rtlCol="0"/>
+          <a:bodyPr wrap="square" lIns="91440" tIns="91440" rIns="91440" bIns="91440" rtlCol="0" anchor="ctr"/>
           <a:lstStyle/>
           <a:p>
-            <a:pPr indent="0" marL="0">
+            <a:pPr algn="l" indent="0" marL="0">
               <a:buNone/>
             </a:pPr>
             <a:r>
-              <a:rPr lang="en-US" b="1" u="sng" dirty="0">
+              <a:rPr lang="en-US" sz="800" b="1" u="sng" dirty="0">
                 <a:solidFill>
                   <a:srgbClr val="000000"/>
                 </a:solidFill>
+                <a:latin typeface="Arial" pitchFamily="34" charset="0"/>
+                <a:ea typeface="Arial" pitchFamily="34" charset="-122"/>
+                <a:cs typeface="Arial" pitchFamily="34" charset="-120"/>
               </a:rPr>
               <a:t>*1</a:t>
             </a:r>
-            <a:pPr indent="0" marL="0">
+            <a:pPr algn="l" indent="0" marL="0">
               <a:buNone/>
             </a:pPr>
             <a:r>
-              <a:rPr lang="en-US" dirty="0">
+              <a:rPr lang="en-US" sz="800" dirty="0">
                 <a:solidFill>
                   <a:srgbClr val="000000"/>
                 </a:solidFill>
+                <a:latin typeface="Arial" pitchFamily="34" charset="0"/>
+                <a:ea typeface="Arial" pitchFamily="34" charset="-122"/>
+                <a:cs typeface="Arial" pitchFamily="34" charset="-120"/>
               </a:rPr>
               <a:t> </a:t>
             </a:r>
-            <a:pPr indent="0" marL="0">
+            <a:pPr algn="l" indent="0" marL="0">
               <a:buNone/>
             </a:pPr>
             <a:r>
-              <a:rPr lang="en-US" u="sng" dirty="0">
+              <a:rPr lang="en-US" sz="800" u="sng" dirty="0">
                 <a:solidFill>
                   <a:srgbClr val="0000EE"/>
                 </a:solidFill>
+                <a:latin typeface="Arial" pitchFamily="34" charset="0"/>
+                <a:ea typeface="Arial" pitchFamily="34" charset="-122"/>
+                <a:cs typeface="Arial" pitchFamily="34" charset="-120"/>
                 <a:hlinkClick r:id="rId1" invalidUrl="" action="" tgtFrame="" tooltip="" history="1" highlightClick="0" endSnd="0">
                   <a:extLst>
                     <a:ext uri="{A12FA001-AC4F-418D-AE19-62706E023703}">
@@ -15182,7 +14848,7 @@
               </a:rPr>
               <a:t>https://arxiv.org/pdf/2408.11039</a:t>
             </a:r>
-            <a:endParaRPr lang="en-US" dirty="0"/>
+            <a:endParaRPr lang="en-US" sz="800" dirty="0"/>
           </a:p>
         </p:txBody>
       </p:sp>
@@ -15396,7 +15062,7 @@
             <a:lvl1pPr>
               <a:defRPr sz="1200">
                 <a:solidFill>
-                  <a:schemeClr val="tx1"/>
+                  <a:srgbClr val="000000"/>
                 </a:solidFill>
                 <a:latin typeface="Arial"/>
                 <a:ea typeface="Arial"/>
@@ -15441,14 +15107,14 @@
       </p:grpSpPr>
       <p:sp>
         <p:nvSpPr>
-          <p:cNvPr id="2" name="Text 0"/>
-          <p:cNvSpPr/>
+          <p:cNvPr id="2" name="Title"/>
+          <p:cNvSpPr txBox="1"/>
           <p:nvPr/>
         </p:nvSpPr>
         <p:spPr>
           <a:xfrm>
-            <a:off x="0" y="0"/>
-            <a:ext cx="6858000" cy="0"/>
+            <a:off x="365760" y="182880"/>
+            <a:ext cx="8412480" cy="411480"/>
           </a:xfrm>
           <a:prstGeom prst="rect">
             <a:avLst/>
@@ -15457,30 +15123,37 @@
           <a:ln/>
         </p:spPr>
         <p:txBody>
-          <a:bodyPr wrap="square" rtlCol="0"/>
+          <a:bodyPr wrap="square" lIns="0" tIns="0" rIns="0" bIns="0" rtlCol="0" anchor="t"/>
           <a:lstStyle/>
           <a:p>
-            <a:pPr indent="0" marL="0">
+            <a:pPr algn="l" indent="0" marL="0">
               <a:buNone/>
             </a:pPr>
             <a:r>
-              <a:rPr lang="en-US" dirty="0"/>
+              <a:rPr lang="en-US" sz="2200" dirty="0">
+                <a:solidFill>
+                  <a:srgbClr val="000000"/>
+                </a:solidFill>
+                <a:latin typeface="Arial" pitchFamily="34" charset="0"/>
+                <a:ea typeface="Arial" pitchFamily="34" charset="-122"/>
+                <a:cs typeface="Arial" pitchFamily="34" charset="-120"/>
+              </a:rPr>
               <a:t>Reasoning quality</a:t>
             </a:r>
-            <a:endParaRPr lang="en-US" dirty="0"/>
+            <a:endParaRPr lang="en-US" sz="2200" dirty="0"/>
           </a:p>
         </p:txBody>
       </p:sp>
       <p:sp>
         <p:nvSpPr>
-          <p:cNvPr id="3" name="Text 1"/>
-          <p:cNvSpPr/>
+          <p:cNvPr id="3" name="Topic"/>
+          <p:cNvSpPr txBox="1"/>
           <p:nvPr/>
         </p:nvSpPr>
         <p:spPr>
           <a:xfrm>
-            <a:off x="0" y="0"/>
-            <a:ext cx="6858000" cy="0"/>
+            <a:off x="365760" y="576072"/>
+            <a:ext cx="8412480" cy="274320"/>
           </a:xfrm>
           <a:prstGeom prst="rect">
             <a:avLst/>
@@ -15489,30 +15162,37 @@
           <a:ln/>
         </p:spPr>
         <p:txBody>
-          <a:bodyPr wrap="square" rtlCol="0"/>
+          <a:bodyPr wrap="square" lIns="0" tIns="0" rIns="0" bIns="0" rtlCol="0" anchor="t"/>
           <a:lstStyle/>
           <a:p>
-            <a:pPr indent="0" marL="0">
+            <a:pPr algn="l" indent="0" marL="0">
               <a:buNone/>
             </a:pPr>
             <a:r>
-              <a:rPr lang="en-US" dirty="0"/>
+              <a:rPr lang="en-US" sz="1250" dirty="0">
+                <a:solidFill>
+                  <a:srgbClr val="9C6B1E"/>
+                </a:solidFill>
+                <a:latin typeface="Arial" pitchFamily="34" charset="0"/>
+                <a:ea typeface="Arial" pitchFamily="34" charset="-122"/>
+                <a:cs typeface="Arial" pitchFamily="34" charset="-120"/>
+              </a:rPr>
               <a:t>Helpfulness (WIP)</a:t>
             </a:r>
-            <a:endParaRPr lang="en-US" dirty="0"/>
+            <a:endParaRPr lang="en-US" sz="1250" dirty="0"/>
           </a:p>
         </p:txBody>
       </p:sp>
       <p:sp>
         <p:nvSpPr>
-          <p:cNvPr id="4" name="Text 2"/>
-          <p:cNvSpPr/>
+          <p:cNvPr id="4" name="Footnote"/>
+          <p:cNvSpPr txBox="1"/>
           <p:nvPr/>
         </p:nvSpPr>
         <p:spPr>
           <a:xfrm>
-            <a:off x="0" y="0"/>
-            <a:ext cx="6858000" cy="0"/>
+            <a:off x="0" y="4791456"/>
+            <a:ext cx="7863840" cy="356616"/>
           </a:xfrm>
           <a:prstGeom prst="rect">
             <a:avLst/>
@@ -15521,39 +15201,48 @@
           <a:ln/>
         </p:spPr>
         <p:txBody>
-          <a:bodyPr wrap="square" rtlCol="0"/>
+          <a:bodyPr wrap="square" lIns="91440" tIns="91440" rIns="91440" bIns="91440" rtlCol="0" anchor="ctr"/>
           <a:lstStyle/>
           <a:p>
-            <a:pPr indent="0" marL="0">
+            <a:pPr algn="l" indent="0" marL="0">
               <a:buNone/>
             </a:pPr>
             <a:r>
-              <a:rPr lang="en-US" b="1" u="sng" dirty="0">
+              <a:rPr lang="en-US" sz="800" b="1" u="sng" dirty="0">
                 <a:solidFill>
                   <a:srgbClr val="000000"/>
                 </a:solidFill>
+                <a:latin typeface="Arial" pitchFamily="34" charset="0"/>
+                <a:ea typeface="Arial" pitchFamily="34" charset="-122"/>
+                <a:cs typeface="Arial" pitchFamily="34" charset="-120"/>
               </a:rPr>
               <a:t>*1</a:t>
             </a:r>
-            <a:pPr indent="0" marL="0">
+            <a:pPr algn="l" indent="0" marL="0">
               <a:buNone/>
             </a:pPr>
             <a:r>
-              <a:rPr lang="en-US" dirty="0">
+              <a:rPr lang="en-US" sz="800" dirty="0">
                 <a:solidFill>
                   <a:srgbClr val="000000"/>
                 </a:solidFill>
+                <a:latin typeface="Arial" pitchFamily="34" charset="0"/>
+                <a:ea typeface="Arial" pitchFamily="34" charset="-122"/>
+                <a:cs typeface="Arial" pitchFamily="34" charset="-120"/>
               </a:rPr>
               <a:t> </a:t>
             </a:r>
-            <a:pPr indent="0" marL="0">
+            <a:pPr algn="l" indent="0" marL="0">
               <a:buNone/>
             </a:pPr>
             <a:r>
-              <a:rPr lang="en-US" u="sng" dirty="0">
+              <a:rPr lang="en-US" sz="800" u="sng" dirty="0">
                 <a:solidFill>
                   <a:srgbClr val="0000EE"/>
                 </a:solidFill>
+                <a:latin typeface="Arial" pitchFamily="34" charset="0"/>
+                <a:ea typeface="Arial" pitchFamily="34" charset="-122"/>
+                <a:cs typeface="Arial" pitchFamily="34" charset="-120"/>
                 <a:hlinkClick r:id="rId1" invalidUrl="" action="" tgtFrame="" tooltip="" history="1" highlightClick="0" endSnd="0">
                   <a:extLst>
                     <a:ext uri="{A12FA001-AC4F-418D-AE19-62706E023703}">
@@ -15564,7 +15253,7 @@
               </a:rPr>
               <a:t>https://arxiv.org/abs/2505.05470</a:t>
             </a:r>
-            <a:endParaRPr lang="en-US" dirty="0"/>
+            <a:endParaRPr lang="en-US" sz="800" dirty="0"/>
           </a:p>
         </p:txBody>
       </p:sp>
@@ -15875,7 +15564,7 @@
             <a:lvl1pPr>
               <a:defRPr sz="1200">
                 <a:solidFill>
-                  <a:schemeClr val="tx1"/>
+                  <a:srgbClr val="000000"/>
                 </a:solidFill>
                 <a:latin typeface="Arial"/>
                 <a:ea typeface="Arial"/>

</xml_diff>

<commit_message>
feat(research-slides): add Marp markdown pipeline before the slide-maker rewrite
Snapshot of the skill before it becomes slide-maker: the Marp theme, engine and
slides.sh (KaTeX math, per-slide footnotes, figure rows, table roles, code
blocks), transparent 800-dpi tex2img output, versioned LibreOffice detection,
and the pending deck.js / design-system edits.
</commit_message>
<xml_diff>
--- a/agents/.agents/skills/research-slides/assets/research-slides-template.pptx
+++ b/agents/.agents/skills/research-slides/assets/research-slides-template.pptx
@@ -121,10 +121,10 @@
   <p:extLst>
     <p:ext uri="{521415D9-36F7-43E2-AB2F-B90AF26B5E84}">
       <p14:sectionLst xmlns:p14="http://schemas.microsoft.com/office/powerpoint/2010/main">
-        <p14:section name="Templates" id="{e547fee6-67e7-8e17-fddc-e417c2337ab3}">
+        <p14:section name="Templates" id="{74da7f44-836c-b97c-ba86-e1841c6fd802}">
           <p14:sldIdLst/>
         </p14:section>
-        <p14:section name="Default-1" id="{0e0066a8-0bd3-490c-7603-a8bb4e3f8250}">
+        <p14:section name="Default-1" id="{bd91bf3c-cc33-0329-eb53-8ddcf4ed30f6}">
           <p14:sldIdLst>
             <p14:sldId id="256"/>
             <p14:sldId id="257"/>
@@ -547,7 +547,7 @@
           <a:p>
             <a:r>
               <a:rPr lang="en-US" dirty="0"/>
-              <a:t>CoverSlide: photo under veil (78% white), cover-title 26pt bold, cover-subtitle 14pt bold Times New Roman in ink-muted. Date form: Oct. 28, 2026. No slide number.</a:t>
+              <a:t>CoverSlide: photo under veil (78% white), cover-title 26pt bold, cover-subtitle 14pt bold Arial in ink-muted. Date form: Oct. 28, 2026. No slide number.</a:t>
             </a:r>
             <a:endParaRPr lang="en-US" dirty="0"/>
           </a:p>
@@ -1075,7 +1075,7 @@
           <a:p>
             <a:r>
               <a:rPr lang="en-US" dirty="0"/>
-              <a:t>TodoSlide: title TODO, a dated dash list in Arial 12pt with a 0.075in inset; bold the blocking item; ➔ for what follows. No figure, no table.</a:t>
+              <a:t>TodoSlide: title TODO, a dated dash list in Times New Roman 12pt with a 0.075in inset; bold the blocking item; ➔ for what follows. No figure, no table.</a:t>
             </a:r>
             <a:endParaRPr lang="en-US" dirty="0"/>
           </a:p>
@@ -1691,7 +1691,7 @@
           <a:p>
             <a:r>
               <a:rPr lang="en-US" dirty="0"/>
-              <a:t>PaperSlide: area as title, paper as topic, typed-dash notes in Arial 12pt with a 0.075in inset, the paper's own figures in the body, arXiv link as *1. Figures never climb beside the title.</a:t>
+              <a:t>PaperSlide: area as title, paper as topic, typed-dash notes in Times New Roman 12pt with a 0.075in inset, the paper's own figures in the body, arXiv link as *1. Figures never climb beside the title.</a:t>
             </a:r>
             <a:endParaRPr lang="en-US" dirty="0"/>
           </a:p>
@@ -1997,9 +1997,9 @@
                 <a:solidFill>
                   <a:srgbClr val="000000"/>
                 </a:solidFill>
-                <a:latin typeface="Arial"/>
-                <a:ea typeface="Arial"/>
-                <a:cs typeface="Arial"/>
+                <a:latin typeface="Times New Roman"/>
+                <a:ea typeface="Times New Roman"/>
+                <a:cs typeface="Times New Roman"/>
               </a:defRPr>
             </a:lvl1pPr>
           </a:lstStyle>
@@ -2077,9 +2077,9 @@
                 <a:solidFill>
                   <a:srgbClr val="000000"/>
                 </a:solidFill>
-                <a:latin typeface="Arial"/>
-                <a:ea typeface="Arial"/>
-                <a:cs typeface="Arial"/>
+                <a:latin typeface="Times New Roman"/>
+                <a:ea typeface="Times New Roman"/>
+                <a:cs typeface="Times New Roman"/>
               </a:defRPr>
             </a:lvl1pPr>
           </a:lstStyle>
@@ -2180,9 +2180,9 @@
                 <a:solidFill>
                   <a:srgbClr val="000000"/>
                 </a:solidFill>
-                <a:latin typeface="Arial"/>
-                <a:ea typeface="Arial"/>
-                <a:cs typeface="Arial"/>
+                <a:latin typeface="Times New Roman"/>
+                <a:ea typeface="Times New Roman"/>
+                <a:cs typeface="Times New Roman"/>
               </a:defRPr>
             </a:lvl1pPr>
           </a:lstStyle>
@@ -2283,9 +2283,9 @@
                 <a:solidFill>
                   <a:srgbClr val="000000"/>
                 </a:solidFill>
-                <a:latin typeface="Arial"/>
-                <a:ea typeface="Arial"/>
-                <a:cs typeface="Arial"/>
+                <a:latin typeface="Times New Roman"/>
+                <a:ea typeface="Times New Roman"/>
+                <a:cs typeface="Times New Roman"/>
               </a:defRPr>
             </a:lvl1pPr>
           </a:lstStyle>
@@ -2356,9 +2356,9 @@
                 <a:solidFill>
                   <a:srgbClr val="000000"/>
                 </a:solidFill>
-                <a:latin typeface="Arial"/>
-                <a:ea typeface="Arial"/>
-                <a:cs typeface="Arial"/>
+                <a:latin typeface="Times New Roman"/>
+                <a:ea typeface="Times New Roman"/>
+                <a:cs typeface="Times New Roman"/>
               </a:defRPr>
             </a:lvl1pPr>
           </a:lstStyle>
@@ -2722,9 +2722,9 @@
                 <a:solidFill>
                   <a:srgbClr val="595959"/>
                 </a:solidFill>
-                <a:latin typeface="Times New Roman" pitchFamily="34" charset="0"/>
-                <a:ea typeface="Times New Roman" pitchFamily="34" charset="-122"/>
-                <a:cs typeface="Times New Roman" pitchFamily="34" charset="-120"/>
+                <a:latin typeface="Arial" pitchFamily="34" charset="0"/>
+                <a:ea typeface="Arial" pitchFamily="34" charset="-122"/>
+                <a:cs typeface="Arial" pitchFamily="34" charset="-120"/>
               </a:rPr>
               <a:t>Woven Anypoint Project</a:t>
             </a:r>
@@ -2739,9 +2739,9 @@
                 <a:solidFill>
                   <a:srgbClr val="595959"/>
                 </a:solidFill>
-                <a:latin typeface="Times New Roman" pitchFamily="34" charset="0"/>
-                <a:ea typeface="Times New Roman" pitchFamily="34" charset="-122"/>
-                <a:cs typeface="Times New Roman" pitchFamily="34" charset="-120"/>
+                <a:latin typeface="Arial" pitchFamily="34" charset="0"/>
+                <a:ea typeface="Arial" pitchFamily="34" charset="-122"/>
+                <a:cs typeface="Arial" pitchFamily="34" charset="-120"/>
               </a:rPr>
               <a:t>Oct. 28, 2026</a:t>
             </a:r>
@@ -2881,9 +2881,9 @@
                 <a:solidFill>
                   <a:srgbClr val="000000"/>
                 </a:solidFill>
-                <a:latin typeface="Arial" pitchFamily="34" charset="0"/>
-                <a:ea typeface="Arial" pitchFamily="34" charset="-122"/>
-                <a:cs typeface="Arial" pitchFamily="34" charset="-120"/>
+                <a:latin typeface="Times New Roman" pitchFamily="34" charset="0"/>
+                <a:ea typeface="Times New Roman" pitchFamily="34" charset="-122"/>
+                <a:cs typeface="Times New Roman" pitchFamily="34" charset="-120"/>
               </a:rPr>
               <a:t>*1</a:t>
             </a:r>
@@ -2895,9 +2895,9 @@
                 <a:solidFill>
                   <a:srgbClr val="000000"/>
                 </a:solidFill>
-                <a:latin typeface="Arial" pitchFamily="34" charset="0"/>
-                <a:ea typeface="Arial" pitchFamily="34" charset="-122"/>
-                <a:cs typeface="Arial" pitchFamily="34" charset="-120"/>
+                <a:latin typeface="Times New Roman" pitchFamily="34" charset="0"/>
+                <a:ea typeface="Times New Roman" pitchFamily="34" charset="-122"/>
+                <a:cs typeface="Times New Roman" pitchFamily="34" charset="-120"/>
               </a:rPr>
               <a:t> </a:t>
             </a:r>
@@ -2909,9 +2909,9 @@
                 <a:solidFill>
                   <a:srgbClr val="0000EE"/>
                 </a:solidFill>
-                <a:latin typeface="Arial" pitchFamily="34" charset="0"/>
-                <a:ea typeface="Arial" pitchFamily="34" charset="-122"/>
-                <a:cs typeface="Arial" pitchFamily="34" charset="-120"/>
+                <a:latin typeface="Times New Roman" pitchFamily="34" charset="0"/>
+                <a:ea typeface="Times New Roman" pitchFamily="34" charset="-122"/>
+                <a:cs typeface="Times New Roman" pitchFamily="34" charset="-120"/>
                 <a:hlinkClick r:id="rId1" invalidUrl="" action="" tgtFrame="" tooltip="" history="1" highlightClick="0" endSnd="0">
                   <a:extLst>
                     <a:ext uri="{A12FA001-AC4F-418D-AE19-62706E023703}">
@@ -3147,9 +3147,9 @@
                 <a:solidFill>
                   <a:srgbClr val="000000"/>
                 </a:solidFill>
-                <a:latin typeface="Arial"/>
-                <a:ea typeface="Arial"/>
-                <a:cs typeface="Arial"/>
+                <a:latin typeface="Times New Roman"/>
+                <a:ea typeface="Times New Roman"/>
+                <a:cs typeface="Times New Roman"/>
               </a:defRPr>
             </a:lvl1pPr>
           </a:lstStyle>
@@ -3334,9 +3334,9 @@
                 <a:solidFill>
                   <a:srgbClr val="000000"/>
                 </a:solidFill>
-                <a:latin typeface="Arial" pitchFamily="34" charset="0"/>
-                <a:ea typeface="Arial" pitchFamily="34" charset="-122"/>
-                <a:cs typeface="Arial" pitchFamily="34" charset="-120"/>
+                <a:latin typeface="Times New Roman" pitchFamily="34" charset="0"/>
+                <a:ea typeface="Times New Roman" pitchFamily="34" charset="-122"/>
+                <a:cs typeface="Times New Roman" pitchFamily="34" charset="-120"/>
               </a:rPr>
               <a:t>*1</a:t>
             </a:r>
@@ -3348,9 +3348,9 @@
                 <a:solidFill>
                   <a:srgbClr val="000000"/>
                 </a:solidFill>
-                <a:latin typeface="Arial" pitchFamily="34" charset="0"/>
-                <a:ea typeface="Arial" pitchFamily="34" charset="-122"/>
-                <a:cs typeface="Arial" pitchFamily="34" charset="-120"/>
+                <a:latin typeface="Times New Roman" pitchFamily="34" charset="0"/>
+                <a:ea typeface="Times New Roman" pitchFamily="34" charset="-122"/>
+                <a:cs typeface="Times New Roman" pitchFamily="34" charset="-120"/>
               </a:rPr>
               <a:t> Rendered with the local TeX Live by the research-slides skill (tex2img.sh); sources under assets/Math/.</a:t>
             </a:r>
@@ -3438,9 +3438,9 @@
                 <a:solidFill>
                   <a:srgbClr val="000000"/>
                 </a:solidFill>
-                <a:latin typeface="Arial"/>
-                <a:ea typeface="Arial"/>
-                <a:cs typeface="Arial"/>
+                <a:latin typeface="Times New Roman"/>
+                <a:ea typeface="Times New Roman"/>
+                <a:cs typeface="Times New Roman"/>
               </a:defRPr>
             </a:lvl1pPr>
           </a:lstStyle>
@@ -3642,9 +3642,9 @@
                 <a:solidFill>
                   <a:srgbClr val="000000"/>
                 </a:solidFill>
-                <a:latin typeface="Arial" pitchFamily="34" charset="0"/>
-                <a:ea typeface="Arial" pitchFamily="34" charset="-122"/>
-                <a:cs typeface="Arial" pitchFamily="34" charset="-120"/>
+                <a:latin typeface="Times New Roman" pitchFamily="34" charset="0"/>
+                <a:ea typeface="Times New Roman" pitchFamily="34" charset="-122"/>
+                <a:cs typeface="Times New Roman" pitchFamily="34" charset="-120"/>
               </a:rPr>
               <a:t>- Union + LM [REJ]: multi-positive over voxels, decision loss on logit margin (</a:t>
             </a:r>
@@ -3673,9 +3673,9 @@
                 <a:solidFill>
                   <a:srgbClr val="000000"/>
                 </a:solidFill>
-                <a:latin typeface="Arial" pitchFamily="34" charset="0"/>
-                <a:ea typeface="Arial" pitchFamily="34" charset="-122"/>
-                <a:cs typeface="Arial" pitchFamily="34" charset="-120"/>
+                <a:latin typeface="Times New Roman" pitchFamily="34" charset="0"/>
+                <a:ea typeface="Times New Roman" pitchFamily="34" charset="-122"/>
+                <a:cs typeface="Times New Roman" pitchFamily="34" charset="-120"/>
               </a:rPr>
               <a:t>)</a:t>
             </a:r>
@@ -3690,9 +3690,9 @@
                 <a:solidFill>
                   <a:srgbClr val="000000"/>
                 </a:solidFill>
-                <a:latin typeface="Arial" pitchFamily="34" charset="0"/>
-                <a:ea typeface="Arial" pitchFamily="34" charset="-122"/>
-                <a:cs typeface="Arial" pitchFamily="34" charset="-120"/>
+                <a:latin typeface="Times New Roman" pitchFamily="34" charset="0"/>
+                <a:ea typeface="Times New Roman" pitchFamily="34" charset="-122"/>
+                <a:cs typeface="Times New Roman" pitchFamily="34" charset="-120"/>
               </a:rPr>
               <a:t>- Union + head null: softmax over [null, voxels]; no-target samples ×1 (6%) and ×5 (~24%)</a:t>
             </a:r>
@@ -3707,9 +3707,9 @@
                 <a:solidFill>
                   <a:srgbClr val="000000"/>
                 </a:solidFill>
-                <a:latin typeface="Arial" pitchFamily="34" charset="0"/>
-                <a:ea typeface="Arial" pitchFamily="34" charset="-122"/>
-                <a:cs typeface="Arial" pitchFamily="34" charset="-120"/>
+                <a:latin typeface="Times New Roman" pitchFamily="34" charset="0"/>
+                <a:ea typeface="Times New Roman" pitchFamily="34" charset="-122"/>
+                <a:cs typeface="Times New Roman" pitchFamily="34" charset="-120"/>
               </a:rPr>
               <a:t>- </a:t>
             </a:r>
@@ -3724,9 +3724,9 @@
                 <a:highlight>
                   <a:srgbClr val="F9CB9C"/>
                 </a:highlight>
-                <a:latin typeface="Arial" pitchFamily="34" charset="0"/>
-                <a:ea typeface="Arial" pitchFamily="34" charset="-122"/>
-                <a:cs typeface="Arial" pitchFamily="34" charset="-120"/>
+                <a:latin typeface="Times New Roman" pitchFamily="34" charset="0"/>
+                <a:ea typeface="Times New Roman" pitchFamily="34" charset="-122"/>
+                <a:cs typeface="Times New Roman" pitchFamily="34" charset="-120"/>
               </a:rPr>
               <a:t>⤷ 4-03</a:t>
             </a:r>
@@ -3738,9 +3738,9 @@
                 <a:solidFill>
                   <a:srgbClr val="000000"/>
                 </a:solidFill>
-                <a:latin typeface="Arial" pitchFamily="34" charset="0"/>
-                <a:ea typeface="Arial" pitchFamily="34" charset="-122"/>
-                <a:cs typeface="Arial" pitchFamily="34" charset="-120"/>
+                <a:latin typeface="Times New Roman" pitchFamily="34" charset="0"/>
+                <a:ea typeface="Times New Roman" pitchFamily="34" charset="-122"/>
+                <a:cs typeface="Times New Roman" pitchFamily="34" charset="-120"/>
               </a:rPr>
               <a:t> is the best of the category C setups on ScanRefer Acc@0.25</a:t>
             </a:r>
@@ -3755,9 +3755,9 @@
                 <a:solidFill>
                   <a:srgbClr val="000000"/>
                 </a:solidFill>
-                <a:latin typeface="Arial" pitchFamily="34" charset="0"/>
-                <a:ea typeface="Arial" pitchFamily="34" charset="-122"/>
-                <a:cs typeface="Arial" pitchFamily="34" charset="-120"/>
+                <a:latin typeface="Times New Roman" pitchFamily="34" charset="0"/>
+                <a:ea typeface="Times New Roman" pitchFamily="34" charset="-122"/>
+                <a:cs typeface="Times New Roman" pitchFamily="34" charset="-120"/>
               </a:rPr>
               <a:t>➔ Next: train the </a:t>
             </a:r>
@@ -3769,9 +3769,9 @@
                 <a:solidFill>
                   <a:srgbClr val="000000"/>
                 </a:solidFill>
-                <a:latin typeface="Arial" pitchFamily="34" charset="0"/>
-                <a:ea typeface="Arial" pitchFamily="34" charset="-122"/>
-                <a:cs typeface="Arial" pitchFamily="34" charset="-120"/>
+                <a:latin typeface="Times New Roman" pitchFamily="34" charset="0"/>
+                <a:ea typeface="Times New Roman" pitchFamily="34" charset="-122"/>
+                <a:cs typeface="Times New Roman" pitchFamily="34" charset="-120"/>
               </a:rPr>
               <a:t>task-agnostic proposal</a:t>
             </a:r>
@@ -3783,9 +3783,9 @@
                 <a:solidFill>
                   <a:srgbClr val="000000"/>
                 </a:solidFill>
-                <a:latin typeface="Arial" pitchFamily="34" charset="0"/>
-                <a:ea typeface="Arial" pitchFamily="34" charset="-122"/>
-                <a:cs typeface="Arial" pitchFamily="34" charset="-120"/>
+                <a:latin typeface="Times New Roman" pitchFamily="34" charset="0"/>
+                <a:ea typeface="Times New Roman" pitchFamily="34" charset="-122"/>
+                <a:cs typeface="Times New Roman" pitchFamily="34" charset="-120"/>
               </a:rPr>
               <a:t> part only, benchmark on ScanNet200 against CLASP and Mask3D</a:t>
             </a:r>
@@ -3800,9 +3800,9 @@
                 <a:solidFill>
                   <a:srgbClr val="000000"/>
                 </a:solidFill>
-                <a:latin typeface="Arial" pitchFamily="34" charset="0"/>
-                <a:ea typeface="Arial" pitchFamily="34" charset="-122"/>
-                <a:cs typeface="Arial" pitchFamily="34" charset="-120"/>
+                <a:latin typeface="Times New Roman" pitchFamily="34" charset="0"/>
+                <a:ea typeface="Times New Roman" pitchFamily="34" charset="-122"/>
+                <a:cs typeface="Times New Roman" pitchFamily="34" charset="-120"/>
               </a:rPr>
               <a:t>➔ </a:t>
             </a:r>
@@ -3814,9 +3814,9 @@
                 <a:solidFill>
                   <a:srgbClr val="CC0000"/>
                 </a:solidFill>
-                <a:latin typeface="Arial" pitchFamily="34" charset="0"/>
-                <a:ea typeface="Arial" pitchFamily="34" charset="-122"/>
-                <a:cs typeface="Arial" pitchFamily="34" charset="-120"/>
+                <a:latin typeface="Times New Roman" pitchFamily="34" charset="0"/>
+                <a:ea typeface="Times New Roman" pitchFamily="34" charset="-122"/>
+                <a:cs typeface="Times New Roman" pitchFamily="34" charset="-120"/>
               </a:rPr>
               <a:t>Disk炸滿了，why</a:t>
             </a:r>
@@ -3828,9 +3828,9 @@
                 <a:solidFill>
                   <a:srgbClr val="000000"/>
                 </a:solidFill>
-                <a:latin typeface="Arial" pitchFamily="34" charset="0"/>
-                <a:ea typeface="Arial" pitchFamily="34" charset="-122"/>
-                <a:cs typeface="Arial" pitchFamily="34" charset="-120"/>
+                <a:latin typeface="Times New Roman" pitchFamily="34" charset="0"/>
+                <a:ea typeface="Times New Roman" pitchFamily="34" charset="-122"/>
+                <a:cs typeface="Times New Roman" pitchFamily="34" charset="-120"/>
               </a:rPr>
               <a:t> — clean </a:t>
             </a:r>
@@ -3859,9 +3859,9 @@
                 <a:solidFill>
                   <a:srgbClr val="000000"/>
                 </a:solidFill>
-                <a:latin typeface="Arial" pitchFamily="34" charset="0"/>
-                <a:ea typeface="Arial" pitchFamily="34" charset="-122"/>
-                <a:cs typeface="Arial" pitchFamily="34" charset="-120"/>
+                <a:latin typeface="Times New Roman" pitchFamily="34" charset="0"/>
+                <a:ea typeface="Times New Roman" pitchFamily="34" charset="-122"/>
+                <a:cs typeface="Times New Roman" pitchFamily="34" charset="-120"/>
               </a:rPr>
               <a:t> after merging its GT-mask keys</a:t>
             </a:r>
@@ -3901,9 +3901,9 @@
                 <a:solidFill>
                   <a:srgbClr val="000000"/>
                 </a:solidFill>
-                <a:latin typeface="Arial"/>
-                <a:ea typeface="Arial"/>
-                <a:cs typeface="Arial"/>
+                <a:latin typeface="Times New Roman"/>
+                <a:ea typeface="Times New Roman"/>
+                <a:cs typeface="Times New Roman"/>
               </a:defRPr>
             </a:lvl1pPr>
           </a:lstStyle>
@@ -4424,9 +4424,9 @@
                 <a:solidFill>
                   <a:srgbClr val="000000"/>
                 </a:solidFill>
-                <a:latin typeface="Arial"/>
-                <a:ea typeface="Arial"/>
-                <a:cs typeface="Arial"/>
+                <a:latin typeface="Times New Roman"/>
+                <a:ea typeface="Times New Roman"/>
+                <a:cs typeface="Times New Roman"/>
               </a:defRPr>
             </a:lvl1pPr>
           </a:lstStyle>
@@ -4572,9 +4572,9 @@
                 <a:solidFill>
                   <a:srgbClr val="000000"/>
                 </a:solidFill>
-                <a:latin typeface="Arial" pitchFamily="34" charset="0"/>
-                <a:ea typeface="Arial" pitchFamily="34" charset="-122"/>
-                <a:cs typeface="Arial" pitchFamily="34" charset="-120"/>
+                <a:latin typeface="Times New Roman" pitchFamily="34" charset="0"/>
+                <a:ea typeface="Times New Roman" pitchFamily="34" charset="-122"/>
+                <a:cs typeface="Times New Roman" pitchFamily="34" charset="-120"/>
               </a:rPr>
               <a:t>*1</a:t>
             </a:r>
@@ -4586,9 +4586,9 @@
                 <a:solidFill>
                   <a:srgbClr val="000000"/>
                 </a:solidFill>
-                <a:latin typeface="Arial" pitchFamily="34" charset="0"/>
-                <a:ea typeface="Arial" pitchFamily="34" charset="-122"/>
-                <a:cs typeface="Arial" pitchFamily="34" charset="-120"/>
+                <a:latin typeface="Times New Roman" pitchFamily="34" charset="0"/>
+                <a:ea typeface="Times New Roman" pitchFamily="34" charset="-122"/>
+                <a:cs typeface="Times New Roman" pitchFamily="34" charset="-120"/>
               </a:rPr>
               <a:t> → means the difference from the base run.</a:t>
             </a:r>
@@ -4637,7 +4637,7 @@
       </p:sp>
       <p:pic>
         <p:nvPicPr>
-          <p:cNvPr id="7" name="Run matrix for the category B setups" descr="/tmp/claude-1000/-home-torridfish-Downloads-slides/120c0694-8c40-4ae3-895f-f20aa4908c6d/scratchpad/ds/project/assets/Figures/run-table-category-b.png">    </p:cNvPr>
+          <p:cNvPr id="7" name="Run matrix for the category B setups" descr="/home/torridfish/Downloads/slides/research-slides/project/assets/Diagrams/research-slides-diagram-kit.png">    </p:cNvPr>
           <p:cNvPicPr>
             <a:picLocks noChangeAspect="1"/>
           </p:cNvPicPr>
@@ -4757,9 +4757,9 @@
                 <a:solidFill>
                   <a:srgbClr val="000000"/>
                 </a:solidFill>
-                <a:latin typeface="Arial"/>
-                <a:ea typeface="Arial"/>
-                <a:cs typeface="Arial"/>
+                <a:latin typeface="Times New Roman"/>
+                <a:ea typeface="Times New Roman"/>
+                <a:cs typeface="Times New Roman"/>
               </a:defRPr>
             </a:lvl1pPr>
           </a:lstStyle>
@@ -4905,9 +4905,9 @@
                 <a:solidFill>
                   <a:srgbClr val="000000"/>
                 </a:solidFill>
-                <a:latin typeface="Arial" pitchFamily="34" charset="0"/>
-                <a:ea typeface="Arial" pitchFamily="34" charset="-122"/>
-                <a:cs typeface="Arial" pitchFamily="34" charset="-120"/>
+                <a:latin typeface="Times New Roman" pitchFamily="34" charset="0"/>
+                <a:ea typeface="Times New Roman" pitchFamily="34" charset="-122"/>
+                <a:cs typeface="Times New Roman" pitchFamily="34" charset="-120"/>
               </a:rPr>
               <a:t>- 08/31 – 09/03: AMD HPC under maintenance</a:t>
             </a:r>
@@ -4922,9 +4922,9 @@
                 <a:solidFill>
                   <a:srgbClr val="000000"/>
                 </a:solidFill>
-                <a:latin typeface="Arial" pitchFamily="34" charset="0"/>
-                <a:ea typeface="Arial" pitchFamily="34" charset="-122"/>
-                <a:cs typeface="Arial" pitchFamily="34" charset="-120"/>
+                <a:latin typeface="Times New Roman" pitchFamily="34" charset="0"/>
+                <a:ea typeface="Times New Roman" pitchFamily="34" charset="-122"/>
+                <a:cs typeface="Times New Roman" pitchFamily="34" charset="-120"/>
               </a:rPr>
               <a:t>- </a:t>
             </a:r>
@@ -4936,9 +4936,9 @@
                 <a:solidFill>
                   <a:srgbClr val="000000"/>
                 </a:solidFill>
-                <a:latin typeface="Arial" pitchFamily="34" charset="0"/>
-                <a:ea typeface="Arial" pitchFamily="34" charset="-122"/>
-                <a:cs typeface="Arial" pitchFamily="34" charset="-120"/>
+                <a:latin typeface="Times New Roman" pitchFamily="34" charset="0"/>
+                <a:ea typeface="Times New Roman" pitchFamily="34" charset="-122"/>
+                <a:cs typeface="Times New Roman" pitchFamily="34" charset="-120"/>
               </a:rPr>
               <a:t>Summarize experiment results of the new VAE</a:t>
             </a:r>
@@ -4953,9 +4953,9 @@
                 <a:solidFill>
                   <a:srgbClr val="000000"/>
                 </a:solidFill>
-                <a:latin typeface="Arial" pitchFamily="34" charset="0"/>
-                <a:ea typeface="Arial" pitchFamily="34" charset="-122"/>
-                <a:cs typeface="Arial" pitchFamily="34" charset="-120"/>
+                <a:latin typeface="Times New Roman" pitchFamily="34" charset="0"/>
+                <a:ea typeface="Times New Roman" pitchFamily="34" charset="-122"/>
+                <a:cs typeface="Times New Roman" pitchFamily="34" charset="-120"/>
               </a:rPr>
               <a:t>    - Does the VAE form a space that is good for the FM model to generate?</a:t>
             </a:r>
@@ -4970,9 +4970,9 @@
                 <a:solidFill>
                   <a:srgbClr val="000000"/>
                 </a:solidFill>
-                <a:latin typeface="Arial" pitchFamily="34" charset="0"/>
-                <a:ea typeface="Arial" pitchFamily="34" charset="-122"/>
-                <a:cs typeface="Arial" pitchFamily="34" charset="-120"/>
+                <a:latin typeface="Times New Roman" pitchFamily="34" charset="0"/>
+                <a:ea typeface="Times New Roman" pitchFamily="34" charset="-122"/>
+                <a:cs typeface="Times New Roman" pitchFamily="34" charset="-120"/>
               </a:rPr>
               <a:t>    - Does the backbone use the thoughts to solve the problem?</a:t>
             </a:r>
@@ -4987,9 +4987,9 @@
                 <a:solidFill>
                   <a:srgbClr val="000000"/>
                 </a:solidFill>
-                <a:latin typeface="Arial" pitchFamily="34" charset="0"/>
-                <a:ea typeface="Arial" pitchFamily="34" charset="-122"/>
-                <a:cs typeface="Arial" pitchFamily="34" charset="-120"/>
+                <a:latin typeface="Times New Roman" pitchFamily="34" charset="0"/>
+                <a:ea typeface="Times New Roman" pitchFamily="34" charset="-122"/>
+                <a:cs typeface="Times New Roman" pitchFamily="34" charset="-120"/>
               </a:rPr>
               <a:t>- Error-case classification (thought / generated code)</a:t>
             </a:r>
@@ -5004,9 +5004,9 @@
                 <a:solidFill>
                   <a:srgbClr val="000000"/>
                 </a:solidFill>
-                <a:latin typeface="Arial" pitchFamily="34" charset="0"/>
-                <a:ea typeface="Arial" pitchFamily="34" charset="-122"/>
-                <a:cs typeface="Arial" pitchFamily="34" charset="-120"/>
+                <a:latin typeface="Times New Roman" pitchFamily="34" charset="0"/>
+                <a:ea typeface="Times New Roman" pitchFamily="34" charset="-122"/>
+                <a:cs typeface="Times New Roman" pitchFamily="34" charset="-120"/>
               </a:rPr>
               <a:t>- Apply the new VAE with the pretrained flow_proj; ablate flow_proj</a:t>
             </a:r>
@@ -5021,9 +5021,9 @@
                 <a:solidFill>
                   <a:srgbClr val="000000"/>
                 </a:solidFill>
-                <a:latin typeface="Arial" pitchFamily="34" charset="0"/>
-                <a:ea typeface="Arial" pitchFamily="34" charset="-122"/>
-                <a:cs typeface="Arial" pitchFamily="34" charset="-120"/>
+                <a:latin typeface="Times New Roman" pitchFamily="34" charset="0"/>
+                <a:ea typeface="Times New Roman" pitchFamily="34" charset="-122"/>
+                <a:cs typeface="Times New Roman" pitchFamily="34" charset="-120"/>
               </a:rPr>
               <a:t>➔ Faithfulness interpretability on HumanEval once the machine is back</a:t>
             </a:r>
@@ -5063,9 +5063,9 @@
                 <a:solidFill>
                   <a:srgbClr val="000000"/>
                 </a:solidFill>
-                <a:latin typeface="Arial"/>
-                <a:ea typeface="Arial"/>
-                <a:cs typeface="Arial"/>
+                <a:latin typeface="Times New Roman"/>
+                <a:ea typeface="Times New Roman"/>
+                <a:cs typeface="Times New Roman"/>
               </a:defRPr>
             </a:lvl1pPr>
           </a:lstStyle>
@@ -5172,9 +5172,9 @@
                 <a:solidFill>
                   <a:srgbClr val="000000"/>
                 </a:solidFill>
-                <a:latin typeface="Arial" pitchFamily="34" charset="0"/>
-                <a:ea typeface="Arial" pitchFamily="34" charset="-122"/>
-                <a:cs typeface="Arial" pitchFamily="34" charset="-120"/>
+                <a:latin typeface="Times New Roman" pitchFamily="34" charset="0"/>
+                <a:ea typeface="Times New Roman" pitchFamily="34" charset="-122"/>
+                <a:cs typeface="Times New Roman" pitchFamily="34" charset="-120"/>
               </a:rPr>
               <a:t>*1</a:t>
             </a:r>
@@ -5186,9 +5186,9 @@
                 <a:solidFill>
                   <a:srgbClr val="000000"/>
                 </a:solidFill>
-                <a:latin typeface="Arial" pitchFamily="34" charset="0"/>
-                <a:ea typeface="Arial" pitchFamily="34" charset="-122"/>
-                <a:cs typeface="Arial" pitchFamily="34" charset="-120"/>
+                <a:latin typeface="Times New Roman" pitchFamily="34" charset="0"/>
+                <a:ea typeface="Times New Roman" pitchFamily="34" charset="-122"/>
+                <a:cs typeface="Times New Roman" pitchFamily="34" charset="-120"/>
               </a:rPr>
               <a:t> Link: </a:t>
             </a:r>
@@ -5200,9 +5200,9 @@
                 <a:solidFill>
                   <a:srgbClr val="0000EE"/>
                 </a:solidFill>
-                <a:latin typeface="Arial" pitchFamily="34" charset="0"/>
-                <a:ea typeface="Arial" pitchFamily="34" charset="-122"/>
-                <a:cs typeface="Arial" pitchFamily="34" charset="-120"/>
+                <a:latin typeface="Times New Roman" pitchFamily="34" charset="0"/>
+                <a:ea typeface="Times New Roman" pitchFamily="34" charset="-122"/>
+                <a:cs typeface="Times New Roman" pitchFamily="34" charset="-120"/>
                 <a:hlinkClick r:id="rId1" invalidUrl="" action="" tgtFrame="" tooltip="" history="1" highlightClick="0" endSnd="0">
                   <a:extLst>
                     <a:ext uri="{A12FA001-AC4F-418D-AE19-62706E023703}">
@@ -5249,9 +5249,9 @@
                 <a:solidFill>
                   <a:srgbClr val="000000"/>
                 </a:solidFill>
-                <a:latin typeface="Arial"/>
-                <a:ea typeface="Arial"/>
-                <a:cs typeface="Arial"/>
+                <a:latin typeface="Times New Roman"/>
+                <a:ea typeface="Times New Roman"/>
+                <a:cs typeface="Times New Roman"/>
               </a:defRPr>
             </a:lvl1pPr>
           </a:lstStyle>
@@ -5361,9 +5361,9 @@
                 <a:solidFill>
                   <a:srgbClr val="000000"/>
                 </a:solidFill>
-                <a:latin typeface="Arial"/>
-                <a:ea typeface="Arial"/>
-                <a:cs typeface="Arial"/>
+                <a:latin typeface="Times New Roman"/>
+                <a:ea typeface="Times New Roman"/>
+                <a:cs typeface="Times New Roman"/>
               </a:defRPr>
             </a:lvl1pPr>
           </a:lstStyle>
@@ -5565,9 +5565,9 @@
                 <a:solidFill>
                   <a:srgbClr val="000000"/>
                 </a:solidFill>
-                <a:latin typeface="Arial" pitchFamily="34" charset="0"/>
-                <a:ea typeface="Arial" pitchFamily="34" charset="-122"/>
-                <a:cs typeface="Arial" pitchFamily="34" charset="-120"/>
+                <a:latin typeface="Times New Roman" pitchFamily="34" charset="0"/>
+                <a:ea typeface="Times New Roman" pitchFamily="34" charset="-122"/>
+                <a:cs typeface="Times New Roman" pitchFamily="34" charset="-120"/>
               </a:rPr>
               <a:t>*1</a:t>
             </a:r>
@@ -5579,9 +5579,9 @@
                 <a:solidFill>
                   <a:srgbClr val="000000"/>
                 </a:solidFill>
-                <a:latin typeface="Arial" pitchFamily="34" charset="0"/>
-                <a:ea typeface="Arial" pitchFamily="34" charset="-122"/>
-                <a:cs typeface="Arial" pitchFamily="34" charset="-120"/>
+                <a:latin typeface="Times New Roman" pitchFamily="34" charset="0"/>
+                <a:ea typeface="Times New Roman" pitchFamily="34" charset="-122"/>
+                <a:cs typeface="Times New Roman" pitchFamily="34" charset="-120"/>
               </a:rPr>
               <a:t> Proposal should be scene-shared, so KV cache </a:t>
             </a:r>
@@ -5593,9 +5593,9 @@
                 <a:solidFill>
                   <a:srgbClr val="000000"/>
                 </a:solidFill>
-                <a:latin typeface="Arial" pitchFamily="34" charset="0"/>
-                <a:ea typeface="Arial" pitchFamily="34" charset="-122"/>
-                <a:cs typeface="Arial" pitchFamily="34" charset="-120"/>
+                <a:latin typeface="Times New Roman" pitchFamily="34" charset="0"/>
+                <a:ea typeface="Times New Roman" pitchFamily="34" charset="-122"/>
+                <a:cs typeface="Times New Roman" pitchFamily="34" charset="-120"/>
               </a:rPr>
               <a:t>reuse</a:t>
             </a:r>
@@ -5607,9 +5607,9 @@
                 <a:solidFill>
                   <a:srgbClr val="000000"/>
                 </a:solidFill>
-                <a:latin typeface="Arial" pitchFamily="34" charset="0"/>
-                <a:ea typeface="Arial" pitchFamily="34" charset="-122"/>
-                <a:cs typeface="Arial" pitchFamily="34" charset="-120"/>
+                <a:latin typeface="Times New Roman" pitchFamily="34" charset="0"/>
+                <a:ea typeface="Times New Roman" pitchFamily="34" charset="-122"/>
+                <a:cs typeface="Times New Roman" pitchFamily="34" charset="-120"/>
               </a:rPr>
               <a:t> here might not be the main proposal.</a:t>
             </a:r>
@@ -5673,9 +5673,9 @@
                 <a:solidFill>
                   <a:srgbClr val="000000"/>
                 </a:solidFill>
-                <a:latin typeface="Arial"/>
-                <a:ea typeface="Arial"/>
-                <a:cs typeface="Arial"/>
+                <a:latin typeface="Times New Roman"/>
+                <a:ea typeface="Times New Roman"/>
+                <a:cs typeface="Times New Roman"/>
               </a:defRPr>
             </a:lvl1pPr>
           </a:lstStyle>
@@ -5860,9 +5860,9 @@
                 <a:solidFill>
                   <a:srgbClr val="000000"/>
                 </a:solidFill>
-                <a:latin typeface="Arial" pitchFamily="34" charset="0"/>
-                <a:ea typeface="Arial" pitchFamily="34" charset="-122"/>
-                <a:cs typeface="Arial" pitchFamily="34" charset="-120"/>
+                <a:latin typeface="Times New Roman" pitchFamily="34" charset="0"/>
+                <a:ea typeface="Times New Roman" pitchFamily="34" charset="-122"/>
+                <a:cs typeface="Times New Roman" pitchFamily="34" charset="-120"/>
               </a:rPr>
               <a:t>*1</a:t>
             </a:r>
@@ -5874,9 +5874,9 @@
                 <a:solidFill>
                   <a:srgbClr val="000000"/>
                 </a:solidFill>
-                <a:latin typeface="Arial" pitchFamily="34" charset="0"/>
-                <a:ea typeface="Arial" pitchFamily="34" charset="-122"/>
-                <a:cs typeface="Arial" pitchFamily="34" charset="-120"/>
+                <a:latin typeface="Times New Roman" pitchFamily="34" charset="0"/>
+                <a:ea typeface="Times New Roman" pitchFamily="34" charset="-122"/>
+                <a:cs typeface="Times New Roman" pitchFamily="34" charset="-120"/>
               </a:rPr>
               <a:t> Source: assets/Diagrams/research-slides-diagram-kit.drawio — export with the research-slides skill: scripts/drawio-export.sh</a:t>
             </a:r>
@@ -5940,9 +5940,9 @@
                 <a:solidFill>
                   <a:srgbClr val="000000"/>
                 </a:solidFill>
-                <a:latin typeface="Arial"/>
-                <a:ea typeface="Arial"/>
-                <a:cs typeface="Arial"/>
+                <a:latin typeface="Times New Roman"/>
+                <a:ea typeface="Times New Roman"/>
+                <a:cs typeface="Times New Roman"/>
               </a:defRPr>
             </a:lvl1pPr>
           </a:lstStyle>
@@ -6088,9 +6088,9 @@
                 <a:solidFill>
                   <a:srgbClr val="000000"/>
                 </a:solidFill>
-                <a:latin typeface="Arial" pitchFamily="34" charset="0"/>
-                <a:ea typeface="Arial" pitchFamily="34" charset="-122"/>
-                <a:cs typeface="Arial" pitchFamily="34" charset="-120"/>
+                <a:latin typeface="Times New Roman" pitchFamily="34" charset="0"/>
+                <a:ea typeface="Times New Roman" pitchFamily="34" charset="-122"/>
+                <a:cs typeface="Times New Roman" pitchFamily="34" charset="-120"/>
               </a:rPr>
               <a:t>*1</a:t>
             </a:r>
@@ -6102,9 +6102,9 @@
                 <a:solidFill>
                   <a:srgbClr val="000000"/>
                 </a:solidFill>
-                <a:latin typeface="Arial" pitchFamily="34" charset="0"/>
-                <a:ea typeface="Arial" pitchFamily="34" charset="-122"/>
-                <a:cs typeface="Arial" pitchFamily="34" charset="-120"/>
+                <a:latin typeface="Times New Roman" pitchFamily="34" charset="0"/>
+                <a:ea typeface="Times New Roman" pitchFamily="34" charset="-122"/>
+                <a:cs typeface="Times New Roman" pitchFamily="34" charset="-120"/>
               </a:rPr>
               <a:t> 2-92 is last week's reference; 4-00 is this week's run, 4-03 the best of the category C setups.</a:t>
             </a:r>
@@ -6157,16 +6157,16 @@
                           <a:solidFill>
                             <a:srgbClr val="000000"/>
                           </a:solidFill>
-                          <a:latin typeface="Arial" pitchFamily="34" charset="0"/>
-                          <a:ea typeface="Arial" pitchFamily="34" charset="-122"/>
-                          <a:cs typeface="Arial" pitchFamily="34" charset="-120"/>
+                          <a:latin typeface="Times New Roman" pitchFamily="34" charset="0"/>
+                          <a:ea typeface="Times New Roman" pitchFamily="34" charset="-122"/>
+                          <a:cs typeface="Times New Roman" pitchFamily="34" charset="-120"/>
                         </a:rPr>
                         <a:t>Name</a:t>
                       </a:r>
                       <a:endParaRPr lang="en-US" sz="900" dirty="0">
-                        <a:latin typeface="Arial" charset="0"/>
-                        <a:ea typeface="Arial" charset="0"/>
-                        <a:cs typeface="Arial" charset="0"/>
+                        <a:latin typeface="Times New Roman" charset="0"/>
+                        <a:ea typeface="Times New Roman" charset="0"/>
+                        <a:cs typeface="Times New Roman" charset="0"/>
                       </a:endParaRPr>
                     </a:p>
                   </a:txBody>
@@ -6225,16 +6225,16 @@
                           <a:solidFill>
                             <a:srgbClr val="000000"/>
                           </a:solidFill>
-                          <a:latin typeface="Arial" pitchFamily="34" charset="0"/>
-                          <a:ea typeface="Arial" pitchFamily="34" charset="-122"/>
-                          <a:cs typeface="Arial" pitchFamily="34" charset="-120"/>
+                          <a:latin typeface="Times New Roman" pitchFamily="34" charset="0"/>
+                          <a:ea typeface="Times New Roman" pitchFamily="34" charset="-122"/>
+                          <a:cs typeface="Times New Roman" pitchFamily="34" charset="-120"/>
                         </a:rPr>
                         <a:t>Acc@0.25</a:t>
                       </a:r>
                       <a:endParaRPr lang="en-US" sz="900" dirty="0">
-                        <a:latin typeface="Arial" charset="0"/>
-                        <a:ea typeface="Arial" charset="0"/>
-                        <a:cs typeface="Arial" charset="0"/>
+                        <a:latin typeface="Times New Roman" charset="0"/>
+                        <a:ea typeface="Times New Roman" charset="0"/>
+                        <a:cs typeface="Times New Roman" charset="0"/>
                       </a:endParaRPr>
                     </a:p>
                   </a:txBody>
@@ -6293,16 +6293,16 @@
                           <a:solidFill>
                             <a:srgbClr val="000000"/>
                           </a:solidFill>
-                          <a:latin typeface="Arial" pitchFamily="34" charset="0"/>
-                          <a:ea typeface="Arial" pitchFamily="34" charset="-122"/>
-                          <a:cs typeface="Arial" pitchFamily="34" charset="-120"/>
+                          <a:latin typeface="Times New Roman" pitchFamily="34" charset="0"/>
+                          <a:ea typeface="Times New Roman" pitchFamily="34" charset="-122"/>
+                          <a:cs typeface="Times New Roman" pitchFamily="34" charset="-120"/>
                         </a:rPr>
                         <a:t>Acc@0.50</a:t>
                       </a:r>
                       <a:endParaRPr lang="en-US" sz="900" dirty="0">
-                        <a:latin typeface="Arial" charset="0"/>
-                        <a:ea typeface="Arial" charset="0"/>
-                        <a:cs typeface="Arial" charset="0"/>
+                        <a:latin typeface="Times New Roman" charset="0"/>
+                        <a:ea typeface="Times New Roman" charset="0"/>
+                        <a:cs typeface="Times New Roman" charset="0"/>
                       </a:endParaRPr>
                     </a:p>
                   </a:txBody>
@@ -6361,16 +6361,16 @@
                           <a:solidFill>
                             <a:srgbClr val="000000"/>
                           </a:solidFill>
-                          <a:latin typeface="Arial" pitchFamily="34" charset="0"/>
-                          <a:ea typeface="Arial" pitchFamily="34" charset="-122"/>
-                          <a:cs typeface="Arial" pitchFamily="34" charset="-120"/>
+                          <a:latin typeface="Times New Roman" pitchFamily="34" charset="0"/>
+                          <a:ea typeface="Times New Roman" pitchFamily="34" charset="-122"/>
+                          <a:cs typeface="Times New Roman" pitchFamily="34" charset="-120"/>
                         </a:rPr>
                         <a:t>Multiple Acc@0.25</a:t>
                       </a:r>
                       <a:endParaRPr lang="en-US" sz="900" dirty="0">
-                        <a:latin typeface="Arial" charset="0"/>
-                        <a:ea typeface="Arial" charset="0"/>
-                        <a:cs typeface="Arial" charset="0"/>
+                        <a:latin typeface="Times New Roman" charset="0"/>
+                        <a:ea typeface="Times New Roman" charset="0"/>
+                        <a:cs typeface="Times New Roman" charset="0"/>
                       </a:endParaRPr>
                     </a:p>
                   </a:txBody>
@@ -6429,16 +6429,16 @@
                           <a:solidFill>
                             <a:srgbClr val="000000"/>
                           </a:solidFill>
-                          <a:latin typeface="Arial" pitchFamily="34" charset="0"/>
-                          <a:ea typeface="Arial" pitchFamily="34" charset="-122"/>
-                          <a:cs typeface="Arial" pitchFamily="34" charset="-120"/>
+                          <a:latin typeface="Times New Roman" pitchFamily="34" charset="0"/>
+                          <a:ea typeface="Times New Roman" pitchFamily="34" charset="-122"/>
+                          <a:cs typeface="Times New Roman" pitchFamily="34" charset="-120"/>
                         </a:rPr>
                         <a:t>Multiple Acc@0.50</a:t>
                       </a:r>
                       <a:endParaRPr lang="en-US" sz="900" dirty="0">
-                        <a:latin typeface="Arial" charset="0"/>
-                        <a:ea typeface="Arial" charset="0"/>
-                        <a:cs typeface="Arial" charset="0"/>
+                        <a:latin typeface="Times New Roman" charset="0"/>
+                        <a:ea typeface="Times New Roman" charset="0"/>
+                        <a:cs typeface="Times New Roman" charset="0"/>
                       </a:endParaRPr>
                     </a:p>
                   </a:txBody>
@@ -6497,16 +6497,16 @@
                           <a:solidFill>
                             <a:srgbClr val="000000"/>
                           </a:solidFill>
-                          <a:latin typeface="Arial" pitchFamily="34" charset="0"/>
-                          <a:ea typeface="Arial" pitchFamily="34" charset="-122"/>
-                          <a:cs typeface="Arial" pitchFamily="34" charset="-120"/>
+                          <a:latin typeface="Times New Roman" pitchFamily="34" charset="0"/>
+                          <a:ea typeface="Times New Roman" pitchFamily="34" charset="-122"/>
+                          <a:cs typeface="Times New Roman" pitchFamily="34" charset="-120"/>
                         </a:rPr>
                         <a:t>Unique Acc@0.25</a:t>
                       </a:r>
                       <a:endParaRPr lang="en-US" sz="900" dirty="0">
-                        <a:latin typeface="Arial" charset="0"/>
-                        <a:ea typeface="Arial" charset="0"/>
-                        <a:cs typeface="Arial" charset="0"/>
+                        <a:latin typeface="Times New Roman" charset="0"/>
+                        <a:ea typeface="Times New Roman" charset="0"/>
+                        <a:cs typeface="Times New Roman" charset="0"/>
                       </a:endParaRPr>
                     </a:p>
                   </a:txBody>
@@ -6565,16 +6565,16 @@
                           <a:solidFill>
                             <a:srgbClr val="000000"/>
                           </a:solidFill>
-                          <a:latin typeface="Arial" pitchFamily="34" charset="0"/>
-                          <a:ea typeface="Arial" pitchFamily="34" charset="-122"/>
-                          <a:cs typeface="Arial" pitchFamily="34" charset="-120"/>
+                          <a:latin typeface="Times New Roman" pitchFamily="34" charset="0"/>
+                          <a:ea typeface="Times New Roman" pitchFamily="34" charset="-122"/>
+                          <a:cs typeface="Times New Roman" pitchFamily="34" charset="-120"/>
                         </a:rPr>
                         <a:t>Unique Acc@0.50</a:t>
                       </a:r>
                       <a:endParaRPr lang="en-US" sz="900" dirty="0">
-                        <a:latin typeface="Arial" charset="0"/>
-                        <a:ea typeface="Arial" charset="0"/>
-                        <a:cs typeface="Arial" charset="0"/>
+                        <a:latin typeface="Times New Roman" charset="0"/>
+                        <a:ea typeface="Times New Roman" charset="0"/>
+                        <a:cs typeface="Times New Roman" charset="0"/>
                       </a:endParaRPr>
                     </a:p>
                   </a:txBody>
@@ -6635,16 +6635,16 @@
                           <a:solidFill>
                             <a:srgbClr val="000000"/>
                           </a:solidFill>
-                          <a:latin typeface="Arial" pitchFamily="34" charset="0"/>
-                          <a:ea typeface="Arial" pitchFamily="34" charset="-122"/>
-                          <a:cs typeface="Arial" pitchFamily="34" charset="-120"/>
+                          <a:latin typeface="Times New Roman" pitchFamily="34" charset="0"/>
+                          <a:ea typeface="Times New Roman" pitchFamily="34" charset="-122"/>
+                          <a:cs typeface="Times New Roman" pitchFamily="34" charset="-120"/>
                         </a:rPr>
                         <a:t>2-92</a:t>
                       </a:r>
                       <a:endParaRPr lang="en-US" sz="900" dirty="0">
-                        <a:latin typeface="Arial" charset="0"/>
-                        <a:ea typeface="Arial" charset="0"/>
-                        <a:cs typeface="Arial" charset="0"/>
+                        <a:latin typeface="Times New Roman" charset="0"/>
+                        <a:ea typeface="Times New Roman" charset="0"/>
+                        <a:cs typeface="Times New Roman" charset="0"/>
                       </a:endParaRPr>
                     </a:p>
                   </a:txBody>
@@ -6703,16 +6703,16 @@
                           <a:solidFill>
                             <a:srgbClr val="000000"/>
                           </a:solidFill>
-                          <a:latin typeface="Arial" pitchFamily="34" charset="0"/>
-                          <a:ea typeface="Arial" pitchFamily="34" charset="-122"/>
-                          <a:cs typeface="Arial" pitchFamily="34" charset="-120"/>
+                          <a:latin typeface="Times New Roman" pitchFamily="34" charset="0"/>
+                          <a:ea typeface="Times New Roman" pitchFamily="34" charset="-122"/>
+                          <a:cs typeface="Times New Roman" pitchFamily="34" charset="-120"/>
                         </a:rPr>
                         <a:t>0.5505</a:t>
                       </a:r>
                       <a:endParaRPr lang="en-US" sz="900" dirty="0">
-                        <a:latin typeface="Arial" charset="0"/>
-                        <a:ea typeface="Arial" charset="0"/>
-                        <a:cs typeface="Arial" charset="0"/>
+                        <a:latin typeface="Times New Roman" charset="0"/>
+                        <a:ea typeface="Times New Roman" charset="0"/>
+                        <a:cs typeface="Times New Roman" charset="0"/>
                       </a:endParaRPr>
                     </a:p>
                   </a:txBody>
@@ -6771,16 +6771,16 @@
                           <a:solidFill>
                             <a:srgbClr val="000000"/>
                           </a:solidFill>
-                          <a:latin typeface="Arial" pitchFamily="34" charset="0"/>
-                          <a:ea typeface="Arial" pitchFamily="34" charset="-122"/>
-                          <a:cs typeface="Arial" pitchFamily="34" charset="-120"/>
+                          <a:latin typeface="Times New Roman" pitchFamily="34" charset="0"/>
+                          <a:ea typeface="Times New Roman" pitchFamily="34" charset="-122"/>
+                          <a:cs typeface="Times New Roman" pitchFamily="34" charset="-120"/>
                         </a:rPr>
                         <a:t>0.4969</a:t>
                       </a:r>
                       <a:endParaRPr lang="en-US" sz="900" dirty="0">
-                        <a:latin typeface="Arial" charset="0"/>
-                        <a:ea typeface="Arial" charset="0"/>
-                        <a:cs typeface="Arial" charset="0"/>
+                        <a:latin typeface="Times New Roman" charset="0"/>
+                        <a:ea typeface="Times New Roman" charset="0"/>
+                        <a:cs typeface="Times New Roman" charset="0"/>
                       </a:endParaRPr>
                     </a:p>
                   </a:txBody>
@@ -6839,16 +6839,16 @@
                           <a:solidFill>
                             <a:srgbClr val="000000"/>
                           </a:solidFill>
-                          <a:latin typeface="Arial" pitchFamily="34" charset="0"/>
-                          <a:ea typeface="Arial" pitchFamily="34" charset="-122"/>
-                          <a:cs typeface="Arial" pitchFamily="34" charset="-120"/>
+                          <a:latin typeface="Times New Roman" pitchFamily="34" charset="0"/>
+                          <a:ea typeface="Times New Roman" pitchFamily="34" charset="-122"/>
+                          <a:cs typeface="Times New Roman" pitchFamily="34" charset="-120"/>
                         </a:rPr>
                         <a:t>0.4685</a:t>
                       </a:r>
                       <a:endParaRPr lang="en-US" sz="900" dirty="0">
-                        <a:latin typeface="Arial" charset="0"/>
-                        <a:ea typeface="Arial" charset="0"/>
-                        <a:cs typeface="Arial" charset="0"/>
+                        <a:latin typeface="Times New Roman" charset="0"/>
+                        <a:ea typeface="Times New Roman" charset="0"/>
+                        <a:cs typeface="Times New Roman" charset="0"/>
                       </a:endParaRPr>
                     </a:p>
                   </a:txBody>
@@ -6907,16 +6907,16 @@
                           <a:solidFill>
                             <a:srgbClr val="000000"/>
                           </a:solidFill>
-                          <a:latin typeface="Arial" pitchFamily="34" charset="0"/>
-                          <a:ea typeface="Arial" pitchFamily="34" charset="-122"/>
-                          <a:cs typeface="Arial" pitchFamily="34" charset="-120"/>
+                          <a:latin typeface="Times New Roman" pitchFamily="34" charset="0"/>
+                          <a:ea typeface="Times New Roman" pitchFamily="34" charset="-122"/>
+                          <a:cs typeface="Times New Roman" pitchFamily="34" charset="-120"/>
                         </a:rPr>
                         <a:t>0.4215</a:t>
                       </a:r>
                       <a:endParaRPr lang="en-US" sz="900" dirty="0">
-                        <a:latin typeface="Arial" charset="0"/>
-                        <a:ea typeface="Arial" charset="0"/>
-                        <a:cs typeface="Arial" charset="0"/>
+                        <a:latin typeface="Times New Roman" charset="0"/>
+                        <a:ea typeface="Times New Roman" charset="0"/>
+                        <a:cs typeface="Times New Roman" charset="0"/>
                       </a:endParaRPr>
                     </a:p>
                   </a:txBody>
@@ -6975,16 +6975,16 @@
                           <a:solidFill>
                             <a:srgbClr val="000000"/>
                           </a:solidFill>
-                          <a:latin typeface="Arial" pitchFamily="34" charset="0"/>
-                          <a:ea typeface="Arial" pitchFamily="34" charset="-122"/>
-                          <a:cs typeface="Arial" pitchFamily="34" charset="-120"/>
+                          <a:latin typeface="Times New Roman" pitchFamily="34" charset="0"/>
+                          <a:ea typeface="Times New Roman" pitchFamily="34" charset="-122"/>
+                          <a:cs typeface="Times New Roman" pitchFamily="34" charset="-120"/>
                         </a:rPr>
                         <a:t>0.8911</a:t>
                       </a:r>
                       <a:endParaRPr lang="en-US" sz="900" dirty="0">
-                        <a:latin typeface="Arial" charset="0"/>
-                        <a:ea typeface="Arial" charset="0"/>
-                        <a:cs typeface="Arial" charset="0"/>
+                        <a:latin typeface="Times New Roman" charset="0"/>
+                        <a:ea typeface="Times New Roman" charset="0"/>
+                        <a:cs typeface="Times New Roman" charset="0"/>
                       </a:endParaRPr>
                     </a:p>
                   </a:txBody>
@@ -7043,16 +7043,16 @@
                           <a:solidFill>
                             <a:srgbClr val="000000"/>
                           </a:solidFill>
-                          <a:latin typeface="Arial" pitchFamily="34" charset="0"/>
-                          <a:ea typeface="Arial" pitchFamily="34" charset="-122"/>
-                          <a:cs typeface="Arial" pitchFamily="34" charset="-120"/>
+                          <a:latin typeface="Times New Roman" pitchFamily="34" charset="0"/>
+                          <a:ea typeface="Times New Roman" pitchFamily="34" charset="-122"/>
+                          <a:cs typeface="Times New Roman" pitchFamily="34" charset="-120"/>
                         </a:rPr>
                         <a:t>0.8103</a:t>
                       </a:r>
                       <a:endParaRPr lang="en-US" sz="900" dirty="0">
-                        <a:latin typeface="Arial" charset="0"/>
-                        <a:ea typeface="Arial" charset="0"/>
-                        <a:cs typeface="Arial" charset="0"/>
+                        <a:latin typeface="Times New Roman" charset="0"/>
+                        <a:ea typeface="Times New Roman" charset="0"/>
+                        <a:cs typeface="Times New Roman" charset="0"/>
                       </a:endParaRPr>
                     </a:p>
                   </a:txBody>
@@ -7113,16 +7113,16 @@
                           <a:solidFill>
                             <a:srgbClr val="000000"/>
                           </a:solidFill>
-                          <a:latin typeface="Arial" pitchFamily="34" charset="0"/>
-                          <a:ea typeface="Arial" pitchFamily="34" charset="-122"/>
-                          <a:cs typeface="Arial" pitchFamily="34" charset="-120"/>
+                          <a:latin typeface="Times New Roman" pitchFamily="34" charset="0"/>
+                          <a:ea typeface="Times New Roman" pitchFamily="34" charset="-122"/>
+                          <a:cs typeface="Times New Roman" pitchFamily="34" charset="-120"/>
                         </a:rPr>
                         <a:t>4-00</a:t>
                       </a:r>
                       <a:endParaRPr lang="en-US" sz="900" dirty="0">
-                        <a:latin typeface="Arial" charset="0"/>
-                        <a:ea typeface="Arial" charset="0"/>
-                        <a:cs typeface="Arial" charset="0"/>
+                        <a:latin typeface="Times New Roman" charset="0"/>
+                        <a:ea typeface="Times New Roman" charset="0"/>
+                        <a:cs typeface="Times New Roman" charset="0"/>
                       </a:endParaRPr>
                     </a:p>
                   </a:txBody>
@@ -7181,16 +7181,16 @@
                           <a:solidFill>
                             <a:srgbClr val="000000"/>
                           </a:solidFill>
-                          <a:latin typeface="Arial" pitchFamily="34" charset="0"/>
-                          <a:ea typeface="Arial" pitchFamily="34" charset="-122"/>
-                          <a:cs typeface="Arial" pitchFamily="34" charset="-120"/>
+                          <a:latin typeface="Times New Roman" pitchFamily="34" charset="0"/>
+                          <a:ea typeface="Times New Roman" pitchFamily="34" charset="-122"/>
+                          <a:cs typeface="Times New Roman" pitchFamily="34" charset="-120"/>
                         </a:rPr>
                         <a:t>0.5186</a:t>
                       </a:r>
                       <a:endParaRPr lang="en-US" sz="900" dirty="0">
-                        <a:latin typeface="Arial" charset="0"/>
-                        <a:ea typeface="Arial" charset="0"/>
-                        <a:cs typeface="Arial" charset="0"/>
+                        <a:latin typeface="Times New Roman" charset="0"/>
+                        <a:ea typeface="Times New Roman" charset="0"/>
+                        <a:cs typeface="Times New Roman" charset="0"/>
                       </a:endParaRPr>
                     </a:p>
                   </a:txBody>
@@ -7249,16 +7249,16 @@
                           <a:solidFill>
                             <a:srgbClr val="000000"/>
                           </a:solidFill>
-                          <a:latin typeface="Arial" pitchFamily="34" charset="0"/>
-                          <a:ea typeface="Arial" pitchFamily="34" charset="-122"/>
-                          <a:cs typeface="Arial" pitchFamily="34" charset="-120"/>
+                          <a:latin typeface="Times New Roman" pitchFamily="34" charset="0"/>
+                          <a:ea typeface="Times New Roman" pitchFamily="34" charset="-122"/>
+                          <a:cs typeface="Times New Roman" pitchFamily="34" charset="-120"/>
                         </a:rPr>
                         <a:t>0.4708</a:t>
                       </a:r>
                       <a:endParaRPr lang="en-US" sz="900" dirty="0">
-                        <a:latin typeface="Arial" charset="0"/>
-                        <a:ea typeface="Arial" charset="0"/>
-                        <a:cs typeface="Arial" charset="0"/>
+                        <a:latin typeface="Times New Roman" charset="0"/>
+                        <a:ea typeface="Times New Roman" charset="0"/>
+                        <a:cs typeface="Times New Roman" charset="0"/>
                       </a:endParaRPr>
                     </a:p>
                   </a:txBody>
@@ -7317,16 +7317,16 @@
                           <a:solidFill>
                             <a:srgbClr val="000000"/>
                           </a:solidFill>
-                          <a:latin typeface="Arial" pitchFamily="34" charset="0"/>
-                          <a:ea typeface="Arial" pitchFamily="34" charset="-122"/>
-                          <a:cs typeface="Arial" pitchFamily="34" charset="-120"/>
+                          <a:latin typeface="Times New Roman" pitchFamily="34" charset="0"/>
+                          <a:ea typeface="Times New Roman" pitchFamily="34" charset="-122"/>
+                          <a:cs typeface="Times New Roman" pitchFamily="34" charset="-120"/>
                         </a:rPr>
                         <a:t>0.4319</a:t>
                       </a:r>
                       <a:endParaRPr lang="en-US" sz="900" dirty="0">
-                        <a:latin typeface="Arial" charset="0"/>
-                        <a:ea typeface="Arial" charset="0"/>
-                        <a:cs typeface="Arial" charset="0"/>
+                        <a:latin typeface="Times New Roman" charset="0"/>
+                        <a:ea typeface="Times New Roman" charset="0"/>
+                        <a:cs typeface="Times New Roman" charset="0"/>
                       </a:endParaRPr>
                     </a:p>
                   </a:txBody>
@@ -7385,16 +7385,16 @@
                           <a:solidFill>
                             <a:srgbClr val="000000"/>
                           </a:solidFill>
-                          <a:latin typeface="Arial" pitchFamily="34" charset="0"/>
-                          <a:ea typeface="Arial" pitchFamily="34" charset="-122"/>
-                          <a:cs typeface="Arial" pitchFamily="34" charset="-120"/>
+                          <a:latin typeface="Times New Roman" pitchFamily="34" charset="0"/>
+                          <a:ea typeface="Times New Roman" pitchFamily="34" charset="-122"/>
+                          <a:cs typeface="Times New Roman" pitchFamily="34" charset="-120"/>
                         </a:rPr>
                         <a:t>0.3925</a:t>
                       </a:r>
                       <a:endParaRPr lang="en-US" sz="900" dirty="0">
-                        <a:latin typeface="Arial" charset="0"/>
-                        <a:ea typeface="Arial" charset="0"/>
-                        <a:cs typeface="Arial" charset="0"/>
+                        <a:latin typeface="Times New Roman" charset="0"/>
+                        <a:ea typeface="Times New Roman" charset="0"/>
+                        <a:cs typeface="Times New Roman" charset="0"/>
                       </a:endParaRPr>
                     </a:p>
                   </a:txBody>
@@ -7453,16 +7453,16 @@
                           <a:solidFill>
                             <a:srgbClr val="000000"/>
                           </a:solidFill>
-                          <a:latin typeface="Arial" pitchFamily="34" charset="0"/>
-                          <a:ea typeface="Arial" pitchFamily="34" charset="-122"/>
-                          <a:cs typeface="Arial" pitchFamily="34" charset="-120"/>
+                          <a:latin typeface="Times New Roman" pitchFamily="34" charset="0"/>
+                          <a:ea typeface="Times New Roman" pitchFamily="34" charset="-122"/>
+                          <a:cs typeface="Times New Roman" pitchFamily="34" charset="-120"/>
                         </a:rPr>
                         <a:t>0.8786</a:t>
                       </a:r>
                       <a:endParaRPr lang="en-US" sz="900" dirty="0">
-                        <a:latin typeface="Arial" charset="0"/>
-                        <a:ea typeface="Arial" charset="0"/>
-                        <a:cs typeface="Arial" charset="0"/>
+                        <a:latin typeface="Times New Roman" charset="0"/>
+                        <a:ea typeface="Times New Roman" charset="0"/>
+                        <a:cs typeface="Times New Roman" charset="0"/>
                       </a:endParaRPr>
                     </a:p>
                   </a:txBody>
@@ -7521,16 +7521,16 @@
                           <a:solidFill>
                             <a:srgbClr val="000000"/>
                           </a:solidFill>
-                          <a:latin typeface="Arial" pitchFamily="34" charset="0"/>
-                          <a:ea typeface="Arial" pitchFamily="34" charset="-122"/>
-                          <a:cs typeface="Arial" pitchFamily="34" charset="-120"/>
+                          <a:latin typeface="Times New Roman" pitchFamily="34" charset="0"/>
+                          <a:ea typeface="Times New Roman" pitchFamily="34" charset="-122"/>
+                          <a:cs typeface="Times New Roman" pitchFamily="34" charset="-120"/>
                         </a:rPr>
                         <a:t>0.7957</a:t>
                       </a:r>
                       <a:endParaRPr lang="en-US" sz="900" dirty="0">
-                        <a:latin typeface="Arial" charset="0"/>
-                        <a:ea typeface="Arial" charset="0"/>
-                        <a:cs typeface="Arial" charset="0"/>
+                        <a:latin typeface="Times New Roman" charset="0"/>
+                        <a:ea typeface="Times New Roman" charset="0"/>
+                        <a:cs typeface="Times New Roman" charset="0"/>
                       </a:endParaRPr>
                     </a:p>
                   </a:txBody>
@@ -7591,16 +7591,16 @@
                           <a:solidFill>
                             <a:srgbClr val="000000"/>
                           </a:solidFill>
-                          <a:latin typeface="Arial" pitchFamily="34" charset="0"/>
-                          <a:ea typeface="Arial" pitchFamily="34" charset="-122"/>
-                          <a:cs typeface="Arial" pitchFamily="34" charset="-120"/>
+                          <a:latin typeface="Times New Roman" pitchFamily="34" charset="0"/>
+                          <a:ea typeface="Times New Roman" pitchFamily="34" charset="-122"/>
+                          <a:cs typeface="Times New Roman" pitchFamily="34" charset="-120"/>
                         </a:rPr>
                         <a:t>4-02</a:t>
                       </a:r>
                       <a:endParaRPr lang="en-US" sz="900" dirty="0">
-                        <a:latin typeface="Arial" charset="0"/>
-                        <a:ea typeface="Arial" charset="0"/>
-                        <a:cs typeface="Arial" charset="0"/>
+                        <a:latin typeface="Times New Roman" charset="0"/>
+                        <a:ea typeface="Times New Roman" charset="0"/>
+                        <a:cs typeface="Times New Roman" charset="0"/>
                       </a:endParaRPr>
                     </a:p>
                   </a:txBody>
@@ -7656,16 +7656,16 @@
                           <a:solidFill>
                             <a:srgbClr val="000000"/>
                           </a:solidFill>
-                          <a:latin typeface="Arial" pitchFamily="34" charset="0"/>
-                          <a:ea typeface="Arial" pitchFamily="34" charset="-122"/>
-                          <a:cs typeface="Arial" pitchFamily="34" charset="-120"/>
+                          <a:latin typeface="Times New Roman" pitchFamily="34" charset="0"/>
+                          <a:ea typeface="Times New Roman" pitchFamily="34" charset="-122"/>
+                          <a:cs typeface="Times New Roman" pitchFamily="34" charset="-120"/>
                         </a:rPr>
                         <a:t>0.4562</a:t>
                       </a:r>
                       <a:endParaRPr lang="en-US" sz="900" dirty="0">
-                        <a:latin typeface="Arial" charset="0"/>
-                        <a:ea typeface="Arial" charset="0"/>
-                        <a:cs typeface="Arial" charset="0"/>
+                        <a:latin typeface="Times New Roman" charset="0"/>
+                        <a:ea typeface="Times New Roman" charset="0"/>
+                        <a:cs typeface="Times New Roman" charset="0"/>
                       </a:endParaRPr>
                     </a:p>
                   </a:txBody>
@@ -7721,16 +7721,16 @@
                           <a:solidFill>
                             <a:srgbClr val="000000"/>
                           </a:solidFill>
-                          <a:latin typeface="Arial" pitchFamily="34" charset="0"/>
-                          <a:ea typeface="Arial" pitchFamily="34" charset="-122"/>
-                          <a:cs typeface="Arial" pitchFamily="34" charset="-120"/>
+                          <a:latin typeface="Times New Roman" pitchFamily="34" charset="0"/>
+                          <a:ea typeface="Times New Roman" pitchFamily="34" charset="-122"/>
+                          <a:cs typeface="Times New Roman" pitchFamily="34" charset="-120"/>
                         </a:rPr>
                         <a:t>0.3170</a:t>
                       </a:r>
                       <a:endParaRPr lang="en-US" sz="900" dirty="0">
-                        <a:latin typeface="Arial" charset="0"/>
-                        <a:ea typeface="Arial" charset="0"/>
-                        <a:cs typeface="Arial" charset="0"/>
+                        <a:latin typeface="Times New Roman" charset="0"/>
+                        <a:ea typeface="Times New Roman" charset="0"/>
+                        <a:cs typeface="Times New Roman" charset="0"/>
                       </a:endParaRPr>
                     </a:p>
                   </a:txBody>
@@ -7786,16 +7786,16 @@
                           <a:solidFill>
                             <a:srgbClr val="000000"/>
                           </a:solidFill>
-                          <a:latin typeface="Arial" pitchFamily="34" charset="0"/>
-                          <a:ea typeface="Arial" pitchFamily="34" charset="-122"/>
-                          <a:cs typeface="Arial" pitchFamily="34" charset="-120"/>
+                          <a:latin typeface="Times New Roman" pitchFamily="34" charset="0"/>
+                          <a:ea typeface="Times New Roman" pitchFamily="34" charset="-122"/>
+                          <a:cs typeface="Times New Roman" pitchFamily="34" charset="-120"/>
                         </a:rPr>
                         <a:t>0.3745</a:t>
                       </a:r>
                       <a:endParaRPr lang="en-US" sz="900" dirty="0">
-                        <a:latin typeface="Arial" charset="0"/>
-                        <a:ea typeface="Arial" charset="0"/>
-                        <a:cs typeface="Arial" charset="0"/>
+                        <a:latin typeface="Times New Roman" charset="0"/>
+                        <a:ea typeface="Times New Roman" charset="0"/>
+                        <a:cs typeface="Times New Roman" charset="0"/>
                       </a:endParaRPr>
                     </a:p>
                   </a:txBody>
@@ -7851,16 +7851,16 @@
                           <a:solidFill>
                             <a:srgbClr val="000000"/>
                           </a:solidFill>
-                          <a:latin typeface="Arial" pitchFamily="34" charset="0"/>
-                          <a:ea typeface="Arial" pitchFamily="34" charset="-122"/>
-                          <a:cs typeface="Arial" pitchFamily="34" charset="-120"/>
+                          <a:latin typeface="Times New Roman" pitchFamily="34" charset="0"/>
+                          <a:ea typeface="Times New Roman" pitchFamily="34" charset="-122"/>
+                          <a:cs typeface="Times New Roman" pitchFamily="34" charset="-120"/>
                         </a:rPr>
                         <a:t>0.2354</a:t>
                       </a:r>
                       <a:endParaRPr lang="en-US" sz="900" dirty="0">
-                        <a:latin typeface="Arial" charset="0"/>
-                        <a:ea typeface="Arial" charset="0"/>
-                        <a:cs typeface="Arial" charset="0"/>
+                        <a:latin typeface="Times New Roman" charset="0"/>
+                        <a:ea typeface="Times New Roman" charset="0"/>
+                        <a:cs typeface="Times New Roman" charset="0"/>
                       </a:endParaRPr>
                     </a:p>
                   </a:txBody>
@@ -7916,16 +7916,16 @@
                           <a:solidFill>
                             <a:srgbClr val="000000"/>
                           </a:solidFill>
-                          <a:latin typeface="Arial" pitchFamily="34" charset="0"/>
-                          <a:ea typeface="Arial" pitchFamily="34" charset="-122"/>
-                          <a:cs typeface="Arial" pitchFamily="34" charset="-120"/>
+                          <a:latin typeface="Times New Roman" pitchFamily="34" charset="0"/>
+                          <a:ea typeface="Times New Roman" pitchFamily="34" charset="-122"/>
+                          <a:cs typeface="Times New Roman" pitchFamily="34" charset="-120"/>
                         </a:rPr>
                         <a:t>0.7957</a:t>
                       </a:r>
                       <a:endParaRPr lang="en-US" sz="900" dirty="0">
-                        <a:latin typeface="Arial" charset="0"/>
-                        <a:ea typeface="Arial" charset="0"/>
-                        <a:cs typeface="Arial" charset="0"/>
+                        <a:latin typeface="Times New Roman" charset="0"/>
+                        <a:ea typeface="Times New Roman" charset="0"/>
+                        <a:cs typeface="Times New Roman" charset="0"/>
                       </a:endParaRPr>
                     </a:p>
                   </a:txBody>
@@ -7981,16 +7981,16 @@
                           <a:solidFill>
                             <a:srgbClr val="000000"/>
                           </a:solidFill>
-                          <a:latin typeface="Arial" pitchFamily="34" charset="0"/>
-                          <a:ea typeface="Arial" pitchFamily="34" charset="-122"/>
-                          <a:cs typeface="Arial" pitchFamily="34" charset="-120"/>
+                          <a:latin typeface="Times New Roman" pitchFamily="34" charset="0"/>
+                          <a:ea typeface="Times New Roman" pitchFamily="34" charset="-122"/>
+                          <a:cs typeface="Times New Roman" pitchFamily="34" charset="-120"/>
                         </a:rPr>
                         <a:t>0.6558</a:t>
                       </a:r>
                       <a:endParaRPr lang="en-US" sz="900" dirty="0">
-                        <a:latin typeface="Arial" charset="0"/>
-                        <a:ea typeface="Arial" charset="0"/>
-                        <a:cs typeface="Arial" charset="0"/>
+                        <a:latin typeface="Times New Roman" charset="0"/>
+                        <a:ea typeface="Times New Roman" charset="0"/>
+                        <a:cs typeface="Times New Roman" charset="0"/>
                       </a:endParaRPr>
                     </a:p>
                   </a:txBody>
@@ -8048,16 +8048,16 @@
                           <a:solidFill>
                             <a:srgbClr val="000000"/>
                           </a:solidFill>
-                          <a:latin typeface="Arial" pitchFamily="34" charset="0"/>
-                          <a:ea typeface="Arial" pitchFamily="34" charset="-122"/>
-                          <a:cs typeface="Arial" pitchFamily="34" charset="-120"/>
+                          <a:latin typeface="Times New Roman" pitchFamily="34" charset="0"/>
+                          <a:ea typeface="Times New Roman" pitchFamily="34" charset="-122"/>
+                          <a:cs typeface="Times New Roman" pitchFamily="34" charset="-120"/>
                         </a:rPr>
                         <a:t>4-03</a:t>
                       </a:r>
                       <a:endParaRPr lang="en-US" sz="900" dirty="0">
-                        <a:latin typeface="Arial" charset="0"/>
-                        <a:ea typeface="Arial" charset="0"/>
-                        <a:cs typeface="Arial" charset="0"/>
+                        <a:latin typeface="Times New Roman" charset="0"/>
+                        <a:ea typeface="Times New Roman" charset="0"/>
+                        <a:cs typeface="Times New Roman" charset="0"/>
                       </a:endParaRPr>
                     </a:p>
                   </a:txBody>
@@ -8116,16 +8116,16 @@
                           <a:solidFill>
                             <a:srgbClr val="000000"/>
                           </a:solidFill>
-                          <a:latin typeface="Arial" pitchFamily="34" charset="0"/>
-                          <a:ea typeface="Arial" pitchFamily="34" charset="-122"/>
-                          <a:cs typeface="Arial" pitchFamily="34" charset="-120"/>
+                          <a:latin typeface="Times New Roman" pitchFamily="34" charset="0"/>
+                          <a:ea typeface="Times New Roman" pitchFamily="34" charset="-122"/>
+                          <a:cs typeface="Times New Roman" pitchFamily="34" charset="-120"/>
                         </a:rPr>
                         <a:t>0.4915</a:t>
                       </a:r>
                       <a:endParaRPr lang="en-US" sz="900" dirty="0">
-                        <a:latin typeface="Arial" charset="0"/>
-                        <a:ea typeface="Arial" charset="0"/>
-                        <a:cs typeface="Arial" charset="0"/>
+                        <a:latin typeface="Times New Roman" charset="0"/>
+                        <a:ea typeface="Times New Roman" charset="0"/>
+                        <a:cs typeface="Times New Roman" charset="0"/>
                       </a:endParaRPr>
                     </a:p>
                   </a:txBody>
@@ -8184,16 +8184,16 @@
                           <a:solidFill>
                             <a:srgbClr val="000000"/>
                           </a:solidFill>
-                          <a:latin typeface="Arial" pitchFamily="34" charset="0"/>
-                          <a:ea typeface="Arial" pitchFamily="34" charset="-122"/>
-                          <a:cs typeface="Arial" pitchFamily="34" charset="-120"/>
+                          <a:latin typeface="Times New Roman" pitchFamily="34" charset="0"/>
+                          <a:ea typeface="Times New Roman" pitchFamily="34" charset="-122"/>
+                          <a:cs typeface="Times New Roman" pitchFamily="34" charset="-120"/>
                         </a:rPr>
                         <a:t>0.3482</a:t>
                       </a:r>
                       <a:endParaRPr lang="en-US" sz="900" dirty="0">
-                        <a:latin typeface="Arial" charset="0"/>
-                        <a:ea typeface="Arial" charset="0"/>
-                        <a:cs typeface="Arial" charset="0"/>
+                        <a:latin typeface="Times New Roman" charset="0"/>
+                        <a:ea typeface="Times New Roman" charset="0"/>
+                        <a:cs typeface="Times New Roman" charset="0"/>
                       </a:endParaRPr>
                     </a:p>
                   </a:txBody>
@@ -8252,16 +8252,16 @@
                           <a:solidFill>
                             <a:srgbClr val="000000"/>
                           </a:solidFill>
-                          <a:latin typeface="Arial" pitchFamily="34" charset="0"/>
-                          <a:ea typeface="Arial" pitchFamily="34" charset="-122"/>
-                          <a:cs typeface="Arial" pitchFamily="34" charset="-120"/>
+                          <a:latin typeface="Times New Roman" pitchFamily="34" charset="0"/>
+                          <a:ea typeface="Times New Roman" pitchFamily="34" charset="-122"/>
+                          <a:cs typeface="Times New Roman" pitchFamily="34" charset="-120"/>
                         </a:rPr>
                         <a:t>0.4139</a:t>
                       </a:r>
                       <a:endParaRPr lang="en-US" sz="900" dirty="0">
-                        <a:latin typeface="Arial" charset="0"/>
-                        <a:ea typeface="Arial" charset="0"/>
-                        <a:cs typeface="Arial" charset="0"/>
+                        <a:latin typeface="Times New Roman" charset="0"/>
+                        <a:ea typeface="Times New Roman" charset="0"/>
+                        <a:cs typeface="Times New Roman" charset="0"/>
                       </a:endParaRPr>
                     </a:p>
                   </a:txBody>
@@ -8320,16 +8320,16 @@
                           <a:solidFill>
                             <a:srgbClr val="000000"/>
                           </a:solidFill>
-                          <a:latin typeface="Arial" pitchFamily="34" charset="0"/>
-                          <a:ea typeface="Arial" pitchFamily="34" charset="-122"/>
-                          <a:cs typeface="Arial" pitchFamily="34" charset="-120"/>
+                          <a:latin typeface="Times New Roman" pitchFamily="34" charset="0"/>
+                          <a:ea typeface="Times New Roman" pitchFamily="34" charset="-122"/>
+                          <a:cs typeface="Times New Roman" pitchFamily="34" charset="-120"/>
                         </a:rPr>
                         <a:t>0.2684</a:t>
                       </a:r>
                       <a:endParaRPr lang="en-US" sz="900" dirty="0">
-                        <a:latin typeface="Arial" charset="0"/>
-                        <a:ea typeface="Arial" charset="0"/>
-                        <a:cs typeface="Arial" charset="0"/>
+                        <a:latin typeface="Times New Roman" charset="0"/>
+                        <a:ea typeface="Times New Roman" charset="0"/>
+                        <a:cs typeface="Times New Roman" charset="0"/>
                       </a:endParaRPr>
                     </a:p>
                   </a:txBody>
@@ -8388,16 +8388,16 @@
                           <a:solidFill>
                             <a:srgbClr val="000000"/>
                           </a:solidFill>
-                          <a:latin typeface="Arial" pitchFamily="34" charset="0"/>
-                          <a:ea typeface="Arial" pitchFamily="34" charset="-122"/>
-                          <a:cs typeface="Arial" pitchFamily="34" charset="-120"/>
+                          <a:latin typeface="Times New Roman" pitchFamily="34" charset="0"/>
+                          <a:ea typeface="Times New Roman" pitchFamily="34" charset="-122"/>
+                          <a:cs typeface="Times New Roman" pitchFamily="34" charset="-120"/>
                         </a:rPr>
                         <a:t>0.8136</a:t>
                       </a:r>
                       <a:endParaRPr lang="en-US" sz="900" dirty="0">
-                        <a:latin typeface="Arial" charset="0"/>
-                        <a:ea typeface="Arial" charset="0"/>
-                        <a:cs typeface="Arial" charset="0"/>
+                        <a:latin typeface="Times New Roman" charset="0"/>
+                        <a:ea typeface="Times New Roman" charset="0"/>
+                        <a:cs typeface="Times New Roman" charset="0"/>
                       </a:endParaRPr>
                     </a:p>
                   </a:txBody>
@@ -8456,16 +8456,16 @@
                           <a:solidFill>
                             <a:srgbClr val="000000"/>
                           </a:solidFill>
-                          <a:latin typeface="Arial" pitchFamily="34" charset="0"/>
-                          <a:ea typeface="Arial" pitchFamily="34" charset="-122"/>
-                          <a:cs typeface="Arial" pitchFamily="34" charset="-120"/>
+                          <a:latin typeface="Times New Roman" pitchFamily="34" charset="0"/>
+                          <a:ea typeface="Times New Roman" pitchFamily="34" charset="-122"/>
+                          <a:cs typeface="Times New Roman" pitchFamily="34" charset="-120"/>
                         </a:rPr>
                         <a:t>0.6797</a:t>
                       </a:r>
                       <a:endParaRPr lang="en-US" sz="900" dirty="0">
-                        <a:latin typeface="Arial" charset="0"/>
-                        <a:ea typeface="Arial" charset="0"/>
-                        <a:cs typeface="Arial" charset="0"/>
+                        <a:latin typeface="Times New Roman" charset="0"/>
+                        <a:ea typeface="Times New Roman" charset="0"/>
+                        <a:cs typeface="Times New Roman" charset="0"/>
                       </a:endParaRPr>
                     </a:p>
                   </a:txBody>
@@ -8526,16 +8526,16 @@
                           <a:solidFill>
                             <a:srgbClr val="000000"/>
                           </a:solidFill>
-                          <a:latin typeface="Arial" pitchFamily="34" charset="0"/>
-                          <a:ea typeface="Arial" pitchFamily="34" charset="-122"/>
-                          <a:cs typeface="Arial" pitchFamily="34" charset="-120"/>
+                          <a:latin typeface="Times New Roman" pitchFamily="34" charset="0"/>
+                          <a:ea typeface="Times New Roman" pitchFamily="34" charset="-122"/>
+                          <a:cs typeface="Times New Roman" pitchFamily="34" charset="-120"/>
                         </a:rPr>
                         <a:t>4-04</a:t>
                       </a:r>
                       <a:endParaRPr lang="en-US" sz="900" dirty="0">
-                        <a:latin typeface="Arial" charset="0"/>
-                        <a:ea typeface="Arial" charset="0"/>
-                        <a:cs typeface="Arial" charset="0"/>
+                        <a:latin typeface="Times New Roman" charset="0"/>
+                        <a:ea typeface="Times New Roman" charset="0"/>
+                        <a:cs typeface="Times New Roman" charset="0"/>
                       </a:endParaRPr>
                     </a:p>
                   </a:txBody>
@@ -8591,16 +8591,16 @@
                           <a:solidFill>
                             <a:srgbClr val="000000"/>
                           </a:solidFill>
-                          <a:latin typeface="Arial" pitchFamily="34" charset="0"/>
-                          <a:ea typeface="Arial" pitchFamily="34" charset="-122"/>
-                          <a:cs typeface="Arial" pitchFamily="34" charset="-120"/>
+                          <a:latin typeface="Times New Roman" pitchFamily="34" charset="0"/>
+                          <a:ea typeface="Times New Roman" pitchFamily="34" charset="-122"/>
+                          <a:cs typeface="Times New Roman" pitchFamily="34" charset="-120"/>
                         </a:rPr>
                         <a:t>0.4686</a:t>
                       </a:r>
                       <a:endParaRPr lang="en-US" sz="900" dirty="0">
-                        <a:latin typeface="Arial" charset="0"/>
-                        <a:ea typeface="Arial" charset="0"/>
-                        <a:cs typeface="Arial" charset="0"/>
+                        <a:latin typeface="Times New Roman" charset="0"/>
+                        <a:ea typeface="Times New Roman" charset="0"/>
+                        <a:cs typeface="Times New Roman" charset="0"/>
                       </a:endParaRPr>
                     </a:p>
                   </a:txBody>
@@ -8656,16 +8656,16 @@
                           <a:solidFill>
                             <a:srgbClr val="000000"/>
                           </a:solidFill>
-                          <a:latin typeface="Arial" pitchFamily="34" charset="0"/>
-                          <a:ea typeface="Arial" pitchFamily="34" charset="-122"/>
-                          <a:cs typeface="Arial" pitchFamily="34" charset="-120"/>
+                          <a:latin typeface="Times New Roman" pitchFamily="34" charset="0"/>
+                          <a:ea typeface="Times New Roman" pitchFamily="34" charset="-122"/>
+                          <a:cs typeface="Times New Roman" pitchFamily="34" charset="-120"/>
                         </a:rPr>
                         <a:t>0.3295</a:t>
                       </a:r>
                       <a:endParaRPr lang="en-US" sz="900" dirty="0">
-                        <a:latin typeface="Arial" charset="0"/>
-                        <a:ea typeface="Arial" charset="0"/>
-                        <a:cs typeface="Arial" charset="0"/>
+                        <a:latin typeface="Times New Roman" charset="0"/>
+                        <a:ea typeface="Times New Roman" charset="0"/>
+                        <a:cs typeface="Times New Roman" charset="0"/>
                       </a:endParaRPr>
                     </a:p>
                   </a:txBody>
@@ -8721,16 +8721,16 @@
                           <a:solidFill>
                             <a:srgbClr val="000000"/>
                           </a:solidFill>
-                          <a:latin typeface="Arial" pitchFamily="34" charset="0"/>
-                          <a:ea typeface="Arial" pitchFamily="34" charset="-122"/>
-                          <a:cs typeface="Arial" pitchFamily="34" charset="-120"/>
+                          <a:latin typeface="Times New Roman" pitchFamily="34" charset="0"/>
+                          <a:ea typeface="Times New Roman" pitchFamily="34" charset="-122"/>
+                          <a:cs typeface="Times New Roman" pitchFamily="34" charset="-120"/>
                         </a:rPr>
                         <a:t>0.3869</a:t>
                       </a:r>
                       <a:endParaRPr lang="en-US" sz="900" dirty="0">
-                        <a:latin typeface="Arial" charset="0"/>
-                        <a:ea typeface="Arial" charset="0"/>
-                        <a:cs typeface="Arial" charset="0"/>
+                        <a:latin typeface="Times New Roman" charset="0"/>
+                        <a:ea typeface="Times New Roman" charset="0"/>
+                        <a:cs typeface="Times New Roman" charset="0"/>
                       </a:endParaRPr>
                     </a:p>
                   </a:txBody>
@@ -8786,16 +8786,16 @@
                           <a:solidFill>
                             <a:srgbClr val="000000"/>
                           </a:solidFill>
-                          <a:latin typeface="Arial" pitchFamily="34" charset="0"/>
-                          <a:ea typeface="Arial" pitchFamily="34" charset="-122"/>
-                          <a:cs typeface="Arial" pitchFamily="34" charset="-120"/>
+                          <a:latin typeface="Times New Roman" pitchFamily="34" charset="0"/>
+                          <a:ea typeface="Times New Roman" pitchFamily="34" charset="-122"/>
+                          <a:cs typeface="Times New Roman" pitchFamily="34" charset="-120"/>
                         </a:rPr>
                         <a:t>0.2449</a:t>
                       </a:r>
                       <a:endParaRPr lang="en-US" sz="900" dirty="0">
-                        <a:latin typeface="Arial" charset="0"/>
-                        <a:ea typeface="Arial" charset="0"/>
-                        <a:cs typeface="Arial" charset="0"/>
+                        <a:latin typeface="Times New Roman" charset="0"/>
+                        <a:ea typeface="Times New Roman" charset="0"/>
+                        <a:cs typeface="Times New Roman" charset="0"/>
                       </a:endParaRPr>
                     </a:p>
                   </a:txBody>
@@ -8851,16 +8851,16 @@
                           <a:solidFill>
                             <a:srgbClr val="000000"/>
                           </a:solidFill>
-                          <a:latin typeface="Arial" pitchFamily="34" charset="0"/>
-                          <a:ea typeface="Arial" pitchFamily="34" charset="-122"/>
-                          <a:cs typeface="Arial" pitchFamily="34" charset="-120"/>
+                          <a:latin typeface="Times New Roman" pitchFamily="34" charset="0"/>
+                          <a:ea typeface="Times New Roman" pitchFamily="34" charset="-122"/>
+                          <a:cs typeface="Times New Roman" pitchFamily="34" charset="-120"/>
                         </a:rPr>
                         <a:t>0.8076</a:t>
                       </a:r>
                       <a:endParaRPr lang="en-US" sz="900" dirty="0">
-                        <a:latin typeface="Arial" charset="0"/>
-                        <a:ea typeface="Arial" charset="0"/>
-                        <a:cs typeface="Arial" charset="0"/>
+                        <a:latin typeface="Times New Roman" charset="0"/>
+                        <a:ea typeface="Times New Roman" charset="0"/>
+                        <a:cs typeface="Times New Roman" charset="0"/>
                       </a:endParaRPr>
                     </a:p>
                   </a:txBody>
@@ -8916,16 +8916,16 @@
                           <a:solidFill>
                             <a:srgbClr val="000000"/>
                           </a:solidFill>
-                          <a:latin typeface="Arial" pitchFamily="34" charset="0"/>
-                          <a:ea typeface="Arial" pitchFamily="34" charset="-122"/>
-                          <a:cs typeface="Arial" pitchFamily="34" charset="-120"/>
+                          <a:latin typeface="Times New Roman" pitchFamily="34" charset="0"/>
+                          <a:ea typeface="Times New Roman" pitchFamily="34" charset="-122"/>
+                          <a:cs typeface="Times New Roman" pitchFamily="34" charset="-120"/>
                         </a:rPr>
                         <a:t>0.6808</a:t>
                       </a:r>
                       <a:endParaRPr lang="en-US" sz="900" dirty="0">
-                        <a:latin typeface="Arial" charset="0"/>
-                        <a:ea typeface="Arial" charset="0"/>
-                        <a:cs typeface="Arial" charset="0"/>
+                        <a:latin typeface="Times New Roman" charset="0"/>
+                        <a:ea typeface="Times New Roman" charset="0"/>
+                        <a:cs typeface="Times New Roman" charset="0"/>
                       </a:endParaRPr>
                     </a:p>
                   </a:txBody>
@@ -8983,16 +8983,16 @@
                           <a:solidFill>
                             <a:srgbClr val="000000"/>
                           </a:solidFill>
-                          <a:latin typeface="Arial" pitchFamily="34" charset="0"/>
-                          <a:ea typeface="Arial" pitchFamily="34" charset="-122"/>
-                          <a:cs typeface="Arial" pitchFamily="34" charset="-120"/>
+                          <a:latin typeface="Times New Roman" pitchFamily="34" charset="0"/>
+                          <a:ea typeface="Times New Roman" pitchFamily="34" charset="-122"/>
+                          <a:cs typeface="Times New Roman" pitchFamily="34" charset="-120"/>
                         </a:rPr>
                         <a:t>4-05</a:t>
                       </a:r>
                       <a:endParaRPr lang="en-US" sz="900" dirty="0">
-                        <a:latin typeface="Arial" charset="0"/>
-                        <a:ea typeface="Arial" charset="0"/>
-                        <a:cs typeface="Arial" charset="0"/>
+                        <a:latin typeface="Times New Roman" charset="0"/>
+                        <a:ea typeface="Times New Roman" charset="0"/>
+                        <a:cs typeface="Times New Roman" charset="0"/>
                       </a:endParaRPr>
                     </a:p>
                   </a:txBody>
@@ -9048,16 +9048,16 @@
                           <a:solidFill>
                             <a:srgbClr val="000000"/>
                           </a:solidFill>
-                          <a:latin typeface="Arial" pitchFamily="34" charset="0"/>
-                          <a:ea typeface="Arial" pitchFamily="34" charset="-122"/>
-                          <a:cs typeface="Arial" pitchFamily="34" charset="-120"/>
+                          <a:latin typeface="Times New Roman" pitchFamily="34" charset="0"/>
+                          <a:ea typeface="Times New Roman" pitchFamily="34" charset="-122"/>
+                          <a:cs typeface="Times New Roman" pitchFamily="34" charset="-120"/>
                         </a:rPr>
                         <a:t>0.4300</a:t>
                       </a:r>
                       <a:endParaRPr lang="en-US" sz="900" dirty="0">
-                        <a:latin typeface="Arial" charset="0"/>
-                        <a:ea typeface="Arial" charset="0"/>
-                        <a:cs typeface="Arial" charset="0"/>
+                        <a:latin typeface="Times New Roman" charset="0"/>
+                        <a:ea typeface="Times New Roman" charset="0"/>
+                        <a:cs typeface="Times New Roman" charset="0"/>
                       </a:endParaRPr>
                     </a:p>
                   </a:txBody>
@@ -9113,16 +9113,16 @@
                           <a:solidFill>
                             <a:srgbClr val="000000"/>
                           </a:solidFill>
-                          <a:latin typeface="Arial" pitchFamily="34" charset="0"/>
-                          <a:ea typeface="Arial" pitchFamily="34" charset="-122"/>
-                          <a:cs typeface="Arial" pitchFamily="34" charset="-120"/>
+                          <a:latin typeface="Times New Roman" pitchFamily="34" charset="0"/>
+                          <a:ea typeface="Times New Roman" pitchFamily="34" charset="-122"/>
+                          <a:cs typeface="Times New Roman" pitchFamily="34" charset="-120"/>
                         </a:rPr>
                         <a:t>0.3014</a:t>
                       </a:r>
                       <a:endParaRPr lang="en-US" sz="900" dirty="0">
-                        <a:latin typeface="Arial" charset="0"/>
-                        <a:ea typeface="Arial" charset="0"/>
-                        <a:cs typeface="Arial" charset="0"/>
+                        <a:latin typeface="Times New Roman" charset="0"/>
+                        <a:ea typeface="Times New Roman" charset="0"/>
+                        <a:cs typeface="Times New Roman" charset="0"/>
                       </a:endParaRPr>
                     </a:p>
                   </a:txBody>
@@ -9178,16 +9178,16 @@
                           <a:solidFill>
                             <a:srgbClr val="000000"/>
                           </a:solidFill>
-                          <a:latin typeface="Arial" pitchFamily="34" charset="0"/>
-                          <a:ea typeface="Arial" pitchFamily="34" charset="-122"/>
-                          <a:cs typeface="Arial" pitchFamily="34" charset="-120"/>
+                          <a:latin typeface="Times New Roman" pitchFamily="34" charset="0"/>
+                          <a:ea typeface="Times New Roman" pitchFamily="34" charset="-122"/>
+                          <a:cs typeface="Times New Roman" pitchFamily="34" charset="-120"/>
                         </a:rPr>
                         <a:t>0.3433</a:t>
                       </a:r>
                       <a:endParaRPr lang="en-US" sz="900" dirty="0">
-                        <a:latin typeface="Arial" charset="0"/>
-                        <a:ea typeface="Arial" charset="0"/>
-                        <a:cs typeface="Arial" charset="0"/>
+                        <a:latin typeface="Times New Roman" charset="0"/>
+                        <a:ea typeface="Times New Roman" charset="0"/>
+                        <a:cs typeface="Times New Roman" charset="0"/>
                       </a:endParaRPr>
                     </a:p>
                   </a:txBody>
@@ -9243,16 +9243,16 @@
                           <a:solidFill>
                             <a:srgbClr val="000000"/>
                           </a:solidFill>
-                          <a:latin typeface="Arial" pitchFamily="34" charset="0"/>
-                          <a:ea typeface="Arial" pitchFamily="34" charset="-122"/>
-                          <a:cs typeface="Arial" pitchFamily="34" charset="-120"/>
+                          <a:latin typeface="Times New Roman" pitchFamily="34" charset="0"/>
+                          <a:ea typeface="Times New Roman" pitchFamily="34" charset="-122"/>
+                          <a:cs typeface="Times New Roman" pitchFamily="34" charset="-120"/>
                         </a:rPr>
                         <a:t>0.2188</a:t>
                       </a:r>
                       <a:endParaRPr lang="en-US" sz="900" dirty="0">
-                        <a:latin typeface="Arial" charset="0"/>
-                        <a:ea typeface="Arial" charset="0"/>
-                        <a:cs typeface="Arial" charset="0"/>
+                        <a:latin typeface="Times New Roman" charset="0"/>
+                        <a:ea typeface="Times New Roman" charset="0"/>
+                        <a:cs typeface="Times New Roman" charset="0"/>
                       </a:endParaRPr>
                     </a:p>
                   </a:txBody>
@@ -9308,16 +9308,16 @@
                           <a:solidFill>
                             <a:srgbClr val="000000"/>
                           </a:solidFill>
-                          <a:latin typeface="Arial" pitchFamily="34" charset="0"/>
-                          <a:ea typeface="Arial" pitchFamily="34" charset="-122"/>
-                          <a:cs typeface="Arial" pitchFamily="34" charset="-120"/>
+                          <a:latin typeface="Times New Roman" pitchFamily="34" charset="0"/>
+                          <a:ea typeface="Times New Roman" pitchFamily="34" charset="-122"/>
+                          <a:cs typeface="Times New Roman" pitchFamily="34" charset="-120"/>
                         </a:rPr>
                         <a:t>0.7897</a:t>
                       </a:r>
                       <a:endParaRPr lang="en-US" sz="900" dirty="0">
-                        <a:latin typeface="Arial" charset="0"/>
-                        <a:ea typeface="Arial" charset="0"/>
-                        <a:cs typeface="Arial" charset="0"/>
+                        <a:latin typeface="Times New Roman" charset="0"/>
+                        <a:ea typeface="Times New Roman" charset="0"/>
+                        <a:cs typeface="Times New Roman" charset="0"/>
                       </a:endParaRPr>
                     </a:p>
                   </a:txBody>
@@ -9373,16 +9373,16 @@
                           <a:solidFill>
                             <a:srgbClr val="000000"/>
                           </a:solidFill>
-                          <a:latin typeface="Arial" pitchFamily="34" charset="0"/>
-                          <a:ea typeface="Arial" pitchFamily="34" charset="-122"/>
-                          <a:cs typeface="Arial" pitchFamily="34" charset="-120"/>
+                          <a:latin typeface="Times New Roman" pitchFamily="34" charset="0"/>
+                          <a:ea typeface="Times New Roman" pitchFamily="34" charset="-122"/>
+                          <a:cs typeface="Times New Roman" pitchFamily="34" charset="-120"/>
                         </a:rPr>
                         <a:t>0.6444</a:t>
                       </a:r>
                       <a:endParaRPr lang="en-US" sz="900" dirty="0">
-                        <a:latin typeface="Arial" charset="0"/>
-                        <a:ea typeface="Arial" charset="0"/>
-                        <a:cs typeface="Arial" charset="0"/>
+                        <a:latin typeface="Times New Roman" charset="0"/>
+                        <a:ea typeface="Times New Roman" charset="0"/>
+                        <a:cs typeface="Times New Roman" charset="0"/>
                       </a:endParaRPr>
                     </a:p>
                   </a:txBody>
@@ -9440,16 +9440,16 @@
                           <a:solidFill>
                             <a:srgbClr val="000000"/>
                           </a:solidFill>
-                          <a:latin typeface="Arial" pitchFamily="34" charset="0"/>
-                          <a:ea typeface="Arial" pitchFamily="34" charset="-122"/>
-                          <a:cs typeface="Arial" pitchFamily="34" charset="-120"/>
+                          <a:latin typeface="Times New Roman" pitchFamily="34" charset="0"/>
+                          <a:ea typeface="Times New Roman" pitchFamily="34" charset="-122"/>
+                          <a:cs typeface="Times New Roman" pitchFamily="34" charset="-120"/>
                         </a:rPr>
                         <a:t>4-06</a:t>
                       </a:r>
                       <a:endParaRPr lang="en-US" sz="900" dirty="0">
-                        <a:latin typeface="Arial" charset="0"/>
-                        <a:ea typeface="Arial" charset="0"/>
-                        <a:cs typeface="Arial" charset="0"/>
+                        <a:latin typeface="Times New Roman" charset="0"/>
+                        <a:ea typeface="Times New Roman" charset="0"/>
+                        <a:cs typeface="Times New Roman" charset="0"/>
                       </a:endParaRPr>
                     </a:p>
                   </a:txBody>
@@ -9505,16 +9505,16 @@
                           <a:solidFill>
                             <a:srgbClr val="000000"/>
                           </a:solidFill>
-                          <a:latin typeface="Arial" pitchFamily="34" charset="0"/>
-                          <a:ea typeface="Arial" pitchFamily="34" charset="-122"/>
-                          <a:cs typeface="Arial" pitchFamily="34" charset="-120"/>
+                          <a:latin typeface="Times New Roman" pitchFamily="34" charset="0"/>
+                          <a:ea typeface="Times New Roman" pitchFamily="34" charset="-122"/>
+                          <a:cs typeface="Times New Roman" pitchFamily="34" charset="-120"/>
                         </a:rPr>
                         <a:t>0.4676</a:t>
                       </a:r>
                       <a:endParaRPr lang="en-US" sz="900" dirty="0">
-                        <a:latin typeface="Arial" charset="0"/>
-                        <a:ea typeface="Arial" charset="0"/>
-                        <a:cs typeface="Arial" charset="0"/>
+                        <a:latin typeface="Times New Roman" charset="0"/>
+                        <a:ea typeface="Times New Roman" charset="0"/>
+                        <a:cs typeface="Times New Roman" charset="0"/>
                       </a:endParaRPr>
                     </a:p>
                   </a:txBody>
@@ -9570,16 +9570,16 @@
                           <a:solidFill>
                             <a:srgbClr val="000000"/>
                           </a:solidFill>
-                          <a:latin typeface="Arial" pitchFamily="34" charset="0"/>
-                          <a:ea typeface="Arial" pitchFamily="34" charset="-122"/>
-                          <a:cs typeface="Arial" pitchFamily="34" charset="-120"/>
+                          <a:latin typeface="Times New Roman" pitchFamily="34" charset="0"/>
+                          <a:ea typeface="Times New Roman" pitchFamily="34" charset="-122"/>
+                          <a:cs typeface="Times New Roman" pitchFamily="34" charset="-120"/>
                         </a:rPr>
                         <a:t>0.3295</a:t>
                       </a:r>
                       <a:endParaRPr lang="en-US" sz="900" dirty="0">
-                        <a:latin typeface="Arial" charset="0"/>
-                        <a:ea typeface="Arial" charset="0"/>
-                        <a:cs typeface="Arial" charset="0"/>
+                        <a:latin typeface="Times New Roman" charset="0"/>
+                        <a:ea typeface="Times New Roman" charset="0"/>
+                        <a:cs typeface="Times New Roman" charset="0"/>
                       </a:endParaRPr>
                     </a:p>
                   </a:txBody>
@@ -9635,16 +9635,16 @@
                           <a:solidFill>
                             <a:srgbClr val="000000"/>
                           </a:solidFill>
-                          <a:latin typeface="Arial" pitchFamily="34" charset="0"/>
-                          <a:ea typeface="Arial" pitchFamily="34" charset="-122"/>
-                          <a:cs typeface="Arial" pitchFamily="34" charset="-120"/>
+                          <a:latin typeface="Times New Roman" pitchFamily="34" charset="0"/>
+                          <a:ea typeface="Times New Roman" pitchFamily="34" charset="-122"/>
+                          <a:cs typeface="Times New Roman" pitchFamily="34" charset="-120"/>
                         </a:rPr>
                         <a:t>0.3882</a:t>
                       </a:r>
                       <a:endParaRPr lang="en-US" sz="900" dirty="0">
-                        <a:latin typeface="Arial" charset="0"/>
-                        <a:ea typeface="Arial" charset="0"/>
-                        <a:cs typeface="Arial" charset="0"/>
+                        <a:latin typeface="Times New Roman" charset="0"/>
+                        <a:ea typeface="Times New Roman" charset="0"/>
+                        <a:cs typeface="Times New Roman" charset="0"/>
                       </a:endParaRPr>
                     </a:p>
                   </a:txBody>
@@ -9700,16 +9700,16 @@
                           <a:solidFill>
                             <a:srgbClr val="000000"/>
                           </a:solidFill>
-                          <a:latin typeface="Arial" pitchFamily="34" charset="0"/>
-                          <a:ea typeface="Arial" pitchFamily="34" charset="-122"/>
-                          <a:cs typeface="Arial" pitchFamily="34" charset="-120"/>
+                          <a:latin typeface="Times New Roman" pitchFamily="34" charset="0"/>
+                          <a:ea typeface="Times New Roman" pitchFamily="34" charset="-122"/>
+                          <a:cs typeface="Times New Roman" pitchFamily="34" charset="-120"/>
                         </a:rPr>
                         <a:t>0.2506</a:t>
                       </a:r>
                       <a:endParaRPr lang="en-US" sz="900" dirty="0">
-                        <a:latin typeface="Arial" charset="0"/>
-                        <a:ea typeface="Arial" charset="0"/>
-                        <a:cs typeface="Arial" charset="0"/>
+                        <a:latin typeface="Times New Roman" charset="0"/>
+                        <a:ea typeface="Times New Roman" charset="0"/>
+                        <a:cs typeface="Times New Roman" charset="0"/>
                       </a:endParaRPr>
                     </a:p>
                   </a:txBody>
@@ -9765,16 +9765,16 @@
                           <a:solidFill>
                             <a:srgbClr val="000000"/>
                           </a:solidFill>
-                          <a:latin typeface="Arial" pitchFamily="34" charset="0"/>
-                          <a:ea typeface="Arial" pitchFamily="34" charset="-122"/>
-                          <a:cs typeface="Arial" pitchFamily="34" charset="-120"/>
+                          <a:latin typeface="Times New Roman" pitchFamily="34" charset="0"/>
+                          <a:ea typeface="Times New Roman" pitchFamily="34" charset="-122"/>
+                          <a:cs typeface="Times New Roman" pitchFamily="34" charset="-120"/>
                         </a:rPr>
                         <a:t>0.7973</a:t>
                       </a:r>
                       <a:endParaRPr lang="en-US" sz="900" dirty="0">
-                        <a:latin typeface="Arial" charset="0"/>
-                        <a:ea typeface="Arial" charset="0"/>
-                        <a:cs typeface="Arial" charset="0"/>
+                        <a:latin typeface="Times New Roman" charset="0"/>
+                        <a:ea typeface="Times New Roman" charset="0"/>
+                        <a:cs typeface="Times New Roman" charset="0"/>
                       </a:endParaRPr>
                     </a:p>
                   </a:txBody>
@@ -9830,16 +9830,16 @@
                           <a:solidFill>
                             <a:srgbClr val="000000"/>
                           </a:solidFill>
-                          <a:latin typeface="Arial" pitchFamily="34" charset="0"/>
-                          <a:ea typeface="Arial" pitchFamily="34" charset="-122"/>
-                          <a:cs typeface="Arial" pitchFamily="34" charset="-120"/>
+                          <a:latin typeface="Times New Roman" pitchFamily="34" charset="0"/>
+                          <a:ea typeface="Times New Roman" pitchFamily="34" charset="-122"/>
+                          <a:cs typeface="Times New Roman" pitchFamily="34" charset="-120"/>
                         </a:rPr>
                         <a:t>0.6575</a:t>
                       </a:r>
                       <a:endParaRPr lang="en-US" sz="900" dirty="0">
-                        <a:latin typeface="Arial" charset="0"/>
-                        <a:ea typeface="Arial" charset="0"/>
-                        <a:cs typeface="Arial" charset="0"/>
+                        <a:latin typeface="Times New Roman" charset="0"/>
+                        <a:ea typeface="Times New Roman" charset="0"/>
+                        <a:cs typeface="Times New Roman" charset="0"/>
                       </a:endParaRPr>
                     </a:p>
                   </a:txBody>
@@ -9897,16 +9897,16 @@
                           <a:solidFill>
                             <a:srgbClr val="000000"/>
                           </a:solidFill>
-                          <a:latin typeface="Arial" pitchFamily="34" charset="0"/>
-                          <a:ea typeface="Arial" pitchFamily="34" charset="-122"/>
-                          <a:cs typeface="Arial" pitchFamily="34" charset="-120"/>
+                          <a:latin typeface="Times New Roman" pitchFamily="34" charset="0"/>
+                          <a:ea typeface="Times New Roman" pitchFamily="34" charset="-122"/>
+                          <a:cs typeface="Times New Roman" pitchFamily="34" charset="-120"/>
                         </a:rPr>
                         <a:t>4-07</a:t>
                       </a:r>
                       <a:endParaRPr lang="en-US" sz="900" dirty="0">
-                        <a:latin typeface="Arial" charset="0"/>
-                        <a:ea typeface="Arial" charset="0"/>
-                        <a:cs typeface="Arial" charset="0"/>
+                        <a:latin typeface="Times New Roman" charset="0"/>
+                        <a:ea typeface="Times New Roman" charset="0"/>
+                        <a:cs typeface="Times New Roman" charset="0"/>
                       </a:endParaRPr>
                     </a:p>
                   </a:txBody>
@@ -9962,16 +9962,16 @@
                           <a:solidFill>
                             <a:srgbClr val="000000"/>
                           </a:solidFill>
-                          <a:latin typeface="Arial" pitchFamily="34" charset="0"/>
-                          <a:ea typeface="Arial" pitchFamily="34" charset="-122"/>
-                          <a:cs typeface="Arial" pitchFamily="34" charset="-120"/>
+                          <a:latin typeface="Times New Roman" pitchFamily="34" charset="0"/>
+                          <a:ea typeface="Times New Roman" pitchFamily="34" charset="-122"/>
+                          <a:cs typeface="Times New Roman" pitchFamily="34" charset="-120"/>
                         </a:rPr>
                         <a:t>0.4322</a:t>
                       </a:r>
                       <a:endParaRPr lang="en-US" sz="900" dirty="0">
-                        <a:latin typeface="Arial" charset="0"/>
-                        <a:ea typeface="Arial" charset="0"/>
-                        <a:cs typeface="Arial" charset="0"/>
+                        <a:latin typeface="Times New Roman" charset="0"/>
+                        <a:ea typeface="Times New Roman" charset="0"/>
+                        <a:cs typeface="Times New Roman" charset="0"/>
                       </a:endParaRPr>
                     </a:p>
                   </a:txBody>
@@ -10027,16 +10027,16 @@
                           <a:solidFill>
                             <a:srgbClr val="000000"/>
                           </a:solidFill>
-                          <a:latin typeface="Arial" pitchFamily="34" charset="0"/>
-                          <a:ea typeface="Arial" pitchFamily="34" charset="-122"/>
-                          <a:cs typeface="Arial" pitchFamily="34" charset="-120"/>
+                          <a:latin typeface="Times New Roman" pitchFamily="34" charset="0"/>
+                          <a:ea typeface="Times New Roman" pitchFamily="34" charset="-122"/>
+                          <a:cs typeface="Times New Roman" pitchFamily="34" charset="-120"/>
                         </a:rPr>
                         <a:t>0.2974</a:t>
                       </a:r>
                       <a:endParaRPr lang="en-US" sz="900" dirty="0">
-                        <a:latin typeface="Arial" charset="0"/>
-                        <a:ea typeface="Arial" charset="0"/>
-                        <a:cs typeface="Arial" charset="0"/>
+                        <a:latin typeface="Times New Roman" charset="0"/>
+                        <a:ea typeface="Times New Roman" charset="0"/>
+                        <a:cs typeface="Times New Roman" charset="0"/>
                       </a:endParaRPr>
                     </a:p>
                   </a:txBody>
@@ -10092,16 +10092,16 @@
                           <a:solidFill>
                             <a:srgbClr val="000000"/>
                           </a:solidFill>
-                          <a:latin typeface="Arial" pitchFamily="34" charset="0"/>
-                          <a:ea typeface="Arial" pitchFamily="34" charset="-122"/>
-                          <a:cs typeface="Arial" pitchFamily="34" charset="-120"/>
+                          <a:latin typeface="Times New Roman" pitchFamily="34" charset="0"/>
+                          <a:ea typeface="Times New Roman" pitchFamily="34" charset="-122"/>
+                          <a:cs typeface="Times New Roman" pitchFamily="34" charset="-120"/>
                         </a:rPr>
                         <a:t>0.3473</a:t>
                       </a:r>
                       <a:endParaRPr lang="en-US" sz="900" dirty="0">
-                        <a:latin typeface="Arial" charset="0"/>
-                        <a:ea typeface="Arial" charset="0"/>
-                        <a:cs typeface="Arial" charset="0"/>
+                        <a:latin typeface="Times New Roman" charset="0"/>
+                        <a:ea typeface="Times New Roman" charset="0"/>
+                        <a:cs typeface="Times New Roman" charset="0"/>
                       </a:endParaRPr>
                     </a:p>
                   </a:txBody>
@@ -10157,16 +10157,16 @@
                           <a:solidFill>
                             <a:srgbClr val="000000"/>
                           </a:solidFill>
-                          <a:latin typeface="Arial" pitchFamily="34" charset="0"/>
-                          <a:ea typeface="Arial" pitchFamily="34" charset="-122"/>
-                          <a:cs typeface="Arial" pitchFamily="34" charset="-120"/>
+                          <a:latin typeface="Times New Roman" pitchFamily="34" charset="0"/>
+                          <a:ea typeface="Times New Roman" pitchFamily="34" charset="-122"/>
+                          <a:cs typeface="Times New Roman" pitchFamily="34" charset="-120"/>
                         </a:rPr>
                         <a:t>0.2141</a:t>
                       </a:r>
                       <a:endParaRPr lang="en-US" sz="900" dirty="0">
-                        <a:latin typeface="Arial" charset="0"/>
-                        <a:ea typeface="Arial" charset="0"/>
-                        <a:cs typeface="Arial" charset="0"/>
+                        <a:latin typeface="Times New Roman" charset="0"/>
+                        <a:ea typeface="Times New Roman" charset="0"/>
+                        <a:cs typeface="Times New Roman" charset="0"/>
                       </a:endParaRPr>
                     </a:p>
                   </a:txBody>
@@ -10222,16 +10222,16 @@
                           <a:solidFill>
                             <a:srgbClr val="000000"/>
                           </a:solidFill>
-                          <a:latin typeface="Arial" pitchFamily="34" charset="0"/>
-                          <a:ea typeface="Arial" pitchFamily="34" charset="-122"/>
-                          <a:cs typeface="Arial" pitchFamily="34" charset="-120"/>
+                          <a:latin typeface="Times New Roman" pitchFamily="34" charset="0"/>
+                          <a:ea typeface="Times New Roman" pitchFamily="34" charset="-122"/>
+                          <a:cs typeface="Times New Roman" pitchFamily="34" charset="-120"/>
                         </a:rPr>
                         <a:t>0.7848</a:t>
                       </a:r>
                       <a:endParaRPr lang="en-US" sz="900" dirty="0">
-                        <a:latin typeface="Arial" charset="0"/>
-                        <a:ea typeface="Arial" charset="0"/>
-                        <a:cs typeface="Arial" charset="0"/>
+                        <a:latin typeface="Times New Roman" charset="0"/>
+                        <a:ea typeface="Times New Roman" charset="0"/>
+                        <a:cs typeface="Times New Roman" charset="0"/>
                       </a:endParaRPr>
                     </a:p>
                   </a:txBody>
@@ -10287,16 +10287,16 @@
                           <a:solidFill>
                             <a:srgbClr val="000000"/>
                           </a:solidFill>
-                          <a:latin typeface="Arial" pitchFamily="34" charset="0"/>
-                          <a:ea typeface="Arial" pitchFamily="34" charset="-122"/>
-                          <a:cs typeface="Arial" pitchFamily="34" charset="-120"/>
+                          <a:latin typeface="Times New Roman" pitchFamily="34" charset="0"/>
+                          <a:ea typeface="Times New Roman" pitchFamily="34" charset="-122"/>
+                          <a:cs typeface="Times New Roman" pitchFamily="34" charset="-120"/>
                         </a:rPr>
                         <a:t>0.6434</a:t>
                       </a:r>
                       <a:endParaRPr lang="en-US" sz="900" dirty="0">
-                        <a:latin typeface="Arial" charset="0"/>
-                        <a:ea typeface="Arial" charset="0"/>
-                        <a:cs typeface="Arial" charset="0"/>
+                        <a:latin typeface="Times New Roman" charset="0"/>
+                        <a:ea typeface="Times New Roman" charset="0"/>
+                        <a:cs typeface="Times New Roman" charset="0"/>
                       </a:endParaRPr>
                     </a:p>
                   </a:txBody>
@@ -10354,16 +10354,16 @@
                           <a:solidFill>
                             <a:srgbClr val="000000"/>
                           </a:solidFill>
-                          <a:latin typeface="Arial" pitchFamily="34" charset="0"/>
-                          <a:ea typeface="Arial" pitchFamily="34" charset="-122"/>
-                          <a:cs typeface="Arial" pitchFamily="34" charset="-120"/>
+                          <a:latin typeface="Times New Roman" pitchFamily="34" charset="0"/>
+                          <a:ea typeface="Times New Roman" pitchFamily="34" charset="-122"/>
+                          <a:cs typeface="Times New Roman" pitchFamily="34" charset="-120"/>
                         </a:rPr>
                         <a:t>4-08</a:t>
                       </a:r>
                       <a:endParaRPr lang="en-US" sz="900" dirty="0">
-                        <a:latin typeface="Arial" charset="0"/>
-                        <a:ea typeface="Arial" charset="0"/>
-                        <a:cs typeface="Arial" charset="0"/>
+                        <a:latin typeface="Times New Roman" charset="0"/>
+                        <a:ea typeface="Times New Roman" charset="0"/>
+                        <a:cs typeface="Times New Roman" charset="0"/>
                       </a:endParaRPr>
                     </a:p>
                   </a:txBody>
@@ -10419,16 +10419,16 @@
                           <a:solidFill>
                             <a:srgbClr val="000000"/>
                           </a:solidFill>
-                          <a:latin typeface="Arial" pitchFamily="34" charset="0"/>
-                          <a:ea typeface="Arial" pitchFamily="34" charset="-122"/>
-                          <a:cs typeface="Arial" pitchFamily="34" charset="-120"/>
+                          <a:latin typeface="Times New Roman" pitchFamily="34" charset="0"/>
+                          <a:ea typeface="Times New Roman" pitchFamily="34" charset="-122"/>
+                          <a:cs typeface="Times New Roman" pitchFamily="34" charset="-120"/>
                         </a:rPr>
                         <a:t>0.4713</a:t>
                       </a:r>
                       <a:endParaRPr lang="en-US" sz="900" dirty="0">
-                        <a:latin typeface="Arial" charset="0"/>
-                        <a:ea typeface="Arial" charset="0"/>
-                        <a:cs typeface="Arial" charset="0"/>
+                        <a:latin typeface="Times New Roman" charset="0"/>
+                        <a:ea typeface="Times New Roman" charset="0"/>
+                        <a:cs typeface="Times New Roman" charset="0"/>
                       </a:endParaRPr>
                     </a:p>
                   </a:txBody>
@@ -10484,16 +10484,16 @@
                           <a:solidFill>
                             <a:srgbClr val="000000"/>
                           </a:solidFill>
-                          <a:latin typeface="Arial" pitchFamily="34" charset="0"/>
-                          <a:ea typeface="Arial" pitchFamily="34" charset="-122"/>
-                          <a:cs typeface="Arial" pitchFamily="34" charset="-120"/>
+                          <a:latin typeface="Times New Roman" pitchFamily="34" charset="0"/>
+                          <a:ea typeface="Times New Roman" pitchFamily="34" charset="-122"/>
+                          <a:cs typeface="Times New Roman" pitchFamily="34" charset="-120"/>
                         </a:rPr>
                         <a:t>0.3345</a:t>
                       </a:r>
                       <a:endParaRPr lang="en-US" sz="900" dirty="0">
-                        <a:latin typeface="Arial" charset="0"/>
-                        <a:ea typeface="Arial" charset="0"/>
-                        <a:cs typeface="Arial" charset="0"/>
+                        <a:latin typeface="Times New Roman" charset="0"/>
+                        <a:ea typeface="Times New Roman" charset="0"/>
+                        <a:cs typeface="Times New Roman" charset="0"/>
                       </a:endParaRPr>
                     </a:p>
                   </a:txBody>
@@ -10549,16 +10549,16 @@
                           <a:solidFill>
                             <a:srgbClr val="000000"/>
                           </a:solidFill>
-                          <a:latin typeface="Arial" pitchFamily="34" charset="0"/>
-                          <a:ea typeface="Arial" pitchFamily="34" charset="-122"/>
-                          <a:cs typeface="Arial" pitchFamily="34" charset="-120"/>
+                          <a:latin typeface="Times New Roman" pitchFamily="34" charset="0"/>
+                          <a:ea typeface="Times New Roman" pitchFamily="34" charset="-122"/>
+                          <a:cs typeface="Times New Roman" pitchFamily="34" charset="-120"/>
                         </a:rPr>
                         <a:t>0.3903</a:t>
                       </a:r>
                       <a:endParaRPr lang="en-US" sz="900" dirty="0">
-                        <a:latin typeface="Arial" charset="0"/>
-                        <a:ea typeface="Arial" charset="0"/>
-                        <a:cs typeface="Arial" charset="0"/>
+                        <a:latin typeface="Times New Roman" charset="0"/>
+                        <a:ea typeface="Times New Roman" charset="0"/>
+                        <a:cs typeface="Times New Roman" charset="0"/>
                       </a:endParaRPr>
                     </a:p>
                   </a:txBody>
@@ -10614,16 +10614,16 @@
                           <a:solidFill>
                             <a:srgbClr val="000000"/>
                           </a:solidFill>
-                          <a:latin typeface="Arial" pitchFamily="34" charset="0"/>
-                          <a:ea typeface="Arial" pitchFamily="34" charset="-122"/>
-                          <a:cs typeface="Arial" pitchFamily="34" charset="-120"/>
+                          <a:latin typeface="Times New Roman" pitchFamily="34" charset="0"/>
+                          <a:ea typeface="Times New Roman" pitchFamily="34" charset="-122"/>
+                          <a:cs typeface="Times New Roman" pitchFamily="34" charset="-120"/>
                         </a:rPr>
                         <a:t>0.2500</a:t>
                       </a:r>
                       <a:endParaRPr lang="en-US" sz="900" dirty="0">
-                        <a:latin typeface="Arial" charset="0"/>
-                        <a:ea typeface="Arial" charset="0"/>
-                        <a:cs typeface="Arial" charset="0"/>
+                        <a:latin typeface="Times New Roman" charset="0"/>
+                        <a:ea typeface="Times New Roman" charset="0"/>
+                        <a:cs typeface="Times New Roman" charset="0"/>
                       </a:endParaRPr>
                     </a:p>
                   </a:txBody>
@@ -10679,16 +10679,16 @@
                           <a:solidFill>
                             <a:srgbClr val="000000"/>
                           </a:solidFill>
-                          <a:latin typeface="Arial" pitchFamily="34" charset="0"/>
-                          <a:ea typeface="Arial" pitchFamily="34" charset="-122"/>
-                          <a:cs typeface="Arial" pitchFamily="34" charset="-120"/>
+                          <a:latin typeface="Times New Roman" pitchFamily="34" charset="0"/>
+                          <a:ea typeface="Times New Roman" pitchFamily="34" charset="-122"/>
+                          <a:cs typeface="Times New Roman" pitchFamily="34" charset="-120"/>
                         </a:rPr>
                         <a:t>0.8076</a:t>
                       </a:r>
                       <a:endParaRPr lang="en-US" sz="900" dirty="0">
-                        <a:latin typeface="Arial" charset="0"/>
-                        <a:ea typeface="Arial" charset="0"/>
-                        <a:cs typeface="Arial" charset="0"/>
+                        <a:latin typeface="Times New Roman" charset="0"/>
+                        <a:ea typeface="Times New Roman" charset="0"/>
+                        <a:cs typeface="Times New Roman" charset="0"/>
                       </a:endParaRPr>
                     </a:p>
                   </a:txBody>
@@ -10744,16 +10744,16 @@
                           <a:solidFill>
                             <a:srgbClr val="000000"/>
                           </a:solidFill>
-                          <a:latin typeface="Arial" pitchFamily="34" charset="0"/>
-                          <a:ea typeface="Arial" pitchFamily="34" charset="-122"/>
-                          <a:cs typeface="Arial" pitchFamily="34" charset="-120"/>
+                          <a:latin typeface="Times New Roman" pitchFamily="34" charset="0"/>
+                          <a:ea typeface="Times New Roman" pitchFamily="34" charset="-122"/>
+                          <a:cs typeface="Times New Roman" pitchFamily="34" charset="-120"/>
                         </a:rPr>
                         <a:t>0.6851</a:t>
                       </a:r>
                       <a:endParaRPr lang="en-US" sz="900" dirty="0">
-                        <a:latin typeface="Arial" charset="0"/>
-                        <a:ea typeface="Arial" charset="0"/>
-                        <a:cs typeface="Arial" charset="0"/>
+                        <a:latin typeface="Times New Roman" charset="0"/>
+                        <a:ea typeface="Times New Roman" charset="0"/>
+                        <a:cs typeface="Times New Roman" charset="0"/>
                       </a:endParaRPr>
                     </a:p>
                   </a:txBody>
@@ -10811,16 +10811,16 @@
                           <a:solidFill>
                             <a:srgbClr val="000000"/>
                           </a:solidFill>
-                          <a:latin typeface="Arial" pitchFamily="34" charset="0"/>
-                          <a:ea typeface="Arial" pitchFamily="34" charset="-122"/>
-                          <a:cs typeface="Arial" pitchFamily="34" charset="-120"/>
+                          <a:latin typeface="Times New Roman" pitchFamily="34" charset="0"/>
+                          <a:ea typeface="Times New Roman" pitchFamily="34" charset="-122"/>
+                          <a:cs typeface="Times New Roman" pitchFamily="34" charset="-120"/>
                         </a:rPr>
                         <a:t>4-09</a:t>
                       </a:r>
                       <a:endParaRPr lang="en-US" sz="900" dirty="0">
-                        <a:latin typeface="Arial" charset="0"/>
-                        <a:ea typeface="Arial" charset="0"/>
-                        <a:cs typeface="Arial" charset="0"/>
+                        <a:latin typeface="Times New Roman" charset="0"/>
+                        <a:ea typeface="Times New Roman" charset="0"/>
+                        <a:cs typeface="Times New Roman" charset="0"/>
                       </a:endParaRPr>
                     </a:p>
                   </a:txBody>
@@ -10876,16 +10876,16 @@
                           <a:solidFill>
                             <a:srgbClr val="000000"/>
                           </a:solidFill>
-                          <a:latin typeface="Arial" pitchFamily="34" charset="0"/>
-                          <a:ea typeface="Arial" pitchFamily="34" charset="-122"/>
-                          <a:cs typeface="Arial" pitchFamily="34" charset="-120"/>
+                          <a:latin typeface="Times New Roman" pitchFamily="34" charset="0"/>
+                          <a:ea typeface="Times New Roman" pitchFamily="34" charset="-122"/>
+                          <a:cs typeface="Times New Roman" pitchFamily="34" charset="-120"/>
                         </a:rPr>
                         <a:t>0.4164</a:t>
                       </a:r>
                       <a:endParaRPr lang="en-US" sz="900" dirty="0">
-                        <a:latin typeface="Arial" charset="0"/>
-                        <a:ea typeface="Arial" charset="0"/>
-                        <a:cs typeface="Arial" charset="0"/>
+                        <a:latin typeface="Times New Roman" charset="0"/>
+                        <a:ea typeface="Times New Roman" charset="0"/>
+                        <a:cs typeface="Times New Roman" charset="0"/>
                       </a:endParaRPr>
                     </a:p>
                   </a:txBody>
@@ -10941,16 +10941,16 @@
                           <a:solidFill>
                             <a:srgbClr val="000000"/>
                           </a:solidFill>
-                          <a:latin typeface="Arial" pitchFamily="34" charset="0"/>
-                          <a:ea typeface="Arial" pitchFamily="34" charset="-122"/>
-                          <a:cs typeface="Arial" pitchFamily="34" charset="-120"/>
+                          <a:latin typeface="Times New Roman" pitchFamily="34" charset="0"/>
+                          <a:ea typeface="Times New Roman" pitchFamily="34" charset="-122"/>
+                          <a:cs typeface="Times New Roman" pitchFamily="34" charset="-120"/>
                         </a:rPr>
                         <a:t>0.2803</a:t>
                       </a:r>
                       <a:endParaRPr lang="en-US" sz="900" dirty="0">
-                        <a:latin typeface="Arial" charset="0"/>
-                        <a:ea typeface="Arial" charset="0"/>
-                        <a:cs typeface="Arial" charset="0"/>
+                        <a:latin typeface="Times New Roman" charset="0"/>
+                        <a:ea typeface="Times New Roman" charset="0"/>
+                        <a:cs typeface="Times New Roman" charset="0"/>
                       </a:endParaRPr>
                     </a:p>
                   </a:txBody>
@@ -11006,16 +11006,16 @@
                           <a:solidFill>
                             <a:srgbClr val="000000"/>
                           </a:solidFill>
-                          <a:latin typeface="Arial" pitchFamily="34" charset="0"/>
-                          <a:ea typeface="Arial" pitchFamily="34" charset="-122"/>
-                          <a:cs typeface="Arial" pitchFamily="34" charset="-120"/>
+                          <a:latin typeface="Times New Roman" pitchFamily="34" charset="0"/>
+                          <a:ea typeface="Times New Roman" pitchFamily="34" charset="-122"/>
+                          <a:cs typeface="Times New Roman" pitchFamily="34" charset="-120"/>
                         </a:rPr>
                         <a:t>0.3330</a:t>
                       </a:r>
                       <a:endParaRPr lang="en-US" sz="900" dirty="0">
-                        <a:latin typeface="Arial" charset="0"/>
-                        <a:ea typeface="Arial" charset="0"/>
-                        <a:cs typeface="Arial" charset="0"/>
+                        <a:latin typeface="Times New Roman" charset="0"/>
+                        <a:ea typeface="Times New Roman" charset="0"/>
+                        <a:cs typeface="Times New Roman" charset="0"/>
                       </a:endParaRPr>
                     </a:p>
                   </a:txBody>
@@ -11071,16 +11071,16 @@
                           <a:solidFill>
                             <a:srgbClr val="000000"/>
                           </a:solidFill>
-                          <a:latin typeface="Arial" pitchFamily="34" charset="0"/>
-                          <a:ea typeface="Arial" pitchFamily="34" charset="-122"/>
-                          <a:cs typeface="Arial" pitchFamily="34" charset="-120"/>
+                          <a:latin typeface="Times New Roman" pitchFamily="34" charset="0"/>
+                          <a:ea typeface="Times New Roman" pitchFamily="34" charset="-122"/>
+                          <a:cs typeface="Times New Roman" pitchFamily="34" charset="-120"/>
                         </a:rPr>
                         <a:t>0.1978</a:t>
                       </a:r>
                       <a:endParaRPr lang="en-US" sz="900" dirty="0">
-                        <a:latin typeface="Arial" charset="0"/>
-                        <a:ea typeface="Arial" charset="0"/>
-                        <a:cs typeface="Arial" charset="0"/>
+                        <a:latin typeface="Times New Roman" charset="0"/>
+                        <a:ea typeface="Times New Roman" charset="0"/>
+                        <a:cs typeface="Times New Roman" charset="0"/>
                       </a:endParaRPr>
                     </a:p>
                   </a:txBody>
@@ -11136,16 +11136,16 @@
                           <a:solidFill>
                             <a:srgbClr val="000000"/>
                           </a:solidFill>
-                          <a:latin typeface="Arial" pitchFamily="34" charset="0"/>
-                          <a:ea typeface="Arial" pitchFamily="34" charset="-122"/>
-                          <a:cs typeface="Arial" pitchFamily="34" charset="-120"/>
+                          <a:latin typeface="Times New Roman" pitchFamily="34" charset="0"/>
+                          <a:ea typeface="Times New Roman" pitchFamily="34" charset="-122"/>
+                          <a:cs typeface="Times New Roman" pitchFamily="34" charset="-120"/>
                         </a:rPr>
                         <a:t>0.7626</a:t>
                       </a:r>
                       <a:endParaRPr lang="en-US" sz="900" dirty="0">
-                        <a:latin typeface="Arial" charset="0"/>
-                        <a:ea typeface="Arial" charset="0"/>
-                        <a:cs typeface="Arial" charset="0"/>
+                        <a:latin typeface="Times New Roman" charset="0"/>
+                        <a:ea typeface="Times New Roman" charset="0"/>
+                        <a:cs typeface="Times New Roman" charset="0"/>
                       </a:endParaRPr>
                     </a:p>
                   </a:txBody>
@@ -11201,16 +11201,16 @@
                           <a:solidFill>
                             <a:srgbClr val="000000"/>
                           </a:solidFill>
-                          <a:latin typeface="Arial" pitchFamily="34" charset="0"/>
-                          <a:ea typeface="Arial" pitchFamily="34" charset="-122"/>
-                          <a:cs typeface="Arial" pitchFamily="34" charset="-120"/>
+                          <a:latin typeface="Times New Roman" pitchFamily="34" charset="0"/>
+                          <a:ea typeface="Times New Roman" pitchFamily="34" charset="-122"/>
+                          <a:cs typeface="Times New Roman" pitchFamily="34" charset="-120"/>
                         </a:rPr>
                         <a:t>0.6228</a:t>
                       </a:r>
                       <a:endParaRPr lang="en-US" sz="900" dirty="0">
-                        <a:latin typeface="Arial" charset="0"/>
-                        <a:ea typeface="Arial" charset="0"/>
-                        <a:cs typeface="Arial" charset="0"/>
+                        <a:latin typeface="Times New Roman" charset="0"/>
+                        <a:ea typeface="Times New Roman" charset="0"/>
+                        <a:cs typeface="Times New Roman" charset="0"/>
                       </a:endParaRPr>
                     </a:p>
                   </a:txBody>
@@ -11268,16 +11268,16 @@
                           <a:solidFill>
                             <a:srgbClr val="000000"/>
                           </a:solidFill>
-                          <a:latin typeface="Arial" pitchFamily="34" charset="0"/>
-                          <a:ea typeface="Arial" pitchFamily="34" charset="-122"/>
-                          <a:cs typeface="Arial" pitchFamily="34" charset="-120"/>
+                          <a:latin typeface="Times New Roman" pitchFamily="34" charset="0"/>
+                          <a:ea typeface="Times New Roman" pitchFamily="34" charset="-122"/>
+                          <a:cs typeface="Times New Roman" pitchFamily="34" charset="-120"/>
                         </a:rPr>
                         <a:t>4-10</a:t>
                       </a:r>
                       <a:endParaRPr lang="en-US" sz="900" dirty="0">
-                        <a:latin typeface="Arial" charset="0"/>
-                        <a:ea typeface="Arial" charset="0"/>
-                        <a:cs typeface="Arial" charset="0"/>
+                        <a:latin typeface="Times New Roman" charset="0"/>
+                        <a:ea typeface="Times New Roman" charset="0"/>
+                        <a:cs typeface="Times New Roman" charset="0"/>
                       </a:endParaRPr>
                     </a:p>
                   </a:txBody>
@@ -11333,16 +11333,16 @@
                           <a:solidFill>
                             <a:srgbClr val="000000"/>
                           </a:solidFill>
-                          <a:latin typeface="Arial" pitchFamily="34" charset="0"/>
-                          <a:ea typeface="Arial" pitchFamily="34" charset="-122"/>
-                          <a:cs typeface="Arial" pitchFamily="34" charset="-120"/>
+                          <a:latin typeface="Times New Roman" pitchFamily="34" charset="0"/>
+                          <a:ea typeface="Times New Roman" pitchFamily="34" charset="-122"/>
+                          <a:cs typeface="Times New Roman" pitchFamily="34" charset="-120"/>
                         </a:rPr>
                         <a:t>0.4247</a:t>
                       </a:r>
                       <a:endParaRPr lang="en-US" sz="900" dirty="0">
-                        <a:latin typeface="Arial" charset="0"/>
-                        <a:ea typeface="Arial" charset="0"/>
-                        <a:cs typeface="Arial" charset="0"/>
+                        <a:latin typeface="Times New Roman" charset="0"/>
+                        <a:ea typeface="Times New Roman" charset="0"/>
+                        <a:cs typeface="Times New Roman" charset="0"/>
                       </a:endParaRPr>
                     </a:p>
                   </a:txBody>
@@ -11398,16 +11398,16 @@
                           <a:solidFill>
                             <a:srgbClr val="000000"/>
                           </a:solidFill>
-                          <a:latin typeface="Arial" pitchFamily="34" charset="0"/>
-                          <a:ea typeface="Arial" pitchFamily="34" charset="-122"/>
-                          <a:cs typeface="Arial" pitchFamily="34" charset="-120"/>
+                          <a:latin typeface="Times New Roman" pitchFamily="34" charset="0"/>
+                          <a:ea typeface="Times New Roman" pitchFamily="34" charset="-122"/>
+                          <a:cs typeface="Times New Roman" pitchFamily="34" charset="-120"/>
                         </a:rPr>
                         <a:t>0.2939</a:t>
                       </a:r>
                       <a:endParaRPr lang="en-US" sz="900" dirty="0">
-                        <a:latin typeface="Arial" charset="0"/>
-                        <a:ea typeface="Arial" charset="0"/>
-                        <a:cs typeface="Arial" charset="0"/>
+                        <a:latin typeface="Times New Roman" charset="0"/>
+                        <a:ea typeface="Times New Roman" charset="0"/>
+                        <a:cs typeface="Times New Roman" charset="0"/>
                       </a:endParaRPr>
                     </a:p>
                   </a:txBody>
@@ -11463,16 +11463,16 @@
                           <a:solidFill>
                             <a:srgbClr val="000000"/>
                           </a:solidFill>
-                          <a:latin typeface="Arial" pitchFamily="34" charset="0"/>
-                          <a:ea typeface="Arial" pitchFamily="34" charset="-122"/>
-                          <a:cs typeface="Arial" pitchFamily="34" charset="-120"/>
+                          <a:latin typeface="Times New Roman" pitchFamily="34" charset="0"/>
+                          <a:ea typeface="Times New Roman" pitchFamily="34" charset="-122"/>
+                          <a:cs typeface="Times New Roman" pitchFamily="34" charset="-120"/>
                         </a:rPr>
                         <a:t>0.3407</a:t>
                       </a:r>
                       <a:endParaRPr lang="en-US" sz="900" dirty="0">
-                        <a:latin typeface="Arial" charset="0"/>
-                        <a:ea typeface="Arial" charset="0"/>
-                        <a:cs typeface="Arial" charset="0"/>
+                        <a:latin typeface="Times New Roman" charset="0"/>
+                        <a:ea typeface="Times New Roman" charset="0"/>
+                        <a:cs typeface="Times New Roman" charset="0"/>
                       </a:endParaRPr>
                     </a:p>
                   </a:txBody>
@@ -11528,16 +11528,16 @@
                           <a:solidFill>
                             <a:srgbClr val="000000"/>
                           </a:solidFill>
-                          <a:latin typeface="Arial" pitchFamily="34" charset="0"/>
-                          <a:ea typeface="Arial" pitchFamily="34" charset="-122"/>
-                          <a:cs typeface="Arial" pitchFamily="34" charset="-120"/>
+                          <a:latin typeface="Times New Roman" pitchFamily="34" charset="0"/>
+                          <a:ea typeface="Times New Roman" pitchFamily="34" charset="-122"/>
+                          <a:cs typeface="Times New Roman" pitchFamily="34" charset="-120"/>
                         </a:rPr>
                         <a:t>0.2118</a:t>
                       </a:r>
                       <a:endParaRPr lang="en-US" sz="900" dirty="0">
-                        <a:latin typeface="Arial" charset="0"/>
-                        <a:ea typeface="Arial" charset="0"/>
-                        <a:cs typeface="Arial" charset="0"/>
+                        <a:latin typeface="Times New Roman" charset="0"/>
+                        <a:ea typeface="Times New Roman" charset="0"/>
+                        <a:cs typeface="Times New Roman" charset="0"/>
                       </a:endParaRPr>
                     </a:p>
                   </a:txBody>
@@ -11593,16 +11593,16 @@
                           <a:solidFill>
                             <a:srgbClr val="000000"/>
                           </a:solidFill>
-                          <a:latin typeface="Arial" pitchFamily="34" charset="0"/>
-                          <a:ea typeface="Arial" pitchFamily="34" charset="-122"/>
-                          <a:cs typeface="Arial" pitchFamily="34" charset="-120"/>
+                          <a:latin typeface="Times New Roman" pitchFamily="34" charset="0"/>
+                          <a:ea typeface="Times New Roman" pitchFamily="34" charset="-122"/>
+                          <a:cs typeface="Times New Roman" pitchFamily="34" charset="-120"/>
                         </a:rPr>
                         <a:t>0.7734</a:t>
                       </a:r>
                       <a:endParaRPr lang="en-US" sz="900" dirty="0">
-                        <a:latin typeface="Arial" charset="0"/>
-                        <a:ea typeface="Arial" charset="0"/>
-                        <a:cs typeface="Arial" charset="0"/>
+                        <a:latin typeface="Times New Roman" charset="0"/>
+                        <a:ea typeface="Times New Roman" charset="0"/>
+                        <a:cs typeface="Times New Roman" charset="0"/>
                       </a:endParaRPr>
                     </a:p>
                   </a:txBody>
@@ -11658,16 +11658,16 @@
                           <a:solidFill>
                             <a:srgbClr val="000000"/>
                           </a:solidFill>
-                          <a:latin typeface="Arial" pitchFamily="34" charset="0"/>
-                          <a:ea typeface="Arial" pitchFamily="34" charset="-122"/>
-                          <a:cs typeface="Arial" pitchFamily="34" charset="-120"/>
+                          <a:latin typeface="Times New Roman" pitchFamily="34" charset="0"/>
+                          <a:ea typeface="Times New Roman" pitchFamily="34" charset="-122"/>
+                          <a:cs typeface="Times New Roman" pitchFamily="34" charset="-120"/>
                         </a:rPr>
                         <a:t>0.6347</a:t>
                       </a:r>
                       <a:endParaRPr lang="en-US" sz="900" dirty="0">
-                        <a:latin typeface="Arial" charset="0"/>
-                        <a:ea typeface="Arial" charset="0"/>
-                        <a:cs typeface="Arial" charset="0"/>
+                        <a:latin typeface="Times New Roman" charset="0"/>
+                        <a:ea typeface="Times New Roman" charset="0"/>
+                        <a:cs typeface="Times New Roman" charset="0"/>
                       </a:endParaRPr>
                     </a:p>
                   </a:txBody>
@@ -11725,16 +11725,16 @@
                           <a:solidFill>
                             <a:srgbClr val="000000"/>
                           </a:solidFill>
-                          <a:latin typeface="Arial" pitchFamily="34" charset="0"/>
-                          <a:ea typeface="Arial" pitchFamily="34" charset="-122"/>
-                          <a:cs typeface="Arial" pitchFamily="34" charset="-120"/>
+                          <a:latin typeface="Times New Roman" pitchFamily="34" charset="0"/>
+                          <a:ea typeface="Times New Roman" pitchFamily="34" charset="-122"/>
+                          <a:cs typeface="Times New Roman" pitchFamily="34" charset="-120"/>
                         </a:rPr>
                         <a:t>4-11</a:t>
                       </a:r>
                       <a:endParaRPr lang="en-US" sz="900" dirty="0">
-                        <a:latin typeface="Arial" charset="0"/>
-                        <a:ea typeface="Arial" charset="0"/>
-                        <a:cs typeface="Arial" charset="0"/>
+                        <a:latin typeface="Times New Roman" charset="0"/>
+                        <a:ea typeface="Times New Roman" charset="0"/>
+                        <a:cs typeface="Times New Roman" charset="0"/>
                       </a:endParaRPr>
                     </a:p>
                   </a:txBody>
@@ -11790,16 +11790,16 @@
                           <a:solidFill>
                             <a:srgbClr val="000000"/>
                           </a:solidFill>
-                          <a:latin typeface="Arial" pitchFamily="34" charset="0"/>
-                          <a:ea typeface="Arial" pitchFamily="34" charset="-122"/>
-                          <a:cs typeface="Arial" pitchFamily="34" charset="-120"/>
+                          <a:latin typeface="Times New Roman" pitchFamily="34" charset="0"/>
+                          <a:ea typeface="Times New Roman" pitchFamily="34" charset="-122"/>
+                          <a:cs typeface="Times New Roman" pitchFamily="34" charset="-120"/>
                         </a:rPr>
                         <a:t>0.4553</a:t>
                       </a:r>
                       <a:endParaRPr lang="en-US" sz="900" dirty="0">
-                        <a:latin typeface="Arial" charset="0"/>
-                        <a:ea typeface="Arial" charset="0"/>
-                        <a:cs typeface="Arial" charset="0"/>
+                        <a:latin typeface="Times New Roman" charset="0"/>
+                        <a:ea typeface="Times New Roman" charset="0"/>
+                        <a:cs typeface="Times New Roman" charset="0"/>
                       </a:endParaRPr>
                     </a:p>
                   </a:txBody>
@@ -11855,16 +11855,16 @@
                           <a:solidFill>
                             <a:srgbClr val="000000"/>
                           </a:solidFill>
-                          <a:latin typeface="Arial" pitchFamily="34" charset="0"/>
-                          <a:ea typeface="Arial" pitchFamily="34" charset="-122"/>
-                          <a:cs typeface="Arial" pitchFamily="34" charset="-120"/>
+                          <a:latin typeface="Times New Roman" pitchFamily="34" charset="0"/>
+                          <a:ea typeface="Times New Roman" pitchFamily="34" charset="-122"/>
+                          <a:cs typeface="Times New Roman" pitchFamily="34" charset="-120"/>
                         </a:rPr>
                         <a:t>0.3254</a:t>
                       </a:r>
                       <a:endParaRPr lang="en-US" sz="900" dirty="0">
-                        <a:latin typeface="Arial" charset="0"/>
-                        <a:ea typeface="Arial" charset="0"/>
-                        <a:cs typeface="Arial" charset="0"/>
+                        <a:latin typeface="Times New Roman" charset="0"/>
+                        <a:ea typeface="Times New Roman" charset="0"/>
+                        <a:cs typeface="Times New Roman" charset="0"/>
                       </a:endParaRPr>
                     </a:p>
                   </a:txBody>
@@ -11920,16 +11920,16 @@
                           <a:solidFill>
                             <a:srgbClr val="000000"/>
                           </a:solidFill>
-                          <a:latin typeface="Arial" pitchFamily="34" charset="0"/>
-                          <a:ea typeface="Arial" pitchFamily="34" charset="-122"/>
-                          <a:cs typeface="Arial" pitchFamily="34" charset="-120"/>
+                          <a:latin typeface="Times New Roman" pitchFamily="34" charset="0"/>
+                          <a:ea typeface="Times New Roman" pitchFamily="34" charset="-122"/>
+                          <a:cs typeface="Times New Roman" pitchFamily="34" charset="-120"/>
                         </a:rPr>
                         <a:t>0.3711</a:t>
                       </a:r>
                       <a:endParaRPr lang="en-US" sz="900" dirty="0">
-                        <a:latin typeface="Arial" charset="0"/>
-                        <a:ea typeface="Arial" charset="0"/>
-                        <a:cs typeface="Arial" charset="0"/>
+                        <a:latin typeface="Times New Roman" charset="0"/>
+                        <a:ea typeface="Times New Roman" charset="0"/>
+                        <a:cs typeface="Times New Roman" charset="0"/>
                       </a:endParaRPr>
                     </a:p>
                   </a:txBody>
@@ -11985,16 +11985,16 @@
                           <a:solidFill>
                             <a:srgbClr val="000000"/>
                           </a:solidFill>
-                          <a:latin typeface="Arial" pitchFamily="34" charset="0"/>
-                          <a:ea typeface="Arial" pitchFamily="34" charset="-122"/>
-                          <a:cs typeface="Arial" pitchFamily="34" charset="-120"/>
+                          <a:latin typeface="Times New Roman" pitchFamily="34" charset="0"/>
+                          <a:ea typeface="Times New Roman" pitchFamily="34" charset="-122"/>
+                          <a:cs typeface="Times New Roman" pitchFamily="34" charset="-120"/>
                         </a:rPr>
                         <a:t>0.2430</a:t>
                       </a:r>
                       <a:endParaRPr lang="en-US" sz="900" dirty="0">
-                        <a:latin typeface="Arial" charset="0"/>
-                        <a:ea typeface="Arial" charset="0"/>
-                        <a:cs typeface="Arial" charset="0"/>
+                        <a:latin typeface="Times New Roman" charset="0"/>
+                        <a:ea typeface="Times New Roman" charset="0"/>
+                        <a:cs typeface="Times New Roman" charset="0"/>
                       </a:endParaRPr>
                     </a:p>
                   </a:txBody>
@@ -12050,16 +12050,16 @@
                           <a:solidFill>
                             <a:srgbClr val="000000"/>
                           </a:solidFill>
-                          <a:latin typeface="Arial" pitchFamily="34" charset="0"/>
-                          <a:ea typeface="Arial" pitchFamily="34" charset="-122"/>
-                          <a:cs typeface="Arial" pitchFamily="34" charset="-120"/>
+                          <a:latin typeface="Times New Roman" pitchFamily="34" charset="0"/>
+                          <a:ea typeface="Times New Roman" pitchFamily="34" charset="-122"/>
+                          <a:cs typeface="Times New Roman" pitchFamily="34" charset="-120"/>
                         </a:rPr>
                         <a:t>0.8049</a:t>
                       </a:r>
                       <a:endParaRPr lang="en-US" sz="900" dirty="0">
-                        <a:latin typeface="Arial" charset="0"/>
-                        <a:ea typeface="Arial" charset="0"/>
-                        <a:cs typeface="Arial" charset="0"/>
+                        <a:latin typeface="Times New Roman" charset="0"/>
+                        <a:ea typeface="Times New Roman" charset="0"/>
+                        <a:cs typeface="Times New Roman" charset="0"/>
                       </a:endParaRPr>
                     </a:p>
                   </a:txBody>
@@ -12115,16 +12115,16 @@
                           <a:solidFill>
                             <a:srgbClr val="000000"/>
                           </a:solidFill>
-                          <a:latin typeface="Arial" pitchFamily="34" charset="0"/>
-                          <a:ea typeface="Arial" pitchFamily="34" charset="-122"/>
-                          <a:cs typeface="Arial" pitchFamily="34" charset="-120"/>
+                          <a:latin typeface="Times New Roman" pitchFamily="34" charset="0"/>
+                          <a:ea typeface="Times New Roman" pitchFamily="34" charset="-122"/>
+                          <a:cs typeface="Times New Roman" pitchFamily="34" charset="-120"/>
                         </a:rPr>
                         <a:t>0.6678</a:t>
                       </a:r>
                       <a:endParaRPr lang="en-US" sz="900" dirty="0">
-                        <a:latin typeface="Arial" charset="0"/>
-                        <a:ea typeface="Arial" charset="0"/>
-                        <a:cs typeface="Arial" charset="0"/>
+                        <a:latin typeface="Times New Roman" charset="0"/>
+                        <a:ea typeface="Times New Roman" charset="0"/>
+                        <a:cs typeface="Times New Roman" charset="0"/>
                       </a:endParaRPr>
                     </a:p>
                   </a:txBody>
@@ -12182,16 +12182,16 @@
                           <a:solidFill>
                             <a:srgbClr val="000000"/>
                           </a:solidFill>
-                          <a:latin typeface="Arial" pitchFamily="34" charset="0"/>
-                          <a:ea typeface="Arial" pitchFamily="34" charset="-122"/>
-                          <a:cs typeface="Arial" pitchFamily="34" charset="-120"/>
+                          <a:latin typeface="Times New Roman" pitchFamily="34" charset="0"/>
+                          <a:ea typeface="Times New Roman" pitchFamily="34" charset="-122"/>
+                          <a:cs typeface="Times New Roman" pitchFamily="34" charset="-120"/>
                         </a:rPr>
                         <a:t>4-12</a:t>
                       </a:r>
                       <a:endParaRPr lang="en-US" sz="900" dirty="0">
-                        <a:latin typeface="Arial" charset="0"/>
-                        <a:ea typeface="Arial" charset="0"/>
-                        <a:cs typeface="Arial" charset="0"/>
+                        <a:latin typeface="Times New Roman" charset="0"/>
+                        <a:ea typeface="Times New Roman" charset="0"/>
+                        <a:cs typeface="Times New Roman" charset="0"/>
                       </a:endParaRPr>
                     </a:p>
                   </a:txBody>
@@ -12247,16 +12247,16 @@
                           <a:solidFill>
                             <a:srgbClr val="000000"/>
                           </a:solidFill>
-                          <a:latin typeface="Arial" pitchFamily="34" charset="0"/>
-                          <a:ea typeface="Arial" pitchFamily="34" charset="-122"/>
-                          <a:cs typeface="Arial" pitchFamily="34" charset="-120"/>
+                          <a:latin typeface="Times New Roman" pitchFamily="34" charset="0"/>
+                          <a:ea typeface="Times New Roman" pitchFamily="34" charset="-122"/>
+                          <a:cs typeface="Times New Roman" pitchFamily="34" charset="-120"/>
                         </a:rPr>
                         <a:t>0.4633</a:t>
                       </a:r>
                       <a:endParaRPr lang="en-US" sz="900" dirty="0">
-                        <a:latin typeface="Arial" charset="0"/>
-                        <a:ea typeface="Arial" charset="0"/>
-                        <a:cs typeface="Arial" charset="0"/>
+                        <a:latin typeface="Times New Roman" charset="0"/>
+                        <a:ea typeface="Times New Roman" charset="0"/>
+                        <a:cs typeface="Times New Roman" charset="0"/>
                       </a:endParaRPr>
                     </a:p>
                   </a:txBody>
@@ -12312,16 +12312,16 @@
                           <a:solidFill>
                             <a:srgbClr val="000000"/>
                           </a:solidFill>
-                          <a:latin typeface="Arial" pitchFamily="34" charset="0"/>
-                          <a:ea typeface="Arial" pitchFamily="34" charset="-122"/>
-                          <a:cs typeface="Arial" pitchFamily="34" charset="-120"/>
+                          <a:latin typeface="Times New Roman" pitchFamily="34" charset="0"/>
+                          <a:ea typeface="Times New Roman" pitchFamily="34" charset="-122"/>
+                          <a:cs typeface="Times New Roman" pitchFamily="34" charset="-120"/>
                         </a:rPr>
                         <a:t>0.3318</a:t>
                       </a:r>
                       <a:endParaRPr lang="en-US" sz="900" dirty="0">
-                        <a:latin typeface="Arial" charset="0"/>
-                        <a:ea typeface="Arial" charset="0"/>
-                        <a:cs typeface="Arial" charset="0"/>
+                        <a:latin typeface="Times New Roman" charset="0"/>
+                        <a:ea typeface="Times New Roman" charset="0"/>
+                        <a:cs typeface="Times New Roman" charset="0"/>
                       </a:endParaRPr>
                     </a:p>
                   </a:txBody>
@@ -12377,16 +12377,16 @@
                           <a:solidFill>
                             <a:srgbClr val="000000"/>
                           </a:solidFill>
-                          <a:latin typeface="Arial" pitchFamily="34" charset="0"/>
-                          <a:ea typeface="Arial" pitchFamily="34" charset="-122"/>
-                          <a:cs typeface="Arial" pitchFamily="34" charset="-120"/>
+                          <a:latin typeface="Times New Roman" pitchFamily="34" charset="0"/>
+                          <a:ea typeface="Times New Roman" pitchFamily="34" charset="-122"/>
+                          <a:cs typeface="Times New Roman" pitchFamily="34" charset="-120"/>
                         </a:rPr>
                         <a:t>0.3775</a:t>
                       </a:r>
                       <a:endParaRPr lang="en-US" sz="900" dirty="0">
-                        <a:latin typeface="Arial" charset="0"/>
-                        <a:ea typeface="Arial" charset="0"/>
-                        <a:cs typeface="Arial" charset="0"/>
+                        <a:latin typeface="Times New Roman" charset="0"/>
+                        <a:ea typeface="Times New Roman" charset="0"/>
+                        <a:cs typeface="Times New Roman" charset="0"/>
                       </a:endParaRPr>
                     </a:p>
                   </a:txBody>
@@ -12442,16 +12442,16 @@
                           <a:solidFill>
                             <a:srgbClr val="000000"/>
                           </a:solidFill>
-                          <a:latin typeface="Arial" pitchFamily="34" charset="0"/>
-                          <a:ea typeface="Arial" pitchFamily="34" charset="-122"/>
-                          <a:cs typeface="Arial" pitchFamily="34" charset="-120"/>
+                          <a:latin typeface="Times New Roman" pitchFamily="34" charset="0"/>
+                          <a:ea typeface="Times New Roman" pitchFamily="34" charset="-122"/>
+                          <a:cs typeface="Times New Roman" pitchFamily="34" charset="-120"/>
                         </a:rPr>
                         <a:t>0.2481</a:t>
                       </a:r>
                       <a:endParaRPr lang="en-US" sz="900" dirty="0">
-                        <a:latin typeface="Arial" charset="0"/>
-                        <a:ea typeface="Arial" charset="0"/>
-                        <a:cs typeface="Arial" charset="0"/>
+                        <a:latin typeface="Times New Roman" charset="0"/>
+                        <a:ea typeface="Times New Roman" charset="0"/>
+                        <a:cs typeface="Times New Roman" charset="0"/>
                       </a:endParaRPr>
                     </a:p>
                   </a:txBody>
@@ -12507,16 +12507,16 @@
                           <a:solidFill>
                             <a:srgbClr val="000000"/>
                           </a:solidFill>
-                          <a:latin typeface="Arial" pitchFamily="34" charset="0"/>
-                          <a:ea typeface="Arial" pitchFamily="34" charset="-122"/>
-                          <a:cs typeface="Arial" pitchFamily="34" charset="-120"/>
+                          <a:latin typeface="Times New Roman" pitchFamily="34" charset="0"/>
+                          <a:ea typeface="Times New Roman" pitchFamily="34" charset="-122"/>
+                          <a:cs typeface="Times New Roman" pitchFamily="34" charset="-120"/>
                         </a:rPr>
                         <a:t>0.8195</a:t>
                       </a:r>
                       <a:endParaRPr lang="en-US" sz="900" dirty="0">
-                        <a:latin typeface="Arial" charset="0"/>
-                        <a:ea typeface="Arial" charset="0"/>
-                        <a:cs typeface="Arial" charset="0"/>
+                        <a:latin typeface="Times New Roman" charset="0"/>
+                        <a:ea typeface="Times New Roman" charset="0"/>
+                        <a:cs typeface="Times New Roman" charset="0"/>
                       </a:endParaRPr>
                     </a:p>
                   </a:txBody>
@@ -12572,16 +12572,16 @@
                           <a:solidFill>
                             <a:srgbClr val="000000"/>
                           </a:solidFill>
-                          <a:latin typeface="Arial" pitchFamily="34" charset="0"/>
-                          <a:ea typeface="Arial" pitchFamily="34" charset="-122"/>
-                          <a:cs typeface="Arial" pitchFamily="34" charset="-120"/>
+                          <a:latin typeface="Times New Roman" pitchFamily="34" charset="0"/>
+                          <a:ea typeface="Times New Roman" pitchFamily="34" charset="-122"/>
+                          <a:cs typeface="Times New Roman" pitchFamily="34" charset="-120"/>
                         </a:rPr>
                         <a:t>0.6797</a:t>
                       </a:r>
                       <a:endParaRPr lang="en-US" sz="900" dirty="0">
-                        <a:latin typeface="Arial" charset="0"/>
-                        <a:ea typeface="Arial" charset="0"/>
-                        <a:cs typeface="Arial" charset="0"/>
+                        <a:latin typeface="Times New Roman" charset="0"/>
+                        <a:ea typeface="Times New Roman" charset="0"/>
+                        <a:cs typeface="Times New Roman" charset="0"/>
                       </a:endParaRPr>
                     </a:p>
                   </a:txBody>
@@ -12661,9 +12661,9 @@
                 <a:solidFill>
                   <a:srgbClr val="000000"/>
                 </a:solidFill>
-                <a:latin typeface="Arial"/>
-                <a:ea typeface="Arial"/>
-                <a:cs typeface="Arial"/>
+                <a:latin typeface="Times New Roman"/>
+                <a:ea typeface="Times New Roman"/>
+                <a:cs typeface="Times New Roman"/>
               </a:defRPr>
             </a:lvl1pPr>
           </a:lstStyle>
@@ -12809,9 +12809,9 @@
                 <a:solidFill>
                   <a:srgbClr val="000000"/>
                 </a:solidFill>
-                <a:latin typeface="Arial" pitchFamily="34" charset="0"/>
-                <a:ea typeface="Arial" pitchFamily="34" charset="-122"/>
-                <a:cs typeface="Arial" pitchFamily="34" charset="-120"/>
+                <a:latin typeface="Times New Roman" pitchFamily="34" charset="0"/>
+                <a:ea typeface="Times New Roman" pitchFamily="34" charset="-122"/>
+                <a:cs typeface="Times New Roman" pitchFamily="34" charset="-120"/>
               </a:rPr>
               <a:t>*1</a:t>
             </a:r>
@@ -12823,9 +12823,9 @@
                 <a:solidFill>
                   <a:srgbClr val="000000"/>
                 </a:solidFill>
-                <a:latin typeface="Arial" pitchFamily="34" charset="0"/>
-                <a:ea typeface="Arial" pitchFamily="34" charset="-122"/>
-                <a:cs typeface="Arial" pitchFamily="34" charset="-120"/>
+                <a:latin typeface="Times New Roman" pitchFamily="34" charset="0"/>
+                <a:ea typeface="Times New Roman" pitchFamily="34" charset="-122"/>
+                <a:cs typeface="Times New Roman" pitchFamily="34" charset="-120"/>
               </a:rPr>
               <a:t> </a:t>
             </a:r>
@@ -12837,9 +12837,9 @@
                 <a:solidFill>
                   <a:srgbClr val="0000EE"/>
                 </a:solidFill>
-                <a:latin typeface="Arial" pitchFamily="34" charset="0"/>
-                <a:ea typeface="Arial" pitchFamily="34" charset="-122"/>
-                <a:cs typeface="Arial" pitchFamily="34" charset="-120"/>
+                <a:latin typeface="Times New Roman" pitchFamily="34" charset="0"/>
+                <a:ea typeface="Times New Roman" pitchFamily="34" charset="-122"/>
+                <a:cs typeface="Times New Roman" pitchFamily="34" charset="-120"/>
                 <a:hlinkClick r:id="rId1" invalidUrl="" action="" tgtFrame="" tooltip="" history="1" highlightClick="0" endSnd="0">
                   <a:extLst>
                     <a:ext uri="{A12FA001-AC4F-418D-AE19-62706E023703}">
@@ -12897,16 +12897,16 @@
                           <a:solidFill>
                             <a:srgbClr val="000000"/>
                           </a:solidFill>
-                          <a:latin typeface="Arial" pitchFamily="34" charset="0"/>
-                          <a:ea typeface="Arial" pitchFamily="34" charset="-122"/>
-                          <a:cs typeface="Arial" pitchFamily="34" charset="-120"/>
+                          <a:latin typeface="Times New Roman" pitchFamily="34" charset="0"/>
+                          <a:ea typeface="Times New Roman" pitchFamily="34" charset="-122"/>
+                          <a:cs typeface="Times New Roman" pitchFamily="34" charset="-120"/>
                         </a:rPr>
                         <a:t>representation</a:t>
                       </a:r>
                       <a:endParaRPr lang="en-US" sz="800" dirty="0">
-                        <a:latin typeface="Arial" charset="0"/>
-                        <a:ea typeface="Arial" charset="0"/>
-                        <a:cs typeface="Arial" charset="0"/>
+                        <a:latin typeface="Times New Roman" charset="0"/>
+                        <a:ea typeface="Times New Roman" charset="0"/>
+                        <a:cs typeface="Times New Roman" charset="0"/>
                       </a:endParaRPr>
                     </a:p>
                   </a:txBody>
@@ -12965,16 +12965,16 @@
                           <a:solidFill>
                             <a:srgbClr val="000000"/>
                           </a:solidFill>
-                          <a:latin typeface="Arial" pitchFamily="34" charset="0"/>
-                          <a:ea typeface="Arial" pitchFamily="34" charset="-122"/>
-                          <a:cs typeface="Arial" pitchFamily="34" charset="-120"/>
+                          <a:latin typeface="Times New Roman" pitchFamily="34" charset="0"/>
+                          <a:ea typeface="Times New Roman" pitchFamily="34" charset="-122"/>
+                          <a:cs typeface="Times New Roman" pitchFamily="34" charset="-120"/>
                         </a:rPr>
                         <a:t>space</a:t>
                       </a:r>
                       <a:endParaRPr lang="en-US" sz="800" dirty="0">
-                        <a:latin typeface="Arial" charset="0"/>
-                        <a:ea typeface="Arial" charset="0"/>
-                        <a:cs typeface="Arial" charset="0"/>
+                        <a:latin typeface="Times New Roman" charset="0"/>
+                        <a:ea typeface="Times New Roman" charset="0"/>
+                        <a:cs typeface="Times New Roman" charset="0"/>
                       </a:endParaRPr>
                     </a:p>
                   </a:txBody>
@@ -13033,16 +13033,16 @@
                           <a:solidFill>
                             <a:srgbClr val="000000"/>
                           </a:solidFill>
-                          <a:latin typeface="Arial" pitchFamily="34" charset="0"/>
-                          <a:ea typeface="Arial" pitchFamily="34" charset="-122"/>
-                          <a:cs typeface="Arial" pitchFamily="34" charset="-120"/>
+                          <a:latin typeface="Times New Roman" pitchFamily="34" charset="0"/>
+                          <a:ea typeface="Times New Roman" pitchFamily="34" charset="-122"/>
+                          <a:cs typeface="Times New Roman" pitchFamily="34" charset="-120"/>
                         </a:rPr>
                         <a:t>samplable</a:t>
                       </a:r>
                       <a:endParaRPr lang="en-US" sz="800" dirty="0">
-                        <a:latin typeface="Arial" charset="0"/>
-                        <a:ea typeface="Arial" charset="0"/>
-                        <a:cs typeface="Arial" charset="0"/>
+                        <a:latin typeface="Times New Roman" charset="0"/>
+                        <a:ea typeface="Times New Roman" charset="0"/>
+                        <a:cs typeface="Times New Roman" charset="0"/>
                       </a:endParaRPr>
                     </a:p>
                   </a:txBody>
@@ -13101,16 +13101,16 @@
                           <a:solidFill>
                             <a:srgbClr val="000000"/>
                           </a:solidFill>
-                          <a:latin typeface="Arial" pitchFamily="34" charset="0"/>
-                          <a:ea typeface="Arial" pitchFamily="34" charset="-122"/>
-                          <a:cs typeface="Arial" pitchFamily="34" charset="-120"/>
+                          <a:latin typeface="Times New Roman" pitchFamily="34" charset="0"/>
+                          <a:ea typeface="Times New Roman" pitchFamily="34" charset="-122"/>
+                          <a:cs typeface="Times New Roman" pitchFamily="34" charset="-120"/>
                         </a:rPr>
                         <a:t>interpretable</a:t>
                       </a:r>
                       <a:endParaRPr lang="en-US" sz="800" dirty="0">
-                        <a:latin typeface="Arial" charset="0"/>
-                        <a:ea typeface="Arial" charset="0"/>
-                        <a:cs typeface="Arial" charset="0"/>
+                        <a:latin typeface="Times New Roman" charset="0"/>
+                        <a:ea typeface="Times New Roman" charset="0"/>
+                        <a:cs typeface="Times New Roman" charset="0"/>
                       </a:endParaRPr>
                     </a:p>
                   </a:txBody>
@@ -13169,16 +13169,16 @@
                           <a:solidFill>
                             <a:srgbClr val="000000"/>
                           </a:solidFill>
-                          <a:latin typeface="Arial" pitchFamily="34" charset="0"/>
-                          <a:ea typeface="Arial" pitchFamily="34" charset="-122"/>
-                          <a:cs typeface="Arial" pitchFamily="34" charset="-120"/>
+                          <a:latin typeface="Times New Roman" pitchFamily="34" charset="0"/>
+                          <a:ea typeface="Times New Roman" pitchFamily="34" charset="-122"/>
+                          <a:cs typeface="Times New Roman" pitchFamily="34" charset="-120"/>
                         </a:rPr>
                         <a:t>examples</a:t>
                       </a:r>
                       <a:endParaRPr lang="en-US" sz="800" dirty="0">
-                        <a:latin typeface="Arial" charset="0"/>
-                        <a:ea typeface="Arial" charset="0"/>
-                        <a:cs typeface="Arial" charset="0"/>
+                        <a:latin typeface="Times New Roman" charset="0"/>
+                        <a:ea typeface="Times New Roman" charset="0"/>
+                        <a:cs typeface="Times New Roman" charset="0"/>
                       </a:endParaRPr>
                     </a:p>
                   </a:txBody>
@@ -13239,16 +13239,16 @@
                           <a:solidFill>
                             <a:srgbClr val="000000"/>
                           </a:solidFill>
-                          <a:latin typeface="Arial" pitchFamily="34" charset="0"/>
-                          <a:ea typeface="Arial" pitchFamily="34" charset="-122"/>
-                          <a:cs typeface="Arial" pitchFamily="34" charset="-120"/>
+                          <a:latin typeface="Times New Roman" pitchFamily="34" charset="0"/>
+                          <a:ea typeface="Times New Roman" pitchFamily="34" charset="-122"/>
+                          <a:cs typeface="Times New Roman" pitchFamily="34" charset="-120"/>
                         </a:rPr>
                         <a:t>Discrete language</a:t>
                       </a:r>
                       <a:endParaRPr lang="en-US" sz="800" dirty="0">
-                        <a:latin typeface="Arial" charset="0"/>
-                        <a:ea typeface="Arial" charset="0"/>
-                        <a:cs typeface="Arial" charset="0"/>
+                        <a:latin typeface="Times New Roman" charset="0"/>
+                        <a:ea typeface="Times New Roman" charset="0"/>
+                        <a:cs typeface="Times New Roman" charset="0"/>
                       </a:endParaRPr>
                     </a:p>
                   </a:txBody>
@@ -13304,16 +13304,16 @@
                           <a:solidFill>
                             <a:srgbClr val="000000"/>
                           </a:solidFill>
-                          <a:latin typeface="Arial" pitchFamily="34" charset="0"/>
-                          <a:ea typeface="Arial" pitchFamily="34" charset="-122"/>
-                          <a:cs typeface="Arial" pitchFamily="34" charset="-120"/>
+                          <a:latin typeface="Times New Roman" pitchFamily="34" charset="0"/>
+                          <a:ea typeface="Times New Roman" pitchFamily="34" charset="-122"/>
+                          <a:cs typeface="Times New Roman" pitchFamily="34" charset="-120"/>
                         </a:rPr>
                         <a:t>Native vocab</a:t>
                       </a:r>
                       <a:endParaRPr lang="en-US" sz="800" dirty="0">
-                        <a:latin typeface="Arial" charset="0"/>
-                        <a:ea typeface="Arial" charset="0"/>
-                        <a:cs typeface="Arial" charset="0"/>
+                        <a:latin typeface="Times New Roman" charset="0"/>
+                        <a:ea typeface="Times New Roman" charset="0"/>
+                        <a:cs typeface="Times New Roman" charset="0"/>
                       </a:endParaRPr>
                     </a:p>
                   </a:txBody>
@@ -13369,16 +13369,16 @@
                           <a:solidFill>
                             <a:srgbClr val="000000"/>
                           </a:solidFill>
-                          <a:latin typeface="Arial" pitchFamily="34" charset="0"/>
-                          <a:ea typeface="Arial" pitchFamily="34" charset="-122"/>
-                          <a:cs typeface="Arial" pitchFamily="34" charset="-120"/>
+                          <a:latin typeface="Times New Roman" pitchFamily="34" charset="0"/>
+                          <a:ea typeface="Times New Roman" pitchFamily="34" charset="-122"/>
+                          <a:cs typeface="Times New Roman" pitchFamily="34" charset="-120"/>
                         </a:rPr>
                         <a:t>v</a:t>
                       </a:r>
                       <a:endParaRPr lang="en-US" sz="800" dirty="0">
-                        <a:latin typeface="Arial" charset="0"/>
-                        <a:ea typeface="Arial" charset="0"/>
-                        <a:cs typeface="Arial" charset="0"/>
+                        <a:latin typeface="Times New Roman" charset="0"/>
+                        <a:ea typeface="Times New Roman" charset="0"/>
+                        <a:cs typeface="Times New Roman" charset="0"/>
                       </a:endParaRPr>
                     </a:p>
                   </a:txBody>
@@ -13434,16 +13434,16 @@
                           <a:solidFill>
                             <a:srgbClr val="000000"/>
                           </a:solidFill>
-                          <a:latin typeface="Arial" pitchFamily="34" charset="0"/>
-                          <a:ea typeface="Arial" pitchFamily="34" charset="-122"/>
-                          <a:cs typeface="Arial" pitchFamily="34" charset="-120"/>
+                          <a:latin typeface="Times New Roman" pitchFamily="34" charset="0"/>
+                          <a:ea typeface="Times New Roman" pitchFamily="34" charset="-122"/>
+                          <a:cs typeface="Times New Roman" pitchFamily="34" charset="-120"/>
                         </a:rPr>
                         <a:t>v</a:t>
                       </a:r>
                       <a:endParaRPr lang="en-US" sz="800" dirty="0">
-                        <a:latin typeface="Arial" charset="0"/>
-                        <a:ea typeface="Arial" charset="0"/>
-                        <a:cs typeface="Arial" charset="0"/>
+                        <a:latin typeface="Times New Roman" charset="0"/>
+                        <a:ea typeface="Times New Roman" charset="0"/>
+                        <a:cs typeface="Times New Roman" charset="0"/>
                       </a:endParaRPr>
                     </a:p>
                   </a:txBody>
@@ -13499,16 +13499,16 @@
                           <a:solidFill>
                             <a:srgbClr val="000000"/>
                           </a:solidFill>
-                          <a:latin typeface="Arial" pitchFamily="34" charset="0"/>
-                          <a:ea typeface="Arial" pitchFamily="34" charset="-122"/>
-                          <a:cs typeface="Arial" pitchFamily="34" charset="-120"/>
+                          <a:latin typeface="Times New Roman" pitchFamily="34" charset="0"/>
+                          <a:ea typeface="Times New Roman" pitchFamily="34" charset="-122"/>
+                          <a:cs typeface="Times New Roman" pitchFamily="34" charset="-120"/>
                         </a:rPr>
                         <a:t>C3oT, CoT-Valve, Markovian Transformers</a:t>
                       </a:r>
                       <a:endParaRPr lang="en-US" sz="800" dirty="0">
-                        <a:latin typeface="Arial" charset="0"/>
-                        <a:ea typeface="Arial" charset="0"/>
-                        <a:cs typeface="Arial" charset="0"/>
+                        <a:latin typeface="Times New Roman" charset="0"/>
+                        <a:ea typeface="Times New Roman" charset="0"/>
+                        <a:cs typeface="Times New Roman" charset="0"/>
                       </a:endParaRPr>
                     </a:p>
                   </a:txBody>
@@ -13566,16 +13566,16 @@
                           <a:solidFill>
                             <a:srgbClr val="000000"/>
                           </a:solidFill>
-                          <a:latin typeface="Arial" pitchFamily="34" charset="0"/>
-                          <a:ea typeface="Arial" pitchFamily="34" charset="-122"/>
-                          <a:cs typeface="Arial" pitchFamily="34" charset="-120"/>
+                          <a:latin typeface="Times New Roman" pitchFamily="34" charset="0"/>
+                          <a:ea typeface="Times New Roman" pitchFamily="34" charset="-122"/>
+                          <a:cs typeface="Times New Roman" pitchFamily="34" charset="-120"/>
                         </a:rPr>
                         <a:t>Continuous hidden state</a:t>
                       </a:r>
                       <a:endParaRPr lang="en-US" sz="800" dirty="0">
-                        <a:latin typeface="Arial" charset="0"/>
-                        <a:ea typeface="Arial" charset="0"/>
-                        <a:cs typeface="Arial" charset="0"/>
+                        <a:latin typeface="Times New Roman" charset="0"/>
+                        <a:ea typeface="Times New Roman" charset="0"/>
+                        <a:cs typeface="Times New Roman" charset="0"/>
                       </a:endParaRPr>
                     </a:p>
                   </a:txBody>
@@ -13631,16 +13631,16 @@
                           <a:solidFill>
                             <a:srgbClr val="000000"/>
                           </a:solidFill>
-                          <a:latin typeface="Arial" pitchFamily="34" charset="0"/>
-                          <a:ea typeface="Arial" pitchFamily="34" charset="-122"/>
-                          <a:cs typeface="Arial" pitchFamily="34" charset="-120"/>
+                          <a:latin typeface="Times New Roman" pitchFamily="34" charset="0"/>
+                          <a:ea typeface="Times New Roman" pitchFamily="34" charset="-122"/>
+                          <a:cs typeface="Times New Roman" pitchFamily="34" charset="-120"/>
                         </a:rPr>
                         <a:t>Model residual stream</a:t>
                       </a:r>
                       <a:endParaRPr lang="en-US" sz="800" dirty="0">
-                        <a:latin typeface="Arial" charset="0"/>
-                        <a:ea typeface="Arial" charset="0"/>
-                        <a:cs typeface="Arial" charset="0"/>
+                        <a:latin typeface="Times New Roman" charset="0"/>
+                        <a:ea typeface="Times New Roman" charset="0"/>
+                        <a:cs typeface="Times New Roman" charset="0"/>
                       </a:endParaRPr>
                     </a:p>
                   </a:txBody>
@@ -13696,16 +13696,16 @@
                           <a:solidFill>
                             <a:srgbClr val="000000"/>
                           </a:solidFill>
-                          <a:latin typeface="Arial" pitchFamily="34" charset="0"/>
-                          <a:ea typeface="Arial" pitchFamily="34" charset="-122"/>
-                          <a:cs typeface="Arial" pitchFamily="34" charset="-120"/>
+                          <a:latin typeface="Times New Roman" pitchFamily="34" charset="0"/>
+                          <a:ea typeface="Times New Roman" pitchFamily="34" charset="-122"/>
+                          <a:cs typeface="Times New Roman" pitchFamily="34" charset="-120"/>
                         </a:rPr>
                         <a:t>–</a:t>
                       </a:r>
                       <a:endParaRPr lang="en-US" sz="800" dirty="0">
-                        <a:latin typeface="Arial" charset="0"/>
-                        <a:ea typeface="Arial" charset="0"/>
-                        <a:cs typeface="Arial" charset="0"/>
+                        <a:latin typeface="Times New Roman" charset="0"/>
+                        <a:ea typeface="Times New Roman" charset="0"/>
+                        <a:cs typeface="Times New Roman" charset="0"/>
                       </a:endParaRPr>
                     </a:p>
                   </a:txBody>
@@ -13761,16 +13761,16 @@
                           <a:solidFill>
                             <a:srgbClr val="000000"/>
                           </a:solidFill>
-                          <a:latin typeface="Arial" pitchFamily="34" charset="0"/>
-                          <a:ea typeface="Arial" pitchFamily="34" charset="-122"/>
-                          <a:cs typeface="Arial" pitchFamily="34" charset="-120"/>
+                          <a:latin typeface="Times New Roman" pitchFamily="34" charset="0"/>
+                          <a:ea typeface="Times New Roman" pitchFamily="34" charset="-122"/>
+                          <a:cs typeface="Times New Roman" pitchFamily="34" charset="-120"/>
                         </a:rPr>
                         <a:t>v 1</a:t>
                       </a:r>
                       <a:endParaRPr lang="en-US" sz="800" dirty="0">
-                        <a:latin typeface="Arial" charset="0"/>
-                        <a:ea typeface="Arial" charset="0"/>
-                        <a:cs typeface="Arial" charset="0"/>
+                        <a:latin typeface="Times New Roman" charset="0"/>
+                        <a:ea typeface="Times New Roman" charset="0"/>
+                        <a:cs typeface="Times New Roman" charset="0"/>
                       </a:endParaRPr>
                     </a:p>
                   </a:txBody>
@@ -13826,16 +13826,16 @@
                           <a:solidFill>
                             <a:srgbClr val="000000"/>
                           </a:solidFill>
-                          <a:latin typeface="Arial" pitchFamily="34" charset="0"/>
-                          <a:ea typeface="Arial" pitchFamily="34" charset="-122"/>
-                          <a:cs typeface="Arial" pitchFamily="34" charset="-120"/>
+                          <a:latin typeface="Times New Roman" pitchFamily="34" charset="0"/>
+                          <a:ea typeface="Times New Roman" pitchFamily="34" charset="-122"/>
+                          <a:cs typeface="Times New Roman" pitchFamily="34" charset="-120"/>
                         </a:rPr>
                         <a:t>Coconut, CODI, LOTUS</a:t>
                       </a:r>
                       <a:endParaRPr lang="en-US" sz="800" dirty="0">
-                        <a:latin typeface="Arial" charset="0"/>
-                        <a:ea typeface="Arial" charset="0"/>
-                        <a:cs typeface="Arial" charset="0"/>
+                        <a:latin typeface="Times New Roman" charset="0"/>
+                        <a:ea typeface="Times New Roman" charset="0"/>
+                        <a:cs typeface="Times New Roman" charset="0"/>
                       </a:endParaRPr>
                     </a:p>
                   </a:txBody>
@@ -13893,16 +13893,16 @@
                           <a:solidFill>
                             <a:srgbClr val="000000"/>
                           </a:solidFill>
-                          <a:latin typeface="Arial" pitchFamily="34" charset="0"/>
-                          <a:ea typeface="Arial" pitchFamily="34" charset="-122"/>
-                          <a:cs typeface="Arial" pitchFamily="34" charset="-120"/>
+                          <a:latin typeface="Times New Roman" pitchFamily="34" charset="0"/>
+                          <a:ea typeface="Times New Roman" pitchFamily="34" charset="-122"/>
+                          <a:cs typeface="Times New Roman" pitchFamily="34" charset="-120"/>
                         </a:rPr>
                         <a:t>Learned latent tokens</a:t>
                       </a:r>
                       <a:endParaRPr lang="en-US" sz="800" dirty="0">
-                        <a:latin typeface="Arial" charset="0"/>
-                        <a:ea typeface="Arial" charset="0"/>
-                        <a:cs typeface="Arial" charset="0"/>
+                        <a:latin typeface="Times New Roman" charset="0"/>
+                        <a:ea typeface="Times New Roman" charset="0"/>
+                        <a:cs typeface="Times New Roman" charset="0"/>
                       </a:endParaRPr>
                     </a:p>
                   </a:txBody>
@@ -13958,16 +13958,16 @@
                           <a:solidFill>
                             <a:srgbClr val="000000"/>
                           </a:solidFill>
-                          <a:latin typeface="Arial" pitchFamily="34" charset="0"/>
-                          <a:ea typeface="Arial" pitchFamily="34" charset="-122"/>
-                          <a:cs typeface="Arial" pitchFamily="34" charset="-120"/>
+                          <a:latin typeface="Times New Roman" pitchFamily="34" charset="0"/>
+                          <a:ea typeface="Times New Roman" pitchFamily="34" charset="-122"/>
+                          <a:cs typeface="Times New Roman" pitchFamily="34" charset="-120"/>
                         </a:rPr>
                         <a:t>Auxiliary codebook</a:t>
                       </a:r>
                       <a:endParaRPr lang="en-US" sz="800" dirty="0">
-                        <a:latin typeface="Arial" charset="0"/>
-                        <a:ea typeface="Arial" charset="0"/>
-                        <a:cs typeface="Arial" charset="0"/>
+                        <a:latin typeface="Times New Roman" charset="0"/>
+                        <a:ea typeface="Times New Roman" charset="0"/>
+                        <a:cs typeface="Times New Roman" charset="0"/>
                       </a:endParaRPr>
                     </a:p>
                   </a:txBody>
@@ -14023,16 +14023,16 @@
                           <a:solidFill>
                             <a:srgbClr val="000000"/>
                           </a:solidFill>
-                          <a:latin typeface="Arial" pitchFamily="34" charset="0"/>
-                          <a:ea typeface="Arial" pitchFamily="34" charset="-122"/>
-                          <a:cs typeface="Arial" pitchFamily="34" charset="-120"/>
+                          <a:latin typeface="Times New Roman" pitchFamily="34" charset="0"/>
+                          <a:ea typeface="Times New Roman" pitchFamily="34" charset="-122"/>
+                          <a:cs typeface="Times New Roman" pitchFamily="34" charset="-120"/>
                         </a:rPr>
                         <a:t>v 2</a:t>
                       </a:r>
                       <a:endParaRPr lang="en-US" sz="800" dirty="0">
-                        <a:latin typeface="Arial" charset="0"/>
-                        <a:ea typeface="Arial" charset="0"/>
-                        <a:cs typeface="Arial" charset="0"/>
+                        <a:latin typeface="Times New Roman" charset="0"/>
+                        <a:ea typeface="Times New Roman" charset="0"/>
+                        <a:cs typeface="Times New Roman" charset="0"/>
                       </a:endParaRPr>
                     </a:p>
                   </a:txBody>
@@ -14088,16 +14088,16 @@
                           <a:solidFill>
                             <a:srgbClr val="000000"/>
                           </a:solidFill>
-                          <a:latin typeface="Arial" pitchFamily="34" charset="0"/>
-                          <a:ea typeface="Arial" pitchFamily="34" charset="-122"/>
-                          <a:cs typeface="Arial" pitchFamily="34" charset="-120"/>
+                          <a:latin typeface="Times New Roman" pitchFamily="34" charset="0"/>
+                          <a:ea typeface="Times New Roman" pitchFamily="34" charset="-122"/>
+                          <a:cs typeface="Times New Roman" pitchFamily="34" charset="-120"/>
                         </a:rPr>
                         <a:t>v 3</a:t>
                       </a:r>
                       <a:endParaRPr lang="en-US" sz="800" dirty="0">
-                        <a:latin typeface="Arial" charset="0"/>
-                        <a:ea typeface="Arial" charset="0"/>
-                        <a:cs typeface="Arial" charset="0"/>
+                        <a:latin typeface="Times New Roman" charset="0"/>
+                        <a:ea typeface="Times New Roman" charset="0"/>
+                        <a:cs typeface="Times New Roman" charset="0"/>
                       </a:endParaRPr>
                     </a:p>
                   </a:txBody>
@@ -14153,16 +14153,16 @@
                           <a:solidFill>
                             <a:srgbClr val="000000"/>
                           </a:solidFill>
-                          <a:latin typeface="Arial" pitchFamily="34" charset="0"/>
-                          <a:ea typeface="Arial" pitchFamily="34" charset="-122"/>
-                          <a:cs typeface="Arial" pitchFamily="34" charset="-120"/>
+                          <a:latin typeface="Times New Roman" pitchFamily="34" charset="0"/>
+                          <a:ea typeface="Times New Roman" pitchFamily="34" charset="-122"/>
+                          <a:cs typeface="Times New Roman" pitchFamily="34" charset="-120"/>
                         </a:rPr>
                         <a:t>Heima, CoLaR 4</a:t>
                       </a:r>
                       <a:endParaRPr lang="en-US" sz="800" dirty="0">
-                        <a:latin typeface="Arial" charset="0"/>
-                        <a:ea typeface="Arial" charset="0"/>
-                        <a:cs typeface="Arial" charset="0"/>
+                        <a:latin typeface="Times New Roman" charset="0"/>
+                        <a:ea typeface="Times New Roman" charset="0"/>
+                        <a:cs typeface="Times New Roman" charset="0"/>
                       </a:endParaRPr>
                     </a:p>
                   </a:txBody>
@@ -14220,16 +14220,16 @@
                           <a:solidFill>
                             <a:srgbClr val="000000"/>
                           </a:solidFill>
-                          <a:latin typeface="Arial" pitchFamily="34" charset="0"/>
-                          <a:ea typeface="Arial" pitchFamily="34" charset="-122"/>
-                          <a:cs typeface="Arial" pitchFamily="34" charset="-120"/>
+                          <a:latin typeface="Times New Roman" pitchFamily="34" charset="0"/>
+                          <a:ea typeface="Times New Roman" pitchFamily="34" charset="-122"/>
+                          <a:cs typeface="Times New Roman" pitchFamily="34" charset="-120"/>
                         </a:rPr>
                         <a:t>Flow / diffusion latents</a:t>
                       </a:r>
                       <a:endParaRPr lang="en-US" sz="800" dirty="0">
-                        <a:latin typeface="Arial" charset="0"/>
-                        <a:ea typeface="Arial" charset="0"/>
-                        <a:cs typeface="Arial" charset="0"/>
+                        <a:latin typeface="Times New Roman" charset="0"/>
+                        <a:ea typeface="Times New Roman" charset="0"/>
+                        <a:cs typeface="Times New Roman" charset="0"/>
                       </a:endParaRPr>
                     </a:p>
                   </a:txBody>
@@ -14285,16 +14285,16 @@
                           <a:solidFill>
                             <a:srgbClr val="000000"/>
                           </a:solidFill>
-                          <a:latin typeface="Arial" pitchFamily="34" charset="0"/>
-                          <a:ea typeface="Arial" pitchFamily="34" charset="-122"/>
-                          <a:cs typeface="Arial" pitchFamily="34" charset="-120"/>
+                          <a:latin typeface="Times New Roman" pitchFamily="34" charset="0"/>
+                          <a:ea typeface="Times New Roman" pitchFamily="34" charset="-122"/>
+                          <a:cs typeface="Times New Roman" pitchFamily="34" charset="-120"/>
                         </a:rPr>
                         <a:t>VAE latent space</a:t>
                       </a:r>
                       <a:endParaRPr lang="en-US" sz="800" dirty="0">
-                        <a:latin typeface="Arial" charset="0"/>
-                        <a:ea typeface="Arial" charset="0"/>
-                        <a:cs typeface="Arial" charset="0"/>
+                        <a:latin typeface="Times New Roman" charset="0"/>
+                        <a:ea typeface="Times New Roman" charset="0"/>
+                        <a:cs typeface="Times New Roman" charset="0"/>
                       </a:endParaRPr>
                     </a:p>
                   </a:txBody>
@@ -14350,16 +14350,16 @@
                           <a:solidFill>
                             <a:srgbClr val="000000"/>
                           </a:solidFill>
-                          <a:latin typeface="Arial" pitchFamily="34" charset="0"/>
-                          <a:ea typeface="Arial" pitchFamily="34" charset="-122"/>
-                          <a:cs typeface="Arial" pitchFamily="34" charset="-120"/>
+                          <a:latin typeface="Times New Roman" pitchFamily="34" charset="0"/>
+                          <a:ea typeface="Times New Roman" pitchFamily="34" charset="-122"/>
+                          <a:cs typeface="Times New Roman" pitchFamily="34" charset="-120"/>
                         </a:rPr>
                         <a:t>v</a:t>
                       </a:r>
                       <a:endParaRPr lang="en-US" sz="800" dirty="0">
-                        <a:latin typeface="Arial" charset="0"/>
-                        <a:ea typeface="Arial" charset="0"/>
-                        <a:cs typeface="Arial" charset="0"/>
+                        <a:latin typeface="Times New Roman" charset="0"/>
+                        <a:ea typeface="Times New Roman" charset="0"/>
+                        <a:cs typeface="Times New Roman" charset="0"/>
                       </a:endParaRPr>
                     </a:p>
                   </a:txBody>
@@ -14415,16 +14415,16 @@
                           <a:solidFill>
                             <a:srgbClr val="000000"/>
                           </a:solidFill>
-                          <a:latin typeface="Arial" pitchFamily="34" charset="0"/>
-                          <a:ea typeface="Arial" pitchFamily="34" charset="-122"/>
-                          <a:cs typeface="Arial" pitchFamily="34" charset="-120"/>
+                          <a:latin typeface="Times New Roman" pitchFamily="34" charset="0"/>
+                          <a:ea typeface="Times New Roman" pitchFamily="34" charset="-122"/>
+                          <a:cs typeface="Times New Roman" pitchFamily="34" charset="-120"/>
                         </a:rPr>
                         <a:t>–</a:t>
                       </a:r>
                       <a:endParaRPr lang="en-US" sz="800" dirty="0">
-                        <a:latin typeface="Arial" charset="0"/>
-                        <a:ea typeface="Arial" charset="0"/>
-                        <a:cs typeface="Arial" charset="0"/>
+                        <a:latin typeface="Times New Roman" charset="0"/>
+                        <a:ea typeface="Times New Roman" charset="0"/>
+                        <a:cs typeface="Times New Roman" charset="0"/>
                       </a:endParaRPr>
                     </a:p>
                   </a:txBody>
@@ -14480,16 +14480,16 @@
                           <a:solidFill>
                             <a:srgbClr val="000000"/>
                           </a:solidFill>
-                          <a:latin typeface="Arial" pitchFamily="34" charset="0"/>
-                          <a:ea typeface="Arial" pitchFamily="34" charset="-122"/>
-                          <a:cs typeface="Arial" pitchFamily="34" charset="-120"/>
+                          <a:latin typeface="Times New Roman" pitchFamily="34" charset="0"/>
+                          <a:ea typeface="Times New Roman" pitchFamily="34" charset="-122"/>
+                          <a:cs typeface="Times New Roman" pitchFamily="34" charset="-120"/>
                         </a:rPr>
                         <a:t>LaDiR, FLaRe</a:t>
                       </a:r>
                       <a:endParaRPr lang="en-US" sz="800" dirty="0">
-                        <a:latin typeface="Arial" charset="0"/>
-                        <a:ea typeface="Arial" charset="0"/>
-                        <a:cs typeface="Arial" charset="0"/>
+                        <a:latin typeface="Times New Roman" charset="0"/>
+                        <a:ea typeface="Times New Roman" charset="0"/>
+                        <a:cs typeface="Times New Roman" charset="0"/>
                       </a:endParaRPr>
                     </a:p>
                   </a:txBody>
@@ -14566,9 +14566,9 @@
                 <a:solidFill>
                   <a:srgbClr val="595959"/>
                 </a:solidFill>
-                <a:latin typeface="Arial" pitchFamily="34" charset="0"/>
-                <a:ea typeface="Arial" pitchFamily="34" charset="-122"/>
-                <a:cs typeface="Arial" pitchFamily="34" charset="-120"/>
+                <a:latin typeface="Times New Roman" pitchFamily="34" charset="0"/>
+                <a:ea typeface="Times New Roman" pitchFamily="34" charset="-122"/>
+                <a:cs typeface="Times New Roman" pitchFamily="34" charset="-120"/>
               </a:rPr>
               <a:t>1 Recoverable to text through an auxiliary decoder (VQ-VAE / VAE decoder, SAE features), not directly readable.</a:t>
             </a:r>
@@ -14583,9 +14583,9 @@
                 <a:solidFill>
                   <a:srgbClr val="595959"/>
                 </a:solidFill>
-                <a:latin typeface="Arial" pitchFamily="34" charset="0"/>
-                <a:ea typeface="Arial" pitchFamily="34" charset="-122"/>
-                <a:cs typeface="Arial" pitchFamily="34" charset="-120"/>
+                <a:latin typeface="Times New Roman" pitchFamily="34" charset="0"/>
+                <a:ea typeface="Times New Roman" pitchFamily="34" charset="-122"/>
+                <a:cs typeface="Times New Roman" pitchFamily="34" charset="-120"/>
               </a:rPr>
               <a:t>2 No native thought distribution; sampling can be bolted on afterwards.</a:t>
             </a:r>
@@ -14600,9 +14600,9 @@
                 <a:solidFill>
                   <a:srgbClr val="595959"/>
                 </a:solidFill>
-                <a:latin typeface="Arial" pitchFamily="34" charset="0"/>
-                <a:ea typeface="Arial" pitchFamily="34" charset="-122"/>
-                <a:cs typeface="Arial" pitchFamily="34" charset="-120"/>
+                <a:latin typeface="Times New Roman" pitchFamily="34" charset="0"/>
+                <a:ea typeface="Times New Roman" pitchFamily="34" charset="-122"/>
+                <a:cs typeface="Times New Roman" pitchFamily="34" charset="-120"/>
               </a:rPr>
               <a:t>3 Heima ships an explainer that partially decodes its thinking tokens.</a:t>
             </a:r>
@@ -14617,9 +14617,9 @@
                 <a:solidFill>
                   <a:srgbClr val="595959"/>
                 </a:solidFill>
-                <a:latin typeface="Arial" pitchFamily="34" charset="0"/>
-                <a:ea typeface="Arial" pitchFamily="34" charset="-122"/>
-                <a:cs typeface="Arial" pitchFamily="34" charset="-120"/>
+                <a:latin typeface="Times New Roman" pitchFamily="34" charset="0"/>
+                <a:ea typeface="Times New Roman" pitchFamily="34" charset="-122"/>
+                <a:cs typeface="Times New Roman" pitchFamily="34" charset="-120"/>
               </a:rPr>
               <a:t>4 CoLaR: latent head predicts a distribution over compressed embeddings.</a:t>
             </a:r>
@@ -14659,9 +14659,9 @@
                 <a:solidFill>
                   <a:srgbClr val="000000"/>
                 </a:solidFill>
-                <a:latin typeface="Arial"/>
-                <a:ea typeface="Arial"/>
-                <a:cs typeface="Arial"/>
+                <a:latin typeface="Times New Roman"/>
+                <a:ea typeface="Times New Roman"/>
+                <a:cs typeface="Times New Roman"/>
               </a:defRPr>
             </a:lvl1pPr>
           </a:lstStyle>
@@ -14807,9 +14807,9 @@
                 <a:solidFill>
                   <a:srgbClr val="000000"/>
                 </a:solidFill>
-                <a:latin typeface="Arial" pitchFamily="34" charset="0"/>
-                <a:ea typeface="Arial" pitchFamily="34" charset="-122"/>
-                <a:cs typeface="Arial" pitchFamily="34" charset="-120"/>
+                <a:latin typeface="Times New Roman" pitchFamily="34" charset="0"/>
+                <a:ea typeface="Times New Roman" pitchFamily="34" charset="-122"/>
+                <a:cs typeface="Times New Roman" pitchFamily="34" charset="-120"/>
               </a:rPr>
               <a:t>*1</a:t>
             </a:r>
@@ -14821,9 +14821,9 @@
                 <a:solidFill>
                   <a:srgbClr val="000000"/>
                 </a:solidFill>
-                <a:latin typeface="Arial" pitchFamily="34" charset="0"/>
-                <a:ea typeface="Arial" pitchFamily="34" charset="-122"/>
-                <a:cs typeface="Arial" pitchFamily="34" charset="-120"/>
+                <a:latin typeface="Times New Roman" pitchFamily="34" charset="0"/>
+                <a:ea typeface="Times New Roman" pitchFamily="34" charset="-122"/>
+                <a:cs typeface="Times New Roman" pitchFamily="34" charset="-120"/>
               </a:rPr>
               <a:t> </a:t>
             </a:r>
@@ -14835,9 +14835,9 @@
                 <a:solidFill>
                   <a:srgbClr val="0000EE"/>
                 </a:solidFill>
-                <a:latin typeface="Arial" pitchFamily="34" charset="0"/>
-                <a:ea typeface="Arial" pitchFamily="34" charset="-122"/>
-                <a:cs typeface="Arial" pitchFamily="34" charset="-120"/>
+                <a:latin typeface="Times New Roman" pitchFamily="34" charset="0"/>
+                <a:ea typeface="Times New Roman" pitchFamily="34" charset="-122"/>
+                <a:cs typeface="Times New Roman" pitchFamily="34" charset="-120"/>
                 <a:hlinkClick r:id="rId1" invalidUrl="" action="" tgtFrame="" tooltip="" history="1" highlightClick="0" endSnd="0">
                   <a:extLst>
                     <a:ext uri="{A12FA001-AC4F-418D-AE19-62706E023703}">
@@ -14881,9 +14881,9 @@
                 <a:solidFill>
                   <a:srgbClr val="000000"/>
                 </a:solidFill>
-                <a:latin typeface="Arial" pitchFamily="34" charset="0"/>
-                <a:ea typeface="Arial" pitchFamily="34" charset="-122"/>
-                <a:cs typeface="Arial" pitchFamily="34" charset="-120"/>
+                <a:latin typeface="Times New Roman" pitchFamily="34" charset="0"/>
+                <a:ea typeface="Times New Roman" pitchFamily="34" charset="-122"/>
+                <a:cs typeface="Times New Roman" pitchFamily="34" charset="-120"/>
               </a:rPr>
               <a:t>Share the transformer backbone between</a:t>
             </a:r>
@@ -14898,9 +14898,9 @@
                 <a:solidFill>
                   <a:srgbClr val="000000"/>
                 </a:solidFill>
-                <a:latin typeface="Arial" pitchFamily="34" charset="0"/>
-                <a:ea typeface="Arial" pitchFamily="34" charset="-122"/>
-                <a:cs typeface="Arial" pitchFamily="34" charset="-120"/>
+                <a:latin typeface="Times New Roman" pitchFamily="34" charset="0"/>
+                <a:ea typeface="Times New Roman" pitchFamily="34" charset="-122"/>
+                <a:cs typeface="Times New Roman" pitchFamily="34" charset="-120"/>
               </a:rPr>
               <a:t>- </a:t>
             </a:r>
@@ -14912,9 +14912,9 @@
                 <a:solidFill>
                   <a:srgbClr val="000000"/>
                 </a:solidFill>
-                <a:latin typeface="Arial" pitchFamily="34" charset="0"/>
-                <a:ea typeface="Arial" pitchFamily="34" charset="-122"/>
-                <a:cs typeface="Arial" pitchFamily="34" charset="-120"/>
+                <a:latin typeface="Times New Roman" pitchFamily="34" charset="0"/>
+                <a:ea typeface="Times New Roman" pitchFamily="34" charset="-122"/>
+                <a:cs typeface="Times New Roman" pitchFamily="34" charset="-120"/>
               </a:rPr>
               <a:t>autoregressive text generation</a:t>
             </a:r>
@@ -14929,9 +14929,9 @@
                 <a:solidFill>
                   <a:srgbClr val="000000"/>
                 </a:solidFill>
-                <a:latin typeface="Arial" pitchFamily="34" charset="0"/>
-                <a:ea typeface="Arial" pitchFamily="34" charset="-122"/>
-                <a:cs typeface="Arial" pitchFamily="34" charset="-120"/>
+                <a:latin typeface="Times New Roman" pitchFamily="34" charset="0"/>
+                <a:ea typeface="Times New Roman" pitchFamily="34" charset="-122"/>
+                <a:cs typeface="Times New Roman" pitchFamily="34" charset="-120"/>
               </a:rPr>
               <a:t>- </a:t>
             </a:r>
@@ -14943,9 +14943,9 @@
                 <a:solidFill>
                   <a:srgbClr val="000000"/>
                 </a:solidFill>
-                <a:latin typeface="Arial" pitchFamily="34" charset="0"/>
-                <a:ea typeface="Arial" pitchFamily="34" charset="-122"/>
-                <a:cs typeface="Arial" pitchFamily="34" charset="-120"/>
+                <a:latin typeface="Times New Roman" pitchFamily="34" charset="0"/>
+                <a:ea typeface="Times New Roman" pitchFamily="34" charset="-122"/>
+                <a:cs typeface="Times New Roman" pitchFamily="34" charset="-120"/>
               </a:rPr>
               <a:t>image generation (denoising)</a:t>
             </a:r>
@@ -14957,9 +14957,9 @@
                 <a:solidFill>
                   <a:srgbClr val="000000"/>
                 </a:solidFill>
-                <a:latin typeface="Arial" pitchFamily="34" charset="0"/>
-                <a:ea typeface="Arial" pitchFamily="34" charset="-122"/>
-                <a:cs typeface="Arial" pitchFamily="34" charset="-120"/>
+                <a:latin typeface="Times New Roman" pitchFamily="34" charset="0"/>
+                <a:ea typeface="Times New Roman" pitchFamily="34" charset="-122"/>
+                <a:cs typeface="Times New Roman" pitchFamily="34" charset="-120"/>
               </a:rPr>
               <a:t>, modality-specific layers only at the input and output</a:t>
             </a:r>
@@ -14974,9 +14974,9 @@
                 <a:solidFill>
                   <a:srgbClr val="000000"/>
                 </a:solidFill>
-                <a:latin typeface="Arial" pitchFamily="34" charset="0"/>
-                <a:ea typeface="Arial" pitchFamily="34" charset="-122"/>
-                <a:cs typeface="Arial" pitchFamily="34" charset="-120"/>
+                <a:latin typeface="Times New Roman" pitchFamily="34" charset="0"/>
+                <a:ea typeface="Times New Roman" pitchFamily="34" charset="-122"/>
+                <a:cs typeface="Times New Roman" pitchFamily="34" charset="-120"/>
               </a:rPr>
               <a:t>- Our analogue: one backbone for the answer tokens and the latent thought, a head per modality</a:t>
             </a:r>
@@ -15064,9 +15064,9 @@
                 <a:solidFill>
                   <a:srgbClr val="000000"/>
                 </a:solidFill>
-                <a:latin typeface="Arial"/>
-                <a:ea typeface="Arial"/>
-                <a:cs typeface="Arial"/>
+                <a:latin typeface="Times New Roman"/>
+                <a:ea typeface="Times New Roman"/>
+                <a:cs typeface="Times New Roman"/>
               </a:defRPr>
             </a:lvl1pPr>
           </a:lstStyle>
@@ -15212,9 +15212,9 @@
                 <a:solidFill>
                   <a:srgbClr val="000000"/>
                 </a:solidFill>
-                <a:latin typeface="Arial" pitchFamily="34" charset="0"/>
-                <a:ea typeface="Arial" pitchFamily="34" charset="-122"/>
-                <a:cs typeface="Arial" pitchFamily="34" charset="-120"/>
+                <a:latin typeface="Times New Roman" pitchFamily="34" charset="0"/>
+                <a:ea typeface="Times New Roman" pitchFamily="34" charset="-122"/>
+                <a:cs typeface="Times New Roman" pitchFamily="34" charset="-120"/>
               </a:rPr>
               <a:t>*1</a:t>
             </a:r>
@@ -15226,9 +15226,9 @@
                 <a:solidFill>
                   <a:srgbClr val="000000"/>
                 </a:solidFill>
-                <a:latin typeface="Arial" pitchFamily="34" charset="0"/>
-                <a:ea typeface="Arial" pitchFamily="34" charset="-122"/>
-                <a:cs typeface="Arial" pitchFamily="34" charset="-120"/>
+                <a:latin typeface="Times New Roman" pitchFamily="34" charset="0"/>
+                <a:ea typeface="Times New Roman" pitchFamily="34" charset="-122"/>
+                <a:cs typeface="Times New Roman" pitchFamily="34" charset="-120"/>
               </a:rPr>
               <a:t> </a:t>
             </a:r>
@@ -15240,9 +15240,9 @@
                 <a:solidFill>
                   <a:srgbClr val="0000EE"/>
                 </a:solidFill>
-                <a:latin typeface="Arial" pitchFamily="34" charset="0"/>
-                <a:ea typeface="Arial" pitchFamily="34" charset="-122"/>
-                <a:cs typeface="Arial" pitchFamily="34" charset="-120"/>
+                <a:latin typeface="Times New Roman" pitchFamily="34" charset="0"/>
+                <a:ea typeface="Times New Roman" pitchFamily="34" charset="-122"/>
+                <a:cs typeface="Times New Roman" pitchFamily="34" charset="-120"/>
                 <a:hlinkClick r:id="rId1" invalidUrl="" action="" tgtFrame="" tooltip="" history="1" highlightClick="0" endSnd="0">
                   <a:extLst>
                     <a:ext uri="{A12FA001-AC4F-418D-AE19-62706E023703}">
@@ -15466,9 +15466,9 @@
                 <a:solidFill>
                   <a:srgbClr val="000000"/>
                 </a:solidFill>
-                <a:latin typeface="Arial" pitchFamily="34" charset="0"/>
-                <a:ea typeface="Arial" pitchFamily="34" charset="-122"/>
-                <a:cs typeface="Arial" pitchFamily="34" charset="-120"/>
+                <a:latin typeface="Times New Roman" pitchFamily="34" charset="0"/>
+                <a:ea typeface="Times New Roman" pitchFamily="34" charset="-122"/>
+                <a:cs typeface="Times New Roman" pitchFamily="34" charset="-120"/>
               </a:rPr>
               <a:t>Logical consistency</a:t>
             </a:r>
@@ -15483,9 +15483,9 @@
                 <a:solidFill>
                   <a:srgbClr val="000000"/>
                 </a:solidFill>
-                <a:latin typeface="Arial" pitchFamily="34" charset="0"/>
-                <a:ea typeface="Arial" pitchFamily="34" charset="-122"/>
-                <a:cs typeface="Arial" pitchFamily="34" charset="-120"/>
+                <a:latin typeface="Times New Roman" pitchFamily="34" charset="0"/>
+                <a:ea typeface="Times New Roman" pitchFamily="34" charset="-122"/>
+                <a:cs typeface="Times New Roman" pitchFamily="34" charset="-120"/>
               </a:rPr>
               <a:t>- Currently no good idea about this part</a:t>
             </a:r>
@@ -15500,9 +15500,9 @@
                 <a:solidFill>
                   <a:srgbClr val="000000"/>
                 </a:solidFill>
-                <a:latin typeface="Arial" pitchFamily="34" charset="0"/>
-                <a:ea typeface="Arial" pitchFamily="34" charset="-122"/>
-                <a:cs typeface="Arial" pitchFamily="34" charset="-120"/>
+                <a:latin typeface="Times New Roman" pitchFamily="34" charset="0"/>
+                <a:ea typeface="Times New Roman" pitchFamily="34" charset="-122"/>
+                <a:cs typeface="Times New Roman" pitchFamily="34" charset="-120"/>
               </a:rPr>
               <a:t>- Might need another judge model; too many axes to tune</a:t>
             </a:r>
@@ -15566,9 +15566,9 @@
                 <a:solidFill>
                   <a:srgbClr val="000000"/>
                 </a:solidFill>
-                <a:latin typeface="Arial"/>
-                <a:ea typeface="Arial"/>
-                <a:cs typeface="Arial"/>
+                <a:latin typeface="Times New Roman"/>
+                <a:ea typeface="Times New Roman"/>
+                <a:cs typeface="Times New Roman"/>
               </a:defRPr>
             </a:lvl1pPr>
           </a:lstStyle>
@@ -15685,7 +15685,7 @@
         <a:font script="Tfng" typeface="Ebrima"/>
       </a:majorFont>
       <a:minorFont>
-        <a:latin typeface="Arial"/>
+        <a:latin typeface="Times New Roman"/>
         <a:ea typeface=""/>
         <a:cs typeface=""/>
         <a:font script="Jpan" typeface="游ゴシック"/>

</xml_diff>